<commit_message>
La premiere partie du présentation est terminer (ma part)
</commit_message>
<xml_diff>
--- a/pptx/presentation.pptx
+++ b/pptx/presentation.pptx
@@ -4,10 +4,16 @@
   <p:sldMasterIdLst>
     <p:sldMasterId id="2147483648" r:id="rId1"/>
   </p:sldMasterIdLst>
+  <p:notesMasterIdLst>
+    <p:notesMasterId r:id="rId8"/>
+  </p:notesMasterIdLst>
   <p:sldIdLst>
     <p:sldId id="257" r:id="rId2"/>
     <p:sldId id="256" r:id="rId3"/>
     <p:sldId id="258" r:id="rId4"/>
+    <p:sldId id="259" r:id="rId5"/>
+    <p:sldId id="260" r:id="rId6"/>
+    <p:sldId id="261" r:id="rId7"/>
   </p:sldIdLst>
   <p:sldSz cx="12192000" cy="6858000"/>
   <p:notesSz cx="6858000" cy="9144000"/>
@@ -112,6 +118,547 @@
     </p:ext>
   </p:extLst>
 </p:presentation>
+</file>
+
+<file path=ppt/notesMasters/notesMaster1.xml><?xml version="1.0" encoding="utf-8"?>
+<p:notesMaster xmlns:a="http://schemas.openxmlformats.org/drawingml/2006/main" xmlns:r="http://schemas.openxmlformats.org/officeDocument/2006/relationships" xmlns:p="http://schemas.openxmlformats.org/presentationml/2006/main">
+  <p:cSld>
+    <p:bg>
+      <p:bgRef idx="1001">
+        <a:schemeClr val="bg1"/>
+      </p:bgRef>
+    </p:bg>
+    <p:spTree>
+      <p:nvGrpSpPr>
+        <p:cNvPr id="1" name=""/>
+        <p:cNvGrpSpPr/>
+        <p:nvPr/>
+      </p:nvGrpSpPr>
+      <p:grpSpPr>
+        <a:xfrm>
+          <a:off x="0" y="0"/>
+          <a:ext cx="0" cy="0"/>
+          <a:chOff x="0" y="0"/>
+          <a:chExt cx="0" cy="0"/>
+        </a:xfrm>
+      </p:grpSpPr>
+      <p:sp>
+        <p:nvSpPr>
+          <p:cNvPr id="2" name="Espace réservé de l'en-tête 1"/>
+          <p:cNvSpPr>
+            <a:spLocks noGrp="1"/>
+          </p:cNvSpPr>
+          <p:nvPr>
+            <p:ph type="hdr" sz="quarter"/>
+          </p:nvPr>
+        </p:nvSpPr>
+        <p:spPr>
+          <a:xfrm>
+            <a:off x="0" y="0"/>
+            <a:ext cx="2971800" cy="458788"/>
+          </a:xfrm>
+          <a:prstGeom prst="rect">
+            <a:avLst/>
+          </a:prstGeom>
+        </p:spPr>
+        <p:txBody>
+          <a:bodyPr vert="horz" lIns="91440" tIns="45720" rIns="91440" bIns="45720" rtlCol="0"/>
+          <a:lstStyle>
+            <a:lvl1pPr algn="l">
+              <a:defRPr sz="1200"/>
+            </a:lvl1pPr>
+          </a:lstStyle>
+          <a:p>
+            <a:endParaRPr lang="fr-FR"/>
+          </a:p>
+        </p:txBody>
+      </p:sp>
+      <p:sp>
+        <p:nvSpPr>
+          <p:cNvPr id="3" name="Espace réservé de la date 2"/>
+          <p:cNvSpPr>
+            <a:spLocks noGrp="1"/>
+          </p:cNvSpPr>
+          <p:nvPr>
+            <p:ph type="dt" idx="1"/>
+          </p:nvPr>
+        </p:nvSpPr>
+        <p:spPr>
+          <a:xfrm>
+            <a:off x="3884613" y="0"/>
+            <a:ext cx="2971800" cy="458788"/>
+          </a:xfrm>
+          <a:prstGeom prst="rect">
+            <a:avLst/>
+          </a:prstGeom>
+        </p:spPr>
+        <p:txBody>
+          <a:bodyPr vert="horz" lIns="91440" tIns="45720" rIns="91440" bIns="45720" rtlCol="0"/>
+          <a:lstStyle>
+            <a:lvl1pPr algn="r">
+              <a:defRPr sz="1200"/>
+            </a:lvl1pPr>
+          </a:lstStyle>
+          <a:p>
+            <a:fld id="{A404731F-3821-431B-A539-6BD7AE6B6915}" type="datetimeFigureOut">
+              <a:rPr lang="fr-FR" smtClean="0"/>
+              <a:t>27/09/2026</a:t>
+            </a:fld>
+            <a:endParaRPr lang="fr-FR"/>
+          </a:p>
+        </p:txBody>
+      </p:sp>
+      <p:sp>
+        <p:nvSpPr>
+          <p:cNvPr id="4" name="Espace réservé de l'image des diapositives 3"/>
+          <p:cNvSpPr>
+            <a:spLocks noGrp="1" noRot="1" noChangeAspect="1"/>
+          </p:cNvSpPr>
+          <p:nvPr>
+            <p:ph type="sldImg" idx="2"/>
+          </p:nvPr>
+        </p:nvSpPr>
+        <p:spPr>
+          <a:xfrm>
+            <a:off x="685800" y="1143000"/>
+            <a:ext cx="5486400" cy="3086100"/>
+          </a:xfrm>
+          <a:prstGeom prst="rect">
+            <a:avLst/>
+          </a:prstGeom>
+          <a:noFill/>
+          <a:ln w="12700">
+            <a:solidFill>
+              <a:prstClr val="black"/>
+            </a:solidFill>
+          </a:ln>
+        </p:spPr>
+        <p:txBody>
+          <a:bodyPr vert="horz" lIns="91440" tIns="45720" rIns="91440" bIns="45720" rtlCol="0" anchor="ctr"/>
+          <a:lstStyle/>
+          <a:p>
+            <a:endParaRPr lang="fr-FR"/>
+          </a:p>
+        </p:txBody>
+      </p:sp>
+      <p:sp>
+        <p:nvSpPr>
+          <p:cNvPr id="5" name="Espace réservé des notes 4"/>
+          <p:cNvSpPr>
+            <a:spLocks noGrp="1"/>
+          </p:cNvSpPr>
+          <p:nvPr>
+            <p:ph type="body" sz="quarter" idx="3"/>
+          </p:nvPr>
+        </p:nvSpPr>
+        <p:spPr>
+          <a:xfrm>
+            <a:off x="685800" y="4400550"/>
+            <a:ext cx="5486400" cy="3600450"/>
+          </a:xfrm>
+          <a:prstGeom prst="rect">
+            <a:avLst/>
+          </a:prstGeom>
+        </p:spPr>
+        <p:txBody>
+          <a:bodyPr vert="horz" lIns="91440" tIns="45720" rIns="91440" bIns="45720" rtlCol="0"/>
+          <a:lstStyle/>
+          <a:p>
+            <a:pPr lvl="0"/>
+            <a:r>
+              <a:rPr lang="fr-FR"/>
+              <a:t>Cliquez pour modifier les styles du texte du masque</a:t>
+            </a:r>
+          </a:p>
+          <a:p>
+            <a:pPr lvl="1"/>
+            <a:r>
+              <a:rPr lang="fr-FR"/>
+              <a:t>Deuxième niveau</a:t>
+            </a:r>
+          </a:p>
+          <a:p>
+            <a:pPr lvl="2"/>
+            <a:r>
+              <a:rPr lang="fr-FR"/>
+              <a:t>Troisième niveau</a:t>
+            </a:r>
+          </a:p>
+          <a:p>
+            <a:pPr lvl="3"/>
+            <a:r>
+              <a:rPr lang="fr-FR"/>
+              <a:t>Quatrième niveau</a:t>
+            </a:r>
+          </a:p>
+          <a:p>
+            <a:pPr lvl="4"/>
+            <a:r>
+              <a:rPr lang="fr-FR"/>
+              <a:t>Cinquième niveau</a:t>
+            </a:r>
+          </a:p>
+        </p:txBody>
+      </p:sp>
+      <p:sp>
+        <p:nvSpPr>
+          <p:cNvPr id="6" name="Espace réservé du pied de page 5"/>
+          <p:cNvSpPr>
+            <a:spLocks noGrp="1"/>
+          </p:cNvSpPr>
+          <p:nvPr>
+            <p:ph type="ftr" sz="quarter" idx="4"/>
+          </p:nvPr>
+        </p:nvSpPr>
+        <p:spPr>
+          <a:xfrm>
+            <a:off x="0" y="8685213"/>
+            <a:ext cx="2971800" cy="458787"/>
+          </a:xfrm>
+          <a:prstGeom prst="rect">
+            <a:avLst/>
+          </a:prstGeom>
+        </p:spPr>
+        <p:txBody>
+          <a:bodyPr vert="horz" lIns="91440" tIns="45720" rIns="91440" bIns="45720" rtlCol="0" anchor="b"/>
+          <a:lstStyle>
+            <a:lvl1pPr algn="l">
+              <a:defRPr sz="1200"/>
+            </a:lvl1pPr>
+          </a:lstStyle>
+          <a:p>
+            <a:endParaRPr lang="fr-FR"/>
+          </a:p>
+        </p:txBody>
+      </p:sp>
+      <p:sp>
+        <p:nvSpPr>
+          <p:cNvPr id="7" name="Espace réservé du numéro de diapositive 6"/>
+          <p:cNvSpPr>
+            <a:spLocks noGrp="1"/>
+          </p:cNvSpPr>
+          <p:nvPr>
+            <p:ph type="sldNum" sz="quarter" idx="5"/>
+          </p:nvPr>
+        </p:nvSpPr>
+        <p:spPr>
+          <a:xfrm>
+            <a:off x="3884613" y="8685213"/>
+            <a:ext cx="2971800" cy="458787"/>
+          </a:xfrm>
+          <a:prstGeom prst="rect">
+            <a:avLst/>
+          </a:prstGeom>
+        </p:spPr>
+        <p:txBody>
+          <a:bodyPr vert="horz" lIns="91440" tIns="45720" rIns="91440" bIns="45720" rtlCol="0" anchor="b"/>
+          <a:lstStyle>
+            <a:lvl1pPr algn="r">
+              <a:defRPr sz="1200"/>
+            </a:lvl1pPr>
+          </a:lstStyle>
+          <a:p>
+            <a:fld id="{89D3F3EC-CB26-4D0C-8BFC-FED84A6526B3}" type="slidenum">
+              <a:rPr lang="fr-FR" smtClean="0"/>
+              <a:t>‹N°›</a:t>
+            </a:fld>
+            <a:endParaRPr lang="fr-FR"/>
+          </a:p>
+        </p:txBody>
+      </p:sp>
+    </p:spTree>
+    <p:extLst>
+      <p:ext uri="{BB962C8B-B14F-4D97-AF65-F5344CB8AC3E}">
+        <p14:creationId xmlns:p14="http://schemas.microsoft.com/office/powerpoint/2010/main" val="3531376121"/>
+      </p:ext>
+    </p:extLst>
+  </p:cSld>
+  <p:clrMap bg1="lt1" tx1="dk1" bg2="lt2" tx2="dk2" accent1="accent1" accent2="accent2" accent3="accent3" accent4="accent4" accent5="accent5" accent6="accent6" hlink="hlink" folHlink="folHlink"/>
+  <p:notesStyle>
+    <a:lvl1pPr marL="0" algn="l" defTabSz="914400" rtl="0" eaLnBrk="1" latinLnBrk="0" hangingPunct="1">
+      <a:defRPr sz="1200" kern="1200">
+        <a:solidFill>
+          <a:schemeClr val="tx1"/>
+        </a:solidFill>
+        <a:latin typeface="+mn-lt"/>
+        <a:ea typeface="+mn-ea"/>
+        <a:cs typeface="+mn-cs"/>
+      </a:defRPr>
+    </a:lvl1pPr>
+    <a:lvl2pPr marL="457200" algn="l" defTabSz="914400" rtl="0" eaLnBrk="1" latinLnBrk="0" hangingPunct="1">
+      <a:defRPr sz="1200" kern="1200">
+        <a:solidFill>
+          <a:schemeClr val="tx1"/>
+        </a:solidFill>
+        <a:latin typeface="+mn-lt"/>
+        <a:ea typeface="+mn-ea"/>
+        <a:cs typeface="+mn-cs"/>
+      </a:defRPr>
+    </a:lvl2pPr>
+    <a:lvl3pPr marL="914400" algn="l" defTabSz="914400" rtl="0" eaLnBrk="1" latinLnBrk="0" hangingPunct="1">
+      <a:defRPr sz="1200" kern="1200">
+        <a:solidFill>
+          <a:schemeClr val="tx1"/>
+        </a:solidFill>
+        <a:latin typeface="+mn-lt"/>
+        <a:ea typeface="+mn-ea"/>
+        <a:cs typeface="+mn-cs"/>
+      </a:defRPr>
+    </a:lvl3pPr>
+    <a:lvl4pPr marL="1371600" algn="l" defTabSz="914400" rtl="0" eaLnBrk="1" latinLnBrk="0" hangingPunct="1">
+      <a:defRPr sz="1200" kern="1200">
+        <a:solidFill>
+          <a:schemeClr val="tx1"/>
+        </a:solidFill>
+        <a:latin typeface="+mn-lt"/>
+        <a:ea typeface="+mn-ea"/>
+        <a:cs typeface="+mn-cs"/>
+      </a:defRPr>
+    </a:lvl4pPr>
+    <a:lvl5pPr marL="1828800" algn="l" defTabSz="914400" rtl="0" eaLnBrk="1" latinLnBrk="0" hangingPunct="1">
+      <a:defRPr sz="1200" kern="1200">
+        <a:solidFill>
+          <a:schemeClr val="tx1"/>
+        </a:solidFill>
+        <a:latin typeface="+mn-lt"/>
+        <a:ea typeface="+mn-ea"/>
+        <a:cs typeface="+mn-cs"/>
+      </a:defRPr>
+    </a:lvl5pPr>
+    <a:lvl6pPr marL="2286000" algn="l" defTabSz="914400" rtl="0" eaLnBrk="1" latinLnBrk="0" hangingPunct="1">
+      <a:defRPr sz="1200" kern="1200">
+        <a:solidFill>
+          <a:schemeClr val="tx1"/>
+        </a:solidFill>
+        <a:latin typeface="+mn-lt"/>
+        <a:ea typeface="+mn-ea"/>
+        <a:cs typeface="+mn-cs"/>
+      </a:defRPr>
+    </a:lvl6pPr>
+    <a:lvl7pPr marL="2743200" algn="l" defTabSz="914400" rtl="0" eaLnBrk="1" latinLnBrk="0" hangingPunct="1">
+      <a:defRPr sz="1200" kern="1200">
+        <a:solidFill>
+          <a:schemeClr val="tx1"/>
+        </a:solidFill>
+        <a:latin typeface="+mn-lt"/>
+        <a:ea typeface="+mn-ea"/>
+        <a:cs typeface="+mn-cs"/>
+      </a:defRPr>
+    </a:lvl7pPr>
+    <a:lvl8pPr marL="3200400" algn="l" defTabSz="914400" rtl="0" eaLnBrk="1" latinLnBrk="0" hangingPunct="1">
+      <a:defRPr sz="1200" kern="1200">
+        <a:solidFill>
+          <a:schemeClr val="tx1"/>
+        </a:solidFill>
+        <a:latin typeface="+mn-lt"/>
+        <a:ea typeface="+mn-ea"/>
+        <a:cs typeface="+mn-cs"/>
+      </a:defRPr>
+    </a:lvl8pPr>
+    <a:lvl9pPr marL="3657600" algn="l" defTabSz="914400" rtl="0" eaLnBrk="1" latinLnBrk="0" hangingPunct="1">
+      <a:defRPr sz="1200" kern="1200">
+        <a:solidFill>
+          <a:schemeClr val="tx1"/>
+        </a:solidFill>
+        <a:latin typeface="+mn-lt"/>
+        <a:ea typeface="+mn-ea"/>
+        <a:cs typeface="+mn-cs"/>
+      </a:defRPr>
+    </a:lvl9pPr>
+  </p:notesStyle>
+</p:notesMaster>
+</file>
+
+<file path=ppt/notesSlides/notesSlide1.xml><?xml version="1.0" encoding="utf-8"?>
+<p:notes xmlns:a="http://schemas.openxmlformats.org/drawingml/2006/main" xmlns:r="http://schemas.openxmlformats.org/officeDocument/2006/relationships" xmlns:p="http://schemas.openxmlformats.org/presentationml/2006/main">
+  <p:cSld>
+    <p:spTree>
+      <p:nvGrpSpPr>
+        <p:cNvPr id="1" name=""/>
+        <p:cNvGrpSpPr/>
+        <p:nvPr/>
+      </p:nvGrpSpPr>
+      <p:grpSpPr>
+        <a:xfrm>
+          <a:off x="0" y="0"/>
+          <a:ext cx="0" cy="0"/>
+          <a:chOff x="0" y="0"/>
+          <a:chExt cx="0" cy="0"/>
+        </a:xfrm>
+      </p:grpSpPr>
+      <p:sp>
+        <p:nvSpPr>
+          <p:cNvPr id="2" name="Espace réservé de l'image des diapositives 1"/>
+          <p:cNvSpPr>
+            <a:spLocks noGrp="1" noRot="1" noChangeAspect="1"/>
+          </p:cNvSpPr>
+          <p:nvPr>
+            <p:ph type="sldImg"/>
+          </p:nvPr>
+        </p:nvSpPr>
+        <p:spPr/>
+      </p:sp>
+      <p:sp>
+        <p:nvSpPr>
+          <p:cNvPr id="3" name="Espace réservé des notes 2"/>
+          <p:cNvSpPr>
+            <a:spLocks noGrp="1"/>
+          </p:cNvSpPr>
+          <p:nvPr>
+            <p:ph type="body" idx="1"/>
+          </p:nvPr>
+        </p:nvSpPr>
+        <p:spPr/>
+        <p:txBody>
+          <a:bodyPr/>
+          <a:lstStyle/>
+          <a:p>
+            <a:endParaRPr lang="fr-FR" dirty="0"/>
+          </a:p>
+        </p:txBody>
+      </p:sp>
+      <p:sp>
+        <p:nvSpPr>
+          <p:cNvPr id="4" name="Espace réservé du numéro de diapositive 3"/>
+          <p:cNvSpPr>
+            <a:spLocks noGrp="1"/>
+          </p:cNvSpPr>
+          <p:nvPr>
+            <p:ph type="sldNum" sz="quarter" idx="5"/>
+          </p:nvPr>
+        </p:nvSpPr>
+        <p:spPr/>
+        <p:txBody>
+          <a:bodyPr/>
+          <a:lstStyle/>
+          <a:p>
+            <a:fld id="{89D3F3EC-CB26-4D0C-8BFC-FED84A6526B3}" type="slidenum">
+              <a:rPr lang="fr-FR" smtClean="0"/>
+              <a:t>4</a:t>
+            </a:fld>
+            <a:endParaRPr lang="fr-FR"/>
+          </a:p>
+        </p:txBody>
+      </p:sp>
+    </p:spTree>
+    <p:extLst>
+      <p:ext uri="{BB962C8B-B14F-4D97-AF65-F5344CB8AC3E}">
+        <p14:creationId xmlns:p14="http://schemas.microsoft.com/office/powerpoint/2010/main" val="2309625756"/>
+      </p:ext>
+    </p:extLst>
+  </p:cSld>
+  <p:clrMapOvr>
+    <a:masterClrMapping/>
+  </p:clrMapOvr>
+</p:notes>
+</file>
+
+<file path=ppt/notesSlides/notesSlide2.xml><?xml version="1.0" encoding="utf-8"?>
+<p:notes xmlns:a="http://schemas.openxmlformats.org/drawingml/2006/main" xmlns:r="http://schemas.openxmlformats.org/officeDocument/2006/relationships" xmlns:p="http://schemas.openxmlformats.org/presentationml/2006/main">
+  <p:cSld>
+    <p:spTree>
+      <p:nvGrpSpPr>
+        <p:cNvPr id="1" name="">
+          <a:extLst>
+            <a:ext uri="{FF2B5EF4-FFF2-40B4-BE49-F238E27FC236}">
+              <a16:creationId xmlns:a16="http://schemas.microsoft.com/office/drawing/2014/main" id="{626DDACA-E00B-33AC-7E7B-CE41118AF32E}"/>
+            </a:ext>
+          </a:extLst>
+        </p:cNvPr>
+        <p:cNvGrpSpPr/>
+        <p:nvPr/>
+      </p:nvGrpSpPr>
+      <p:grpSpPr>
+        <a:xfrm>
+          <a:off x="0" y="0"/>
+          <a:ext cx="0" cy="0"/>
+          <a:chOff x="0" y="0"/>
+          <a:chExt cx="0" cy="0"/>
+        </a:xfrm>
+      </p:grpSpPr>
+      <p:sp>
+        <p:nvSpPr>
+          <p:cNvPr id="2" name="Espace réservé de l'image des diapositives 1">
+            <a:extLst>
+              <a:ext uri="{FF2B5EF4-FFF2-40B4-BE49-F238E27FC236}">
+                <a16:creationId xmlns:a16="http://schemas.microsoft.com/office/drawing/2014/main" id="{48F2740C-CED5-5AC1-33A4-4A668099F7D5}"/>
+              </a:ext>
+            </a:extLst>
+          </p:cNvPr>
+          <p:cNvSpPr>
+            <a:spLocks noGrp="1" noRot="1" noChangeAspect="1"/>
+          </p:cNvSpPr>
+          <p:nvPr>
+            <p:ph type="sldImg"/>
+          </p:nvPr>
+        </p:nvSpPr>
+        <p:spPr/>
+      </p:sp>
+      <p:sp>
+        <p:nvSpPr>
+          <p:cNvPr id="3" name="Espace réservé des notes 2">
+            <a:extLst>
+              <a:ext uri="{FF2B5EF4-FFF2-40B4-BE49-F238E27FC236}">
+                <a16:creationId xmlns:a16="http://schemas.microsoft.com/office/drawing/2014/main" id="{812EC472-460B-FAE1-31BA-98873560121E}"/>
+              </a:ext>
+            </a:extLst>
+          </p:cNvPr>
+          <p:cNvSpPr>
+            <a:spLocks noGrp="1"/>
+          </p:cNvSpPr>
+          <p:nvPr>
+            <p:ph type="body" idx="1"/>
+          </p:nvPr>
+        </p:nvSpPr>
+        <p:spPr/>
+        <p:txBody>
+          <a:bodyPr/>
+          <a:lstStyle/>
+          <a:p>
+            <a:endParaRPr lang="fr-FR" dirty="0"/>
+          </a:p>
+        </p:txBody>
+      </p:sp>
+      <p:sp>
+        <p:nvSpPr>
+          <p:cNvPr id="4" name="Espace réservé du numéro de diapositive 3">
+            <a:extLst>
+              <a:ext uri="{FF2B5EF4-FFF2-40B4-BE49-F238E27FC236}">
+                <a16:creationId xmlns:a16="http://schemas.microsoft.com/office/drawing/2014/main" id="{1E8511B3-46DC-B04E-C7F8-33E524A3A992}"/>
+              </a:ext>
+            </a:extLst>
+          </p:cNvPr>
+          <p:cNvSpPr>
+            <a:spLocks noGrp="1"/>
+          </p:cNvSpPr>
+          <p:nvPr>
+            <p:ph type="sldNum" sz="quarter" idx="5"/>
+          </p:nvPr>
+        </p:nvSpPr>
+        <p:spPr/>
+        <p:txBody>
+          <a:bodyPr/>
+          <a:lstStyle/>
+          <a:p>
+            <a:fld id="{89D3F3EC-CB26-4D0C-8BFC-FED84A6526B3}" type="slidenum">
+              <a:rPr lang="fr-FR" smtClean="0"/>
+              <a:t>5</a:t>
+            </a:fld>
+            <a:endParaRPr lang="fr-FR"/>
+          </a:p>
+        </p:txBody>
+      </p:sp>
+    </p:spTree>
+    <p:extLst>
+      <p:ext uri="{BB962C8B-B14F-4D97-AF65-F5344CB8AC3E}">
+        <p14:creationId xmlns:p14="http://schemas.microsoft.com/office/powerpoint/2010/main" val="1600511551"/>
+      </p:ext>
+    </p:extLst>
+  </p:cSld>
+  <p:clrMapOvr>
+    <a:masterClrMapping/>
+  </p:clrMapOvr>
+</p:notes>
 </file>
 
 <file path=ppt/slideLayouts/slideLayout1.xml><?xml version="1.0" encoding="utf-8"?>
@@ -3578,153 +4125,6 @@
           <a:chExt cx="0" cy="0"/>
         </a:xfrm>
       </p:grpSpPr>
-      <mc:AlternateContent xmlns:mc="http://schemas.openxmlformats.org/markup-compatibility/2006">
-        <mc:Choice xmlns:a14="http://schemas.microsoft.com/office/drawing/2010/main" Requires="a14">
-          <p:sp>
-            <p:nvSpPr>
-              <p:cNvPr id="2" name="ZoneTexte 1">
-                <a:extLst>
-                  <a:ext uri="{FF2B5EF4-FFF2-40B4-BE49-F238E27FC236}">
-                    <a16:creationId xmlns:a16="http://schemas.microsoft.com/office/drawing/2014/main" id="{5491276A-B02F-89C0-B945-17BAFABCF282}"/>
-                  </a:ext>
-                </a:extLst>
-              </p:cNvPr>
-              <p:cNvSpPr txBox="1"/>
-              <p:nvPr/>
-            </p:nvSpPr>
-            <p:spPr>
-              <a:xfrm>
-                <a:off x="6487886" y="6009434"/>
-                <a:ext cx="819007" cy="848566"/>
-              </a:xfrm>
-              <a:prstGeom prst="rect">
-                <a:avLst/>
-              </a:prstGeom>
-              <a:noFill/>
-            </p:spPr>
-            <p:txBody>
-              <a:bodyPr wrap="none" rtlCol="0">
-                <a:spAutoFit/>
-              </a:bodyPr>
-              <a:lstStyle/>
-              <a:p>
-                <a14:m>
-                  <m:oMathPara xmlns:m="http://schemas.openxmlformats.org/officeDocument/2006/math">
-                    <m:oMath>
-                      <m:nary>
-                        <m:naryPr>
-                          <m:chr m:val="∑"/>
-                          <m:limLoc m:val="undOvr"/>
-                          <m:grow m:val="on"/>
-                          <m:ctrlPr>
-                            <a:rPr lang="fr-FR" i="1" dirty="0">
-                              <a:latin typeface="Cambria Math" panose="02040503050406030204" pitchFamily="18" charset="0"/>
-                            </a:rPr>
-                          </m:ctrlPr>
-                        </m:naryPr>
-                        <m:sub>
-                          <m:r>
-                            <a:rPr lang="fr-FR" i="1" dirty="0">
-                              <a:latin typeface="Cambria Math" panose="02040503050406030204" pitchFamily="18" charset="0"/>
-                            </a:rPr>
-                            <m:t>𝑖</m:t>
-                          </m:r>
-                          <m:r>
-                            <a:rPr lang="fr-FR" dirty="0">
-                              <a:latin typeface="Cambria Math" panose="02040503050406030204" pitchFamily="18" charset="0"/>
-                            </a:rPr>
-                            <m:t>=1</m:t>
-                          </m:r>
-                        </m:sub>
-                        <m:sup>
-                          <m:r>
-                            <a:rPr lang="fr-FR" i="1" dirty="0">
-                              <a:latin typeface="Cambria Math" panose="02040503050406030204" pitchFamily="18" charset="0"/>
-                            </a:rPr>
-                            <m:t>𝑛</m:t>
-                          </m:r>
-                        </m:sup>
-                        <m:e>
-                          <m:sSup>
-                            <m:sSupPr>
-                              <m:ctrlPr>
-                                <a:rPr lang="fr-FR" i="1" dirty="0">
-                                  <a:latin typeface="Cambria Math" panose="02040503050406030204" pitchFamily="18" charset="0"/>
-                                </a:rPr>
-                              </m:ctrlPr>
-                            </m:sSupPr>
-                            <m:e>
-                              <m:r>
-                                <a:rPr lang="fr-FR" i="1" dirty="0">
-                                  <a:latin typeface="Cambria Math" panose="02040503050406030204" pitchFamily="18" charset="0"/>
-                                </a:rPr>
-                                <m:t>𝑥</m:t>
-                              </m:r>
-                            </m:e>
-                            <m:sup>
-                              <m:r>
-                                <a:rPr lang="fr-FR" dirty="0">
-                                  <a:latin typeface="Cambria Math" panose="02040503050406030204" pitchFamily="18" charset="0"/>
-                                </a:rPr>
-                                <m:t>2</m:t>
-                              </m:r>
-                            </m:sup>
-                          </m:sSup>
-                        </m:e>
-                      </m:nary>
-                    </m:oMath>
-                  </m:oMathPara>
-                </a14:m>
-                <a:endParaRPr lang="fr-FR" dirty="0"/>
-              </a:p>
-            </p:txBody>
-          </p:sp>
-        </mc:Choice>
-        <mc:Fallback>
-          <p:sp>
-            <p:nvSpPr>
-              <p:cNvPr id="2" name="ZoneTexte 1">
-                <a:extLst>
-                  <a:ext uri="{FF2B5EF4-FFF2-40B4-BE49-F238E27FC236}">
-                    <a16:creationId xmlns:a16="http://schemas.microsoft.com/office/drawing/2014/main" id="{5491276A-B02F-89C0-B945-17BAFABCF282}"/>
-                  </a:ext>
-                </a:extLst>
-              </p:cNvPr>
-              <p:cNvSpPr txBox="1">
-                <a:spLocks noRot="1" noChangeAspect="1" noMove="1" noResize="1" noEditPoints="1" noAdjustHandles="1" noChangeArrowheads="1" noChangeShapeType="1" noTextEdit="1"/>
-              </p:cNvSpPr>
-              <p:nvPr/>
-            </p:nvSpPr>
-            <p:spPr>
-              <a:xfrm>
-                <a:off x="6487886" y="6009434"/>
-                <a:ext cx="819007" cy="848566"/>
-              </a:xfrm>
-              <a:prstGeom prst="rect">
-                <a:avLst/>
-              </a:prstGeom>
-              <a:blipFill>
-                <a:blip r:embed="rId2"/>
-                <a:stretch>
-                  <a:fillRect/>
-                </a:stretch>
-              </a:blipFill>
-            </p:spPr>
-            <p:txBody>
-              <a:bodyPr/>
-              <a:lstStyle/>
-              <a:p>
-                <a:r>
-                  <a:rPr lang="fr-FR">
-                    <a:noFill/>
-                  </a:rPr>
-                  <a:t> </a:t>
-                </a:r>
-              </a:p>
-            </p:txBody>
-          </p:sp>
-        </mc:Fallback>
-      </mc:AlternateContent>
       <p:sp>
         <p:nvSpPr>
           <p:cNvPr id="3" name="Rectangle 2">
@@ -5192,7 +5592,7 @@
               </a:lnSpc>
             </a:pPr>
             <a:r>
-              <a:rPr lang="en-US" sz="2000" dirty="0" err="1">
+              <a:rPr lang="en-US" sz="2000" b="1" dirty="0" err="1">
                 <a:solidFill>
                   <a:schemeClr val="tx1"/>
                 </a:solidFill>
@@ -5203,6 +5603,39 @@
               <a:t>Agréger</a:t>
             </a:r>
             <a:r>
+              <a:rPr lang="en-US" sz="2000" b="1" dirty="0">
+                <a:solidFill>
+                  <a:schemeClr val="tx1"/>
+                </a:solidFill>
+                <a:latin typeface="Calibri" pitchFamily="34" charset="0"/>
+                <a:ea typeface="Calibri" pitchFamily="34" charset="-122"/>
+                <a:cs typeface="Calibri" pitchFamily="34" charset="-120"/>
+              </a:rPr>
+              <a:t> </a:t>
+            </a:r>
+            <a:r>
+              <a:rPr lang="en-US" sz="2000" b="1" dirty="0" err="1">
+                <a:solidFill>
+                  <a:schemeClr val="tx1"/>
+                </a:solidFill>
+                <a:latin typeface="Calibri" pitchFamily="34" charset="0"/>
+                <a:ea typeface="Calibri" pitchFamily="34" charset="-122"/>
+                <a:cs typeface="Calibri" pitchFamily="34" charset="-120"/>
+              </a:rPr>
+              <a:t>d’abord</a:t>
+            </a:r>
+            <a:r>
+              <a:rPr lang="en-US" sz="2000" b="1" dirty="0">
+                <a:solidFill>
+                  <a:schemeClr val="tx1"/>
+                </a:solidFill>
+                <a:latin typeface="Calibri" pitchFamily="34" charset="0"/>
+                <a:ea typeface="Calibri" pitchFamily="34" charset="-122"/>
+                <a:cs typeface="Calibri" pitchFamily="34" charset="-120"/>
+              </a:rPr>
+              <a:t> </a:t>
+            </a:r>
+            <a:r>
               <a:rPr lang="en-US" sz="2000" dirty="0">
                 <a:solidFill>
                   <a:schemeClr val="tx1"/>
@@ -5211,10 +5644,10 @@
                 <a:ea typeface="Calibri" pitchFamily="34" charset="-122"/>
                 <a:cs typeface="Calibri" pitchFamily="34" charset="-120"/>
               </a:rPr>
-              <a:t> </a:t>
-            </a:r>
-            <a:r>
-              <a:rPr lang="en-US" sz="2000" dirty="0" err="1">
+              <a:t>–&gt;  </a:t>
+            </a:r>
+            <a:r>
+              <a:rPr lang="en-US" sz="2000" b="1" dirty="0" err="1">
                 <a:solidFill>
                   <a:schemeClr val="tx1"/>
                 </a:solidFill>
@@ -5222,7 +5655,40 @@
                 <a:ea typeface="Calibri" pitchFamily="34" charset="-122"/>
                 <a:cs typeface="Calibri" pitchFamily="34" charset="-120"/>
               </a:rPr>
-              <a:t>d’abord</a:t>
+              <a:t>Puis</a:t>
+            </a:r>
+            <a:r>
+              <a:rPr lang="en-US" sz="2000" b="1" dirty="0">
+                <a:solidFill>
+                  <a:schemeClr val="tx1"/>
+                </a:solidFill>
+                <a:latin typeface="Calibri" pitchFamily="34" charset="0"/>
+                <a:ea typeface="Calibri" pitchFamily="34" charset="-122"/>
+                <a:cs typeface="Calibri" pitchFamily="34" charset="-120"/>
+              </a:rPr>
+              <a:t> </a:t>
+            </a:r>
+            <a:r>
+              <a:rPr lang="en-US" sz="2000" b="1" dirty="0" err="1">
+                <a:solidFill>
+                  <a:schemeClr val="tx1"/>
+                </a:solidFill>
+                <a:latin typeface="Calibri" pitchFamily="34" charset="0"/>
+                <a:ea typeface="Calibri" pitchFamily="34" charset="-122"/>
+                <a:cs typeface="Calibri" pitchFamily="34" charset="-120"/>
+              </a:rPr>
+              <a:t>mesurer</a:t>
+            </a:r>
+            <a:r>
+              <a:rPr lang="en-US" sz="2000" b="1" dirty="0">
+                <a:solidFill>
+                  <a:schemeClr val="tx1"/>
+                </a:solidFill>
+                <a:latin typeface="Calibri" pitchFamily="34" charset="0"/>
+                <a:ea typeface="Calibri" pitchFamily="34" charset="-122"/>
+                <a:cs typeface="Calibri" pitchFamily="34" charset="-120"/>
+              </a:rPr>
+              <a:t> le risque</a:t>
             </a:r>
             <a:r>
               <a:rPr lang="en-US" sz="2000" dirty="0">
@@ -5233,24 +5699,1098 @@
                 <a:ea typeface="Calibri" pitchFamily="34" charset="-122"/>
                 <a:cs typeface="Calibri" pitchFamily="34" charset="-120"/>
               </a:rPr>
-              <a:t> – </a:t>
-            </a:r>
-            <a:r>
-              <a:rPr lang="en-US" sz="2000" dirty="0" err="1">
-                <a:solidFill>
-                  <a:schemeClr val="tx1"/>
-                </a:solidFill>
+              <a:t>.</a:t>
+            </a:r>
+            <a:endParaRPr lang="en-US" sz="2000" dirty="0">
+              <a:solidFill>
+                <a:schemeClr val="tx1"/>
+              </a:solidFill>
+            </a:endParaRPr>
+          </a:p>
+        </p:txBody>
+      </p:sp>
+    </p:spTree>
+    <p:extLst>
+      <p:ext uri="{BB962C8B-B14F-4D97-AF65-F5344CB8AC3E}">
+        <p14:creationId xmlns:p14="http://schemas.microsoft.com/office/powerpoint/2010/main" val="2024187343"/>
+      </p:ext>
+    </p:extLst>
+  </p:cSld>
+  <p:clrMapOvr>
+    <a:masterClrMapping/>
+  </p:clrMapOvr>
+</p:sld>
+</file>
+
+<file path=ppt/slides/slide4.xml><?xml version="1.0" encoding="utf-8"?>
+<p:sld xmlns:a="http://schemas.openxmlformats.org/drawingml/2006/main" xmlns:r="http://schemas.openxmlformats.org/officeDocument/2006/relationships" xmlns:p="http://schemas.openxmlformats.org/presentationml/2006/main">
+  <p:cSld>
+    <p:spTree>
+      <p:nvGrpSpPr>
+        <p:cNvPr id="1" name="">
+          <a:extLst>
+            <a:ext uri="{FF2B5EF4-FFF2-40B4-BE49-F238E27FC236}">
+              <a16:creationId xmlns:a16="http://schemas.microsoft.com/office/drawing/2014/main" id="{613C4AD1-EED4-A8A8-4A53-E76CF213F97A}"/>
+            </a:ext>
+          </a:extLst>
+        </p:cNvPr>
+        <p:cNvGrpSpPr/>
+        <p:nvPr/>
+      </p:nvGrpSpPr>
+      <p:grpSpPr>
+        <a:xfrm>
+          <a:off x="0" y="0"/>
+          <a:ext cx="0" cy="0"/>
+          <a:chOff x="0" y="0"/>
+          <a:chExt cx="0" cy="0"/>
+        </a:xfrm>
+      </p:grpSpPr>
+      <p:sp>
+        <p:nvSpPr>
+          <p:cNvPr id="3" name="Rectangle 2">
+            <a:extLst>
+              <a:ext uri="{FF2B5EF4-FFF2-40B4-BE49-F238E27FC236}">
+                <a16:creationId xmlns:a16="http://schemas.microsoft.com/office/drawing/2014/main" id="{B283BAFA-FBC1-E48D-6F24-82C88BBB20CA}"/>
+              </a:ext>
+            </a:extLst>
+          </p:cNvPr>
+          <p:cNvSpPr/>
+          <p:nvPr/>
+        </p:nvSpPr>
+        <p:spPr>
+          <a:xfrm>
+            <a:off x="0" y="0"/>
+            <a:ext cx="12192000" cy="708091"/>
+          </a:xfrm>
+          <a:prstGeom prst="rect">
+            <a:avLst/>
+          </a:prstGeom>
+        </p:spPr>
+        <p:style>
+          <a:lnRef idx="2">
+            <a:schemeClr val="accent1">
+              <a:shade val="15000"/>
+            </a:schemeClr>
+          </a:lnRef>
+          <a:fillRef idx="1">
+            <a:schemeClr val="accent1"/>
+          </a:fillRef>
+          <a:effectRef idx="0">
+            <a:schemeClr val="accent1"/>
+          </a:effectRef>
+          <a:fontRef idx="minor">
+            <a:schemeClr val="lt1"/>
+          </a:fontRef>
+        </p:style>
+        <p:txBody>
+          <a:bodyPr rtlCol="0" anchor="ctr"/>
+          <a:lstStyle/>
+          <a:p>
+            <a:r>
+              <a:rPr lang="fr-FR" sz="2800" dirty="0"/>
+              <a:t>MESURE DE RISQUE SPATIAL</a:t>
+            </a:r>
+          </a:p>
+        </p:txBody>
+      </p:sp>
+      <mc:AlternateContent xmlns:mc="http://schemas.openxmlformats.org/markup-compatibility/2006">
+        <mc:Choice xmlns:a14="http://schemas.microsoft.com/office/drawing/2010/main" Requires="a14">
+          <p:sp>
+            <p:nvSpPr>
+              <p:cNvPr id="7" name="Rectangle 6">
+                <a:extLst>
+                  <a:ext uri="{FF2B5EF4-FFF2-40B4-BE49-F238E27FC236}">
+                    <a16:creationId xmlns:a16="http://schemas.microsoft.com/office/drawing/2014/main" id="{C4B2840F-E2BE-E9D3-0A7D-AD9C9FACF78D}"/>
+                  </a:ext>
+                </a:extLst>
+              </p:cNvPr>
+              <p:cNvSpPr/>
+              <p:nvPr/>
+            </p:nvSpPr>
+            <p:spPr>
+              <a:xfrm>
+                <a:off x="609598" y="1448839"/>
+                <a:ext cx="10308771" cy="1469573"/>
+              </a:xfrm>
+              <a:prstGeom prst="rect">
+                <a:avLst/>
+              </a:prstGeom>
+              <a:solidFill>
+                <a:schemeClr val="bg1"/>
+              </a:solidFill>
+            </p:spPr>
+            <p:style>
+              <a:lnRef idx="2">
+                <a:schemeClr val="accent1">
+                  <a:shade val="15000"/>
+                </a:schemeClr>
+              </a:lnRef>
+              <a:fillRef idx="1">
+                <a:schemeClr val="accent1"/>
+              </a:fillRef>
+              <a:effectRef idx="0">
+                <a:schemeClr val="accent1"/>
+              </a:effectRef>
+              <a:fontRef idx="minor">
+                <a:schemeClr val="lt1"/>
+              </a:fontRef>
+            </p:style>
+            <p:txBody>
+              <a:bodyPr rtlCol="0" anchor="ctr"/>
+              <a:lstStyle/>
+              <a:p>
+                <a:pPr>
+                  <a:spcAft>
+                    <a:spcPts val="1600"/>
+                  </a:spcAft>
+                  <a:buSzPct val="100000"/>
+                </a:pPr>
+                <a:r>
+                  <a:rPr lang="fr-FR" sz="2000" dirty="0">
+                    <a:solidFill>
+                      <a:schemeClr val="tx1"/>
+                    </a:solidFill>
+                  </a:rPr>
+                  <a:t>Soit </a:t>
+                </a:r>
+                <a:r>
+                  <a:rPr lang="fr-FR" sz="2000" b="1" dirty="0">
+                    <a:solidFill>
+                      <a:schemeClr val="tx1"/>
+                    </a:solidFill>
+                  </a:rPr>
+                  <a:t>A</a:t>
+                </a:r>
+                <a:r>
+                  <a:rPr lang="fr-FR" sz="2000" dirty="0">
+                    <a:solidFill>
+                      <a:schemeClr val="tx1"/>
+                    </a:solidFill>
+                  </a:rPr>
+                  <a:t> la région, </a:t>
+                </a:r>
+                <a:r>
+                  <a:rPr lang="fr-FR" sz="2000" b="1" dirty="0">
+                    <a:solidFill>
+                      <a:schemeClr val="tx1"/>
+                    </a:solidFill>
+                  </a:rPr>
+                  <a:t>P</a:t>
+                </a:r>
+                <a:r>
+                  <a:rPr lang="fr-FR" sz="2000" dirty="0">
+                    <a:solidFill>
+                      <a:schemeClr val="tx1"/>
+                    </a:solidFill>
+                  </a:rPr>
+                  <a:t> distribution du coup </a:t>
+                </a:r>
+                <a14:m>
+                  <m:oMath xmlns:m="http://schemas.openxmlformats.org/officeDocument/2006/math">
+                    <m:sSub>
+                      <m:sSubPr>
+                        <m:ctrlPr>
+                          <a:rPr lang="en-US" sz="2000" b="1" i="1" dirty="0">
+                            <a:solidFill>
+                              <a:schemeClr val="tx1"/>
+                            </a:solidFill>
+                            <a:latin typeface="Cambria Math" panose="02040503050406030204" pitchFamily="18" charset="0"/>
+                            <a:ea typeface="Cambria Math" pitchFamily="34" charset="-122"/>
+                          </a:rPr>
+                        </m:ctrlPr>
+                      </m:sSubPr>
+                      <m:e>
+                        <m:r>
+                          <a:rPr lang="en-US" sz="2000" b="1" i="1" dirty="0">
+                            <a:solidFill>
+                              <a:schemeClr val="tx1"/>
+                            </a:solidFill>
+                            <a:latin typeface="Cambria Math" panose="02040503050406030204" pitchFamily="18" charset="0"/>
+                            <a:ea typeface="Cambria Math" pitchFamily="34" charset="-122"/>
+                          </a:rPr>
+                          <m:t>𝑪</m:t>
+                        </m:r>
+                      </m:e>
+                      <m:sub>
+                        <m:r>
+                          <a:rPr lang="en-US" sz="2000" b="1" i="1" dirty="0">
+                            <a:solidFill>
+                              <a:schemeClr val="tx1"/>
+                            </a:solidFill>
+                            <a:latin typeface="Cambria Math" panose="02040503050406030204" pitchFamily="18" charset="0"/>
+                            <a:ea typeface="Cambria Math" pitchFamily="34" charset="-122"/>
+                          </a:rPr>
+                          <m:t>𝑷</m:t>
+                        </m:r>
+                      </m:sub>
+                    </m:sSub>
+                  </m:oMath>
+                </a14:m>
+                <a:r>
+                  <a:rPr lang="fr-FR" sz="2000" dirty="0">
+                    <a:solidFill>
+                      <a:schemeClr val="tx1"/>
+                    </a:solidFill>
+                  </a:rPr>
+                  <a:t>.</a:t>
+                </a:r>
+              </a:p>
+              <a:p>
+                <a:pPr>
+                  <a:spcAft>
+                    <a:spcPts val="1600"/>
+                  </a:spcAft>
+                  <a:buSzPct val="100000"/>
+                </a:pPr>
+                <a:r>
+                  <a:rPr lang="fr-FR" sz="2000" dirty="0">
+                    <a:solidFill>
+                      <a:schemeClr val="tx1"/>
+                    </a:solidFill>
+                    <a:latin typeface="Cambria Math" pitchFamily="34" charset="0"/>
+                    <a:ea typeface="Cambria Math" pitchFamily="34" charset="-122"/>
+                    <a:cs typeface="Cambria Math" pitchFamily="34" charset="-120"/>
+                  </a:rPr>
+                  <a:t>La perte agrégée normalisée est définie par : </a:t>
+                </a:r>
+                <a:r>
+                  <a:rPr lang="en-US" sz="2000" b="1" dirty="0">
+                    <a:solidFill>
+                      <a:schemeClr val="tx1"/>
+                    </a:solidFill>
+                    <a:latin typeface="Cambria Math" pitchFamily="34" charset="0"/>
+                    <a:ea typeface="Cambria Math" pitchFamily="34" charset="-122"/>
+                    <a:cs typeface="Cambria Math" pitchFamily="34" charset="-120"/>
+                  </a:rPr>
+                  <a:t>Lₙ(A,P) =</a:t>
+                </a:r>
+                <a14:m>
+                  <m:oMath xmlns:m="http://schemas.openxmlformats.org/officeDocument/2006/math">
+                    <m:f>
+                      <m:fPr>
+                        <m:ctrlPr>
+                          <a:rPr lang="fr-FR" sz="2000" b="1" i="1" dirty="0" smtClean="0">
+                            <a:solidFill>
+                              <a:schemeClr val="tx1"/>
+                            </a:solidFill>
+                            <a:latin typeface="Cambria Math" panose="02040503050406030204" pitchFamily="18" charset="0"/>
+                            <a:ea typeface="Cambria Math" pitchFamily="34" charset="-122"/>
+                          </a:rPr>
+                        </m:ctrlPr>
+                      </m:fPr>
+                      <m:num>
+                        <m:r>
+                          <a:rPr lang="fr-FR" sz="2000" b="1" i="1" dirty="0" smtClean="0">
+                            <a:solidFill>
+                              <a:schemeClr val="tx1"/>
+                            </a:solidFill>
+                            <a:latin typeface="Cambria Math" panose="02040503050406030204" pitchFamily="18" charset="0"/>
+                            <a:ea typeface="Cambria Math" pitchFamily="34" charset="-122"/>
+                          </a:rPr>
+                          <m:t>𝟏</m:t>
+                        </m:r>
+                      </m:num>
+                      <m:den>
+                        <m:d>
+                          <m:dPr>
+                            <m:begChr m:val="|"/>
+                            <m:endChr m:val="|"/>
+                            <m:ctrlPr>
+                              <a:rPr lang="fr-FR" sz="2000" b="1" i="1" dirty="0" smtClean="0">
+                                <a:solidFill>
+                                  <a:schemeClr val="tx1"/>
+                                </a:solidFill>
+                                <a:latin typeface="Cambria Math" panose="02040503050406030204" pitchFamily="18" charset="0"/>
+                                <a:ea typeface="Cambria Math" pitchFamily="34" charset="-122"/>
+                              </a:rPr>
+                            </m:ctrlPr>
+                          </m:dPr>
+                          <m:e>
+                            <m:r>
+                              <a:rPr lang="fr-FR" sz="2000" b="1" i="1" dirty="0" smtClean="0">
+                                <a:solidFill>
+                                  <a:schemeClr val="tx1"/>
+                                </a:solidFill>
+                                <a:latin typeface="Cambria Math" panose="02040503050406030204" pitchFamily="18" charset="0"/>
+                                <a:ea typeface="Cambria Math" pitchFamily="34" charset="-122"/>
+                              </a:rPr>
+                              <m:t>𝑨</m:t>
+                            </m:r>
+                          </m:e>
+                        </m:d>
+                      </m:den>
+                    </m:f>
+                  </m:oMath>
+                </a14:m>
+                <a:r>
+                  <a:rPr lang="fr-FR" sz="2000" b="1" dirty="0">
+                    <a:solidFill>
+                      <a:schemeClr val="tx1"/>
+                    </a:solidFill>
+                    <a:latin typeface="Cambria Math" pitchFamily="34" charset="0"/>
+                    <a:ea typeface="Cambria Math" pitchFamily="34" charset="-122"/>
+                    <a:cs typeface="Cambria Math" pitchFamily="34" charset="-120"/>
+                  </a:rPr>
+                  <a:t> </a:t>
+                </a:r>
+                <a14:m>
+                  <m:oMath xmlns:m="http://schemas.openxmlformats.org/officeDocument/2006/math">
+                    <m:nary>
+                      <m:naryPr>
+                        <m:limLoc m:val="subSup"/>
+                        <m:grow m:val="on"/>
+                        <m:supHide m:val="on"/>
+                        <m:ctrlPr>
+                          <a:rPr lang="en-US" sz="2000" b="1" i="1" dirty="0" smtClean="0">
+                            <a:solidFill>
+                              <a:schemeClr val="tx1"/>
+                            </a:solidFill>
+                            <a:latin typeface="Cambria Math" panose="02040503050406030204" pitchFamily="18" charset="0"/>
+                            <a:ea typeface="Cambria Math" pitchFamily="34" charset="-122"/>
+                          </a:rPr>
+                        </m:ctrlPr>
+                      </m:naryPr>
+                      <m:sub>
+                        <m:r>
+                          <a:rPr lang="en-US" sz="2000" b="1" i="1" dirty="0" smtClean="0">
+                            <a:solidFill>
+                              <a:schemeClr val="tx1"/>
+                            </a:solidFill>
+                            <a:latin typeface="Cambria Math" panose="02040503050406030204" pitchFamily="18" charset="0"/>
+                            <a:ea typeface="Cambria Math" pitchFamily="34" charset="-122"/>
+                          </a:rPr>
+                          <m:t>𝑨</m:t>
+                        </m:r>
+                      </m:sub>
+                      <m:sup/>
+                      <m:e>
+                        <m:sSub>
+                          <m:sSubPr>
+                            <m:ctrlPr>
+                              <a:rPr lang="en-US" sz="2000" b="1" i="1" dirty="0" smtClean="0">
+                                <a:solidFill>
+                                  <a:schemeClr val="tx1"/>
+                                </a:solidFill>
+                                <a:latin typeface="Cambria Math" panose="02040503050406030204" pitchFamily="18" charset="0"/>
+                                <a:ea typeface="Cambria Math" pitchFamily="34" charset="-122"/>
+                              </a:rPr>
+                            </m:ctrlPr>
+                          </m:sSubPr>
+                          <m:e>
+                            <m:r>
+                              <a:rPr lang="en-US" sz="2000" b="1" i="1" dirty="0" smtClean="0">
+                                <a:solidFill>
+                                  <a:schemeClr val="tx1"/>
+                                </a:solidFill>
+                                <a:latin typeface="Cambria Math" panose="02040503050406030204" pitchFamily="18" charset="0"/>
+                                <a:ea typeface="Cambria Math" pitchFamily="34" charset="-122"/>
+                              </a:rPr>
+                              <m:t>𝑪</m:t>
+                            </m:r>
+                          </m:e>
+                          <m:sub>
+                            <m:r>
+                              <a:rPr lang="en-US" sz="2000" b="1" i="1" dirty="0" smtClean="0">
+                                <a:solidFill>
+                                  <a:schemeClr val="tx1"/>
+                                </a:solidFill>
+                                <a:latin typeface="Cambria Math" panose="02040503050406030204" pitchFamily="18" charset="0"/>
+                                <a:ea typeface="Cambria Math" pitchFamily="34" charset="-122"/>
+                              </a:rPr>
+                              <m:t>𝑷</m:t>
+                            </m:r>
+                          </m:sub>
+                        </m:sSub>
+                        <m:d>
+                          <m:dPr>
+                            <m:ctrlPr>
+                              <a:rPr lang="en-US" sz="2000" b="1" i="1" dirty="0" smtClean="0">
+                                <a:solidFill>
+                                  <a:schemeClr val="tx1"/>
+                                </a:solidFill>
+                                <a:latin typeface="Cambria Math" panose="02040503050406030204" pitchFamily="18" charset="0"/>
+                                <a:ea typeface="Cambria Math" pitchFamily="34" charset="-122"/>
+                              </a:rPr>
+                            </m:ctrlPr>
+                          </m:dPr>
+                          <m:e>
+                            <m:r>
+                              <a:rPr lang="en-US" sz="2000" b="1" i="1" dirty="0" smtClean="0">
+                                <a:solidFill>
+                                  <a:schemeClr val="tx1"/>
+                                </a:solidFill>
+                                <a:latin typeface="Cambria Math" panose="02040503050406030204" pitchFamily="18" charset="0"/>
+                                <a:ea typeface="Cambria Math" pitchFamily="34" charset="-122"/>
+                              </a:rPr>
+                              <m:t>𝒙</m:t>
+                            </m:r>
+                          </m:e>
+                        </m:d>
+                        <m:r>
+                          <a:rPr lang="en-US" sz="2000" b="1" i="0" dirty="0" smtClean="0">
+                            <a:solidFill>
+                              <a:schemeClr val="tx1"/>
+                            </a:solidFill>
+                            <a:latin typeface="Cambria Math" panose="02040503050406030204" pitchFamily="18" charset="0"/>
+                            <a:ea typeface="Cambria Math" pitchFamily="34" charset="-122"/>
+                          </a:rPr>
+                          <m:t>ⅆ</m:t>
+                        </m:r>
+                        <m:r>
+                          <a:rPr lang="en-US" sz="2000" b="1" i="1" dirty="0" smtClean="0">
+                            <a:solidFill>
+                              <a:schemeClr val="tx1"/>
+                            </a:solidFill>
+                            <a:latin typeface="Cambria Math" panose="02040503050406030204" pitchFamily="18" charset="0"/>
+                            <a:ea typeface="Cambria Math" pitchFamily="34" charset="-122"/>
+                          </a:rPr>
+                          <m:t>𝒙</m:t>
+                        </m:r>
+                      </m:e>
+                    </m:nary>
+                  </m:oMath>
+                </a14:m>
+                <a:endParaRPr lang="en-US" sz="2000" b="1" dirty="0">
+                  <a:solidFill>
+                    <a:srgbClr val="5B6B78"/>
+                  </a:solidFill>
+                  <a:latin typeface="Cambria Math" pitchFamily="34" charset="0"/>
+                  <a:ea typeface="Cambria Math" pitchFamily="34" charset="-122"/>
+                  <a:cs typeface="Cambria Math" pitchFamily="34" charset="-120"/>
+                </a:endParaRPr>
+              </a:p>
+            </p:txBody>
+          </p:sp>
+        </mc:Choice>
+        <mc:Fallback>
+          <p:sp>
+            <p:nvSpPr>
+              <p:cNvPr id="7" name="Rectangle 6">
+                <a:extLst>
+                  <a:ext uri="{FF2B5EF4-FFF2-40B4-BE49-F238E27FC236}">
+                    <a16:creationId xmlns:a16="http://schemas.microsoft.com/office/drawing/2014/main" id="{C4B2840F-E2BE-E9D3-0A7D-AD9C9FACF78D}"/>
+                  </a:ext>
+                </a:extLst>
+              </p:cNvPr>
+              <p:cNvSpPr>
+                <a:spLocks noRot="1" noChangeAspect="1" noMove="1" noResize="1" noEditPoints="1" noAdjustHandles="1" noChangeArrowheads="1" noChangeShapeType="1" noTextEdit="1"/>
+              </p:cNvSpPr>
+              <p:nvPr/>
+            </p:nvSpPr>
+            <p:spPr>
+              <a:xfrm>
+                <a:off x="609598" y="1448839"/>
+                <a:ext cx="10308771" cy="1469573"/>
+              </a:xfrm>
+              <a:prstGeom prst="rect">
+                <a:avLst/>
+              </a:prstGeom>
+              <a:blipFill>
+                <a:blip r:embed="rId3"/>
+                <a:stretch>
+                  <a:fillRect l="-531"/>
+                </a:stretch>
+              </a:blipFill>
+            </p:spPr>
+            <p:txBody>
+              <a:bodyPr/>
+              <a:lstStyle/>
+              <a:p>
+                <a:r>
+                  <a:rPr lang="fr-FR">
+                    <a:noFill/>
+                  </a:rPr>
+                  <a:t> </a:t>
+                </a:r>
+              </a:p>
+            </p:txBody>
+          </p:sp>
+        </mc:Fallback>
+      </mc:AlternateContent>
+      <p:sp>
+        <p:nvSpPr>
+          <p:cNvPr id="8" name="Rectangle : coins arrondis 7">
+            <a:extLst>
+              <a:ext uri="{FF2B5EF4-FFF2-40B4-BE49-F238E27FC236}">
+                <a16:creationId xmlns:a16="http://schemas.microsoft.com/office/drawing/2014/main" id="{39ADA16F-C3B6-C3D2-70CD-5A5D803F6E9C}"/>
+              </a:ext>
+            </a:extLst>
+          </p:cNvPr>
+          <p:cNvSpPr/>
+          <p:nvPr/>
+        </p:nvSpPr>
+        <p:spPr>
+          <a:xfrm>
+            <a:off x="609598" y="1068359"/>
+            <a:ext cx="10308771" cy="380480"/>
+          </a:xfrm>
+          <a:prstGeom prst="roundRect">
+            <a:avLst/>
+          </a:prstGeom>
+        </p:spPr>
+        <p:style>
+          <a:lnRef idx="2">
+            <a:schemeClr val="accent1">
+              <a:shade val="15000"/>
+            </a:schemeClr>
+          </a:lnRef>
+          <a:fillRef idx="1">
+            <a:schemeClr val="accent1"/>
+          </a:fillRef>
+          <a:effectRef idx="0">
+            <a:schemeClr val="accent1"/>
+          </a:effectRef>
+          <a:fontRef idx="minor">
+            <a:schemeClr val="lt1"/>
+          </a:fontRef>
+        </p:style>
+        <p:txBody>
+          <a:bodyPr rtlCol="0" anchor="ctr"/>
+          <a:lstStyle/>
+          <a:p>
+            <a:r>
+              <a:rPr lang="fr-FR" sz="2400" dirty="0"/>
+              <a:t>Définition 1 : Perte agrégée normalisée</a:t>
+            </a:r>
+          </a:p>
+        </p:txBody>
+      </p:sp>
+      <p:sp>
+        <p:nvSpPr>
+          <p:cNvPr id="15" name="Rectangle : coins arrondis 14">
+            <a:extLst>
+              <a:ext uri="{FF2B5EF4-FFF2-40B4-BE49-F238E27FC236}">
+                <a16:creationId xmlns:a16="http://schemas.microsoft.com/office/drawing/2014/main" id="{27BA26A1-A9D6-238E-6ED9-98BEE49E345D}"/>
+              </a:ext>
+            </a:extLst>
+          </p:cNvPr>
+          <p:cNvSpPr/>
+          <p:nvPr/>
+        </p:nvSpPr>
+        <p:spPr>
+          <a:xfrm>
+            <a:off x="609598" y="3134567"/>
+            <a:ext cx="10308771" cy="380480"/>
+          </a:xfrm>
+          <a:prstGeom prst="roundRect">
+            <a:avLst/>
+          </a:prstGeom>
+        </p:spPr>
+        <p:style>
+          <a:lnRef idx="2">
+            <a:schemeClr val="accent1">
+              <a:shade val="15000"/>
+            </a:schemeClr>
+          </a:lnRef>
+          <a:fillRef idx="1">
+            <a:schemeClr val="accent1"/>
+          </a:fillRef>
+          <a:effectRef idx="0">
+            <a:schemeClr val="accent1"/>
+          </a:effectRef>
+          <a:fontRef idx="minor">
+            <a:schemeClr val="lt1"/>
+          </a:fontRef>
+        </p:style>
+        <p:txBody>
+          <a:bodyPr rtlCol="0" anchor="ctr"/>
+          <a:lstStyle/>
+          <a:p>
+            <a:r>
+              <a:rPr lang="fr-FR" sz="2400" dirty="0"/>
+              <a:t>Définition 2 : Mesure de risque spatial</a:t>
+            </a:r>
+          </a:p>
+        </p:txBody>
+      </p:sp>
+      <mc:AlternateContent xmlns:mc="http://schemas.openxmlformats.org/markup-compatibility/2006">
+        <mc:Choice xmlns:a14="http://schemas.microsoft.com/office/drawing/2010/main" Requires="a14">
+          <p:sp>
+            <p:nvSpPr>
+              <p:cNvPr id="17" name="Rectangle 16">
+                <a:extLst>
+                  <a:ext uri="{FF2B5EF4-FFF2-40B4-BE49-F238E27FC236}">
+                    <a16:creationId xmlns:a16="http://schemas.microsoft.com/office/drawing/2014/main" id="{E284062B-A33A-5D67-1BE4-60B3DF392E8D}"/>
+                  </a:ext>
+                </a:extLst>
+              </p:cNvPr>
+              <p:cNvSpPr/>
+              <p:nvPr/>
+            </p:nvSpPr>
+            <p:spPr>
+              <a:xfrm>
+                <a:off x="609598" y="3525413"/>
+                <a:ext cx="10308771" cy="1938177"/>
+              </a:xfrm>
+              <a:prstGeom prst="rect">
+                <a:avLst/>
+              </a:prstGeom>
+              <a:solidFill>
+                <a:schemeClr val="bg1"/>
+              </a:solidFill>
+            </p:spPr>
+            <p:style>
+              <a:lnRef idx="2">
+                <a:schemeClr val="accent1">
+                  <a:shade val="15000"/>
+                </a:schemeClr>
+              </a:lnRef>
+              <a:fillRef idx="1">
+                <a:schemeClr val="accent1"/>
+              </a:fillRef>
+              <a:effectRef idx="0">
+                <a:schemeClr val="accent1"/>
+              </a:effectRef>
+              <a:fontRef idx="minor">
+                <a:schemeClr val="lt1"/>
+              </a:fontRef>
+            </p:style>
+            <p:txBody>
+              <a:bodyPr rtlCol="0" anchor="ctr"/>
+              <a:lstStyle/>
+              <a:p>
+                <a:pPr>
+                  <a:spcAft>
+                    <a:spcPts val="1600"/>
+                  </a:spcAft>
+                  <a:buSzPct val="100000"/>
+                </a:pPr>
+                <a:r>
+                  <a:rPr lang="fr-FR" sz="2000" dirty="0">
+                    <a:solidFill>
+                      <a:schemeClr val="tx1"/>
+                    </a:solidFill>
+                  </a:rPr>
+                  <a:t>Soit </a:t>
+                </a:r>
+                <a:r>
+                  <a:rPr lang="fr-FR" sz="2000" b="1" dirty="0">
+                    <a:solidFill>
+                      <a:schemeClr val="tx1"/>
+                    </a:solidFill>
+                  </a:rPr>
+                  <a:t>A</a:t>
+                </a:r>
+                <a:r>
+                  <a:rPr lang="fr-FR" sz="2000" dirty="0">
+                    <a:solidFill>
+                      <a:schemeClr val="tx1"/>
+                    </a:solidFill>
+                  </a:rPr>
+                  <a:t> la région, </a:t>
+                </a:r>
+                <a:r>
+                  <a:rPr lang="fr-FR" sz="2000" b="1" dirty="0">
+                    <a:solidFill>
+                      <a:schemeClr val="tx1"/>
+                    </a:solidFill>
+                  </a:rPr>
+                  <a:t>P</a:t>
+                </a:r>
+                <a:r>
+                  <a:rPr lang="fr-FR" sz="2000" dirty="0">
+                    <a:solidFill>
+                      <a:schemeClr val="tx1"/>
+                    </a:solidFill>
+                  </a:rPr>
+                  <a:t> distribution du coup Cp.</a:t>
+                </a:r>
+              </a:p>
+              <a:p>
+                <a:pPr>
+                  <a:spcAft>
+                    <a:spcPts val="1600"/>
+                  </a:spcAft>
+                  <a:buSzPct val="100000"/>
+                </a:pPr>
+                <a:r>
+                  <a:rPr lang="fr-FR" sz="2000" dirty="0">
+                    <a:solidFill>
+                      <a:schemeClr val="tx1"/>
+                    </a:solidFill>
+                  </a:rPr>
+                  <a:t>La mesure de risque spatial </a:t>
+                </a:r>
+                <a14:m>
+                  <m:oMath xmlns:m="http://schemas.openxmlformats.org/officeDocument/2006/math">
+                    <m:sSub>
+                      <m:sSubPr>
+                        <m:ctrlPr>
+                          <a:rPr lang="fr-FR" sz="2000" b="1" i="1" smtClean="0">
+                            <a:solidFill>
+                              <a:schemeClr val="tx1"/>
+                            </a:solidFill>
+                            <a:latin typeface="Cambria Math" panose="02040503050406030204" pitchFamily="18" charset="0"/>
+                          </a:rPr>
+                        </m:ctrlPr>
+                      </m:sSubPr>
+                      <m:e>
+                        <m:r>
+                          <a:rPr lang="fr-FR" sz="2000" b="1" i="1" smtClean="0">
+                            <a:solidFill>
+                              <a:schemeClr val="tx1"/>
+                            </a:solidFill>
+                            <a:latin typeface="Cambria Math" panose="02040503050406030204" pitchFamily="18" charset="0"/>
+                          </a:rPr>
+                          <m:t>𝑹</m:t>
+                        </m:r>
+                      </m:e>
+                      <m:sub>
+                        <m:r>
+                          <a:rPr lang="fr-FR" sz="2000" b="1" i="1" smtClean="0">
+                            <a:solidFill>
+                              <a:schemeClr val="tx1"/>
+                            </a:solidFill>
+                            <a:latin typeface="Cambria Math" panose="02040503050406030204" pitchFamily="18" charset="0"/>
+                          </a:rPr>
+                          <m:t>𝝅</m:t>
+                        </m:r>
+                      </m:sub>
+                    </m:sSub>
+                  </m:oMath>
+                </a14:m>
+                <a:r>
+                  <a:rPr lang="fr-FR" sz="2000" b="1" dirty="0">
+                    <a:solidFill>
+                      <a:schemeClr val="tx1"/>
+                    </a:solidFill>
+                  </a:rPr>
+                  <a:t> </a:t>
+                </a:r>
+                <a:r>
+                  <a:rPr lang="fr-FR" sz="2000" dirty="0">
+                    <a:solidFill>
+                      <a:schemeClr val="tx1"/>
+                    </a:solidFill>
+                  </a:rPr>
+                  <a:t>est donnée par :  </a:t>
+                </a:r>
+              </a:p>
+              <a:p>
+                <a:pPr>
+                  <a:spcAft>
+                    <a:spcPts val="1600"/>
+                  </a:spcAft>
+                  <a:buSzPct val="100000"/>
+                </a:pPr>
+                <a14:m>
+                  <m:oMathPara xmlns:m="http://schemas.openxmlformats.org/officeDocument/2006/math">
+                    <m:oMath>
+                      <m:sSub>
+                        <m:sSubPr>
+                          <m:ctrlPr>
+                            <a:rPr lang="fr-FR" sz="2000" b="1" i="1">
+                              <a:solidFill>
+                                <a:schemeClr val="tx1"/>
+                              </a:solidFill>
+                              <a:latin typeface="Cambria Math" panose="02040503050406030204" pitchFamily="18" charset="0"/>
+                            </a:rPr>
+                          </m:ctrlPr>
+                        </m:sSubPr>
+                        <m:e>
+                          <m:r>
+                            <a:rPr lang="fr-FR" sz="2000" b="1" i="1">
+                              <a:solidFill>
+                                <a:schemeClr val="tx1"/>
+                              </a:solidFill>
+                              <a:latin typeface="Cambria Math" panose="02040503050406030204" pitchFamily="18" charset="0"/>
+                            </a:rPr>
+                            <m:t>𝑹</m:t>
+                          </m:r>
+                        </m:e>
+                        <m:sub>
+                          <m:r>
+                            <a:rPr lang="fr-FR" sz="2000" b="1" i="1">
+                              <a:solidFill>
+                                <a:schemeClr val="tx1"/>
+                              </a:solidFill>
+                              <a:latin typeface="Cambria Math" panose="02040503050406030204" pitchFamily="18" charset="0"/>
+                            </a:rPr>
+                            <m:t>𝝅</m:t>
+                          </m:r>
+                        </m:sub>
+                      </m:sSub>
+                      <m:r>
+                        <a:rPr lang="fr-FR" sz="2000" b="1" i="1" smtClean="0">
+                          <a:solidFill>
+                            <a:schemeClr val="tx1"/>
+                          </a:solidFill>
+                          <a:latin typeface="Cambria Math" panose="02040503050406030204" pitchFamily="18" charset="0"/>
+                        </a:rPr>
+                        <m:t>=</m:t>
+                      </m:r>
+                      <m:r>
+                        <a:rPr lang="fr-FR" sz="2000" b="1" i="1" dirty="0" smtClean="0">
+                          <a:solidFill>
+                            <a:schemeClr val="tx1"/>
+                          </a:solidFill>
+                          <a:latin typeface="Cambria Math" panose="02040503050406030204" pitchFamily="18" charset="0"/>
+                        </a:rPr>
+                        <m:t>𝜫</m:t>
+                      </m:r>
+                      <m:d>
+                        <m:dPr>
+                          <m:ctrlPr>
+                            <a:rPr lang="fr-FR" sz="2000" b="1" i="1" dirty="0" smtClean="0">
+                              <a:solidFill>
+                                <a:schemeClr val="tx1"/>
+                              </a:solidFill>
+                              <a:latin typeface="Cambria Math" panose="02040503050406030204" pitchFamily="18" charset="0"/>
+                            </a:rPr>
+                          </m:ctrlPr>
+                        </m:dPr>
+                        <m:e>
+                          <m:sSub>
+                            <m:sSubPr>
+                              <m:ctrlPr>
+                                <a:rPr lang="fr-FR" sz="2000" b="1" i="1" dirty="0" smtClean="0">
+                                  <a:solidFill>
+                                    <a:schemeClr val="tx1"/>
+                                  </a:solidFill>
+                                  <a:latin typeface="Cambria Math" panose="02040503050406030204" pitchFamily="18" charset="0"/>
+                                </a:rPr>
+                              </m:ctrlPr>
+                            </m:sSubPr>
+                            <m:e>
+                              <m:r>
+                                <a:rPr lang="fr-FR" sz="2000" b="1" i="1" dirty="0" smtClean="0">
+                                  <a:solidFill>
+                                    <a:schemeClr val="tx1"/>
+                                  </a:solidFill>
+                                  <a:latin typeface="Cambria Math" panose="02040503050406030204" pitchFamily="18" charset="0"/>
+                                </a:rPr>
+                                <m:t>𝑳</m:t>
+                              </m:r>
+                            </m:e>
+                            <m:sub>
+                              <m:r>
+                                <a:rPr lang="fr-FR" sz="2000" b="1" i="1" dirty="0" smtClean="0">
+                                  <a:solidFill>
+                                    <a:schemeClr val="tx1"/>
+                                  </a:solidFill>
+                                  <a:latin typeface="Cambria Math" panose="02040503050406030204" pitchFamily="18" charset="0"/>
+                                </a:rPr>
+                                <m:t>𝒏</m:t>
+                              </m:r>
+                            </m:sub>
+                          </m:sSub>
+                          <m:d>
+                            <m:dPr>
+                              <m:ctrlPr>
+                                <a:rPr lang="fr-FR" sz="2000" b="1" i="1" dirty="0" smtClean="0">
+                                  <a:solidFill>
+                                    <a:schemeClr val="tx1"/>
+                                  </a:solidFill>
+                                  <a:latin typeface="Cambria Math" panose="02040503050406030204" pitchFamily="18" charset="0"/>
+                                </a:rPr>
+                              </m:ctrlPr>
+                            </m:dPr>
+                            <m:e>
+                              <m:r>
+                                <a:rPr lang="fr-FR" sz="2000" b="1" i="1" dirty="0" smtClean="0">
+                                  <a:solidFill>
+                                    <a:schemeClr val="tx1"/>
+                                  </a:solidFill>
+                                  <a:latin typeface="Cambria Math" panose="02040503050406030204" pitchFamily="18" charset="0"/>
+                                </a:rPr>
+                                <m:t>𝑨</m:t>
+                              </m:r>
+                              <m:r>
+                                <a:rPr lang="fr-FR" sz="2000" b="1" i="0" dirty="0" smtClean="0">
+                                  <a:solidFill>
+                                    <a:schemeClr val="tx1"/>
+                                  </a:solidFill>
+                                  <a:latin typeface="Cambria Math" panose="02040503050406030204" pitchFamily="18" charset="0"/>
+                                </a:rPr>
+                                <m:t>,</m:t>
+                              </m:r>
+                              <m:r>
+                                <a:rPr lang="fr-FR" sz="2000" b="1" i="1" dirty="0" smtClean="0">
+                                  <a:solidFill>
+                                    <a:schemeClr val="tx1"/>
+                                  </a:solidFill>
+                                  <a:latin typeface="Cambria Math" panose="02040503050406030204" pitchFamily="18" charset="0"/>
+                                </a:rPr>
+                                <m:t>𝑷</m:t>
+                              </m:r>
+                            </m:e>
+                          </m:d>
+                        </m:e>
+                      </m:d>
+                    </m:oMath>
+                  </m:oMathPara>
+                </a14:m>
+                <a:endParaRPr lang="fr-FR" sz="2000" b="1" dirty="0">
+                  <a:solidFill>
+                    <a:schemeClr val="tx1"/>
+                  </a:solidFill>
+                </a:endParaRPr>
+              </a:p>
+            </p:txBody>
+          </p:sp>
+        </mc:Choice>
+        <mc:Fallback>
+          <p:sp>
+            <p:nvSpPr>
+              <p:cNvPr id="17" name="Rectangle 16">
+                <a:extLst>
+                  <a:ext uri="{FF2B5EF4-FFF2-40B4-BE49-F238E27FC236}">
+                    <a16:creationId xmlns:a16="http://schemas.microsoft.com/office/drawing/2014/main" id="{E284062B-A33A-5D67-1BE4-60B3DF392E8D}"/>
+                  </a:ext>
+                </a:extLst>
+              </p:cNvPr>
+              <p:cNvSpPr>
+                <a:spLocks noRot="1" noChangeAspect="1" noMove="1" noResize="1" noEditPoints="1" noAdjustHandles="1" noChangeArrowheads="1" noChangeShapeType="1" noTextEdit="1"/>
+              </p:cNvSpPr>
+              <p:nvPr/>
+            </p:nvSpPr>
+            <p:spPr>
+              <a:xfrm>
+                <a:off x="609598" y="3525413"/>
+                <a:ext cx="10308771" cy="1938177"/>
+              </a:xfrm>
+              <a:prstGeom prst="rect">
+                <a:avLst/>
+              </a:prstGeom>
+              <a:blipFill>
+                <a:blip r:embed="rId4"/>
+                <a:stretch>
+                  <a:fillRect l="-531"/>
+                </a:stretch>
+              </a:blipFill>
+            </p:spPr>
+            <p:txBody>
+              <a:bodyPr/>
+              <a:lstStyle/>
+              <a:p>
+                <a:r>
+                  <a:rPr lang="fr-FR">
+                    <a:noFill/>
+                  </a:rPr>
+                  <a:t> </a:t>
+                </a:r>
+              </a:p>
+            </p:txBody>
+          </p:sp>
+        </mc:Fallback>
+      </mc:AlternateContent>
+      <p:sp>
+        <p:nvSpPr>
+          <p:cNvPr id="4" name="ZoneTexte 3">
+            <a:extLst>
+              <a:ext uri="{FF2B5EF4-FFF2-40B4-BE49-F238E27FC236}">
+                <a16:creationId xmlns:a16="http://schemas.microsoft.com/office/drawing/2014/main" id="{853FD590-48C0-ECB8-7686-3F7C07A77034}"/>
+              </a:ext>
+            </a:extLst>
+          </p:cNvPr>
+          <p:cNvSpPr txBox="1"/>
+          <p:nvPr/>
+        </p:nvSpPr>
+        <p:spPr>
+          <a:xfrm>
+            <a:off x="609598" y="5593698"/>
+            <a:ext cx="11573618" cy="1179810"/>
+          </a:xfrm>
+          <a:prstGeom prst="rect">
+            <a:avLst/>
+          </a:prstGeom>
+          <a:noFill/>
+        </p:spPr>
+        <p:txBody>
+          <a:bodyPr wrap="none" rtlCol="0">
+            <a:spAutoFit/>
+          </a:bodyPr>
+          <a:lstStyle/>
+          <a:p>
+            <a:pPr marL="228600" indent="-228600">
+              <a:spcAft>
+                <a:spcPts val="1000"/>
+              </a:spcAft>
+              <a:buSzPct val="100000"/>
+              <a:buChar char="•"/>
+            </a:pPr>
+            <a:r>
+              <a:rPr lang="en-US" dirty="0">
                 <a:latin typeface="Calibri" pitchFamily="34" charset="0"/>
                 <a:ea typeface="Calibri" pitchFamily="34" charset="-122"/>
                 <a:cs typeface="Calibri" pitchFamily="34" charset="-120"/>
               </a:rPr>
-              <a:t>puis</a:t>
-            </a:r>
-            <a:r>
-              <a:rPr lang="en-US" sz="2000" dirty="0">
-                <a:solidFill>
-                  <a:schemeClr val="tx1"/>
-                </a:solidFill>
+              <a:t>La </a:t>
+            </a:r>
+            <a:r>
+              <a:rPr lang="en-US" dirty="0" err="1">
+                <a:latin typeface="Calibri" pitchFamily="34" charset="0"/>
+                <a:ea typeface="Calibri" pitchFamily="34" charset="-122"/>
+                <a:cs typeface="Calibri" pitchFamily="34" charset="-120"/>
+              </a:rPr>
+              <a:t>normalisation</a:t>
+            </a:r>
+            <a:r>
+              <a:rPr lang="en-US" dirty="0">
+                <a:latin typeface="Calibri" pitchFamily="34" charset="0"/>
+                <a:ea typeface="Calibri" pitchFamily="34" charset="-122"/>
+                <a:cs typeface="Calibri" pitchFamily="34" charset="-120"/>
+              </a:rPr>
+              <a:t> par |A| </a:t>
+            </a:r>
+            <a:r>
+              <a:rPr lang="en-US" dirty="0" err="1">
+                <a:latin typeface="Calibri" pitchFamily="34" charset="0"/>
+                <a:ea typeface="Calibri" pitchFamily="34" charset="-122"/>
+                <a:cs typeface="Calibri" pitchFamily="34" charset="-120"/>
+              </a:rPr>
+              <a:t>donne</a:t>
+            </a:r>
+            <a:r>
+              <a:rPr lang="en-US" dirty="0">
+                <a:latin typeface="Calibri" pitchFamily="34" charset="0"/>
+                <a:ea typeface="Calibri" pitchFamily="34" charset="-122"/>
+                <a:cs typeface="Calibri" pitchFamily="34" charset="-120"/>
+              </a:rPr>
+              <a:t> une </a:t>
+            </a:r>
+            <a:r>
+              <a:rPr lang="en-US" dirty="0" err="1">
+                <a:latin typeface="Calibri" pitchFamily="34" charset="0"/>
+                <a:ea typeface="Calibri" pitchFamily="34" charset="-122"/>
+                <a:cs typeface="Calibri" pitchFamily="34" charset="-120"/>
+              </a:rPr>
+              <a:t>perte</a:t>
+            </a:r>
+            <a:r>
+              <a:rPr lang="en-US" dirty="0">
+                <a:latin typeface="Calibri" pitchFamily="34" charset="0"/>
+                <a:ea typeface="Calibri" pitchFamily="34" charset="-122"/>
+                <a:cs typeface="Calibri" pitchFamily="34" charset="-120"/>
+              </a:rPr>
+              <a:t> « par </a:t>
+            </a:r>
+            <a:r>
+              <a:rPr lang="en-US" dirty="0" err="1">
+                <a:latin typeface="Calibri" pitchFamily="34" charset="0"/>
+                <a:ea typeface="Calibri" pitchFamily="34" charset="-122"/>
+                <a:cs typeface="Calibri" pitchFamily="34" charset="-120"/>
+              </a:rPr>
+              <a:t>unité</a:t>
+            </a:r>
+            <a:r>
+              <a:rPr lang="en-US" dirty="0">
+                <a:latin typeface="Calibri" pitchFamily="34" charset="0"/>
+                <a:ea typeface="Calibri" pitchFamily="34" charset="-122"/>
+                <a:cs typeface="Calibri" pitchFamily="34" charset="-120"/>
+              </a:rPr>
+              <a:t> de surface » (</a:t>
+            </a:r>
+            <a:r>
+              <a:rPr lang="en-US" dirty="0" err="1">
+                <a:latin typeface="Calibri" pitchFamily="34" charset="0"/>
+                <a:ea typeface="Calibri" pitchFamily="34" charset="-122"/>
+                <a:cs typeface="Calibri" pitchFamily="34" charset="-120"/>
+              </a:rPr>
+              <a:t>interprétable</a:t>
+            </a:r>
+            <a:r>
+              <a:rPr lang="en-US" dirty="0">
                 <a:latin typeface="Calibri" pitchFamily="34" charset="0"/>
                 <a:ea typeface="Calibri" pitchFamily="34" charset="-122"/>
                 <a:cs typeface="Calibri" pitchFamily="34" charset="-120"/>
@@ -5258,28 +6798,2330 @@
               <a:t> </a:t>
             </a:r>
             <a:r>
-              <a:rPr lang="en-US" sz="2000" dirty="0" err="1">
-                <a:solidFill>
-                  <a:schemeClr val="tx1"/>
-                </a:solidFill>
+              <a:rPr lang="en-US" dirty="0" err="1">
                 <a:latin typeface="Calibri" pitchFamily="34" charset="0"/>
                 <a:ea typeface="Calibri" pitchFamily="34" charset="-122"/>
                 <a:cs typeface="Calibri" pitchFamily="34" charset="-120"/>
               </a:rPr>
-              <a:t>mesurer</a:t>
-            </a:r>
-            <a:r>
-              <a:rPr lang="en-US" sz="2000" dirty="0">
-                <a:solidFill>
-                  <a:schemeClr val="tx1"/>
-                </a:solidFill>
+              <a:t>comme</a:t>
+            </a:r>
+            <a:r>
+              <a:rPr lang="en-US" dirty="0">
                 <a:latin typeface="Calibri" pitchFamily="34" charset="0"/>
                 <a:ea typeface="Calibri" pitchFamily="34" charset="-122"/>
                 <a:cs typeface="Calibri" pitchFamily="34" charset="-120"/>
               </a:rPr>
-              <a:t> le risque.</a:t>
-            </a:r>
-            <a:endParaRPr lang="en-US" sz="2000" dirty="0">
+              <a:t> </a:t>
+            </a:r>
+            <a:r>
+              <a:rPr lang="en-US" dirty="0" err="1">
+                <a:latin typeface="Calibri" pitchFamily="34" charset="0"/>
+                <a:ea typeface="Calibri" pitchFamily="34" charset="-122"/>
+                <a:cs typeface="Calibri" pitchFamily="34" charset="-120"/>
+              </a:rPr>
+              <a:t>perte</a:t>
+            </a:r>
+            <a:r>
+              <a:rPr lang="en-US" dirty="0">
+                <a:latin typeface="Calibri" pitchFamily="34" charset="0"/>
+                <a:ea typeface="Calibri" pitchFamily="34" charset="-122"/>
+                <a:cs typeface="Calibri" pitchFamily="34" charset="-120"/>
+              </a:rPr>
+              <a:t> par police </a:t>
+            </a:r>
+            <a:r>
+              <a:rPr lang="en-US" dirty="0" err="1">
+                <a:latin typeface="Calibri" pitchFamily="34" charset="0"/>
+                <a:ea typeface="Calibri" pitchFamily="34" charset="-122"/>
+                <a:cs typeface="Calibri" pitchFamily="34" charset="-120"/>
+              </a:rPr>
+              <a:t>d'assurance</a:t>
+            </a:r>
+            <a:r>
+              <a:rPr lang="en-US" dirty="0">
+                <a:latin typeface="Calibri" pitchFamily="34" charset="0"/>
+                <a:ea typeface="Calibri" pitchFamily="34" charset="-122"/>
+                <a:cs typeface="Calibri" pitchFamily="34" charset="-120"/>
+              </a:rPr>
+              <a:t>).</a:t>
+            </a:r>
+            <a:endParaRPr lang="en-US" dirty="0"/>
+          </a:p>
+          <a:p>
+            <a:pPr marL="228600" indent="-228600">
+              <a:spcAft>
+                <a:spcPts val="1000"/>
+              </a:spcAft>
+              <a:buSzPct val="100000"/>
+              <a:buChar char="•"/>
+            </a:pPr>
+            <a:r>
+              <a:rPr lang="en-US" dirty="0" err="1">
+                <a:latin typeface="Calibri" pitchFamily="34" charset="0"/>
+                <a:ea typeface="Calibri" pitchFamily="34" charset="-122"/>
+                <a:cs typeface="Calibri" pitchFamily="34" charset="-120"/>
+              </a:rPr>
+              <a:t>Contrairement</a:t>
+            </a:r>
+            <a:r>
+              <a:rPr lang="en-US" dirty="0">
+                <a:latin typeface="Calibri" pitchFamily="34" charset="0"/>
+                <a:ea typeface="Calibri" pitchFamily="34" charset="-122"/>
+                <a:cs typeface="Calibri" pitchFamily="34" charset="-120"/>
+              </a:rPr>
+              <a:t> à </a:t>
+            </a:r>
+            <a:r>
+              <a:rPr lang="en-US" dirty="0" err="1">
+                <a:latin typeface="Calibri" pitchFamily="34" charset="0"/>
+                <a:ea typeface="Calibri" pitchFamily="34" charset="-122"/>
+                <a:cs typeface="Calibri" pitchFamily="34" charset="-120"/>
+              </a:rPr>
+              <a:t>l'espérance</a:t>
+            </a:r>
+            <a:r>
+              <a:rPr lang="en-US" dirty="0">
+                <a:latin typeface="Calibri" pitchFamily="34" charset="0"/>
+                <a:ea typeface="Calibri" pitchFamily="34" charset="-122"/>
+                <a:cs typeface="Calibri" pitchFamily="34" charset="-120"/>
+              </a:rPr>
+              <a:t>, la variance </a:t>
+            </a:r>
+            <a:r>
+              <a:rPr lang="en-US" dirty="0" err="1">
+                <a:latin typeface="Calibri" pitchFamily="34" charset="0"/>
+                <a:ea typeface="Calibri" pitchFamily="34" charset="-122"/>
+                <a:cs typeface="Calibri" pitchFamily="34" charset="-120"/>
+              </a:rPr>
+              <a:t>ou</a:t>
+            </a:r>
+            <a:r>
+              <a:rPr lang="en-US" dirty="0">
+                <a:latin typeface="Calibri" pitchFamily="34" charset="0"/>
+                <a:ea typeface="Calibri" pitchFamily="34" charset="-122"/>
+                <a:cs typeface="Calibri" pitchFamily="34" charset="-120"/>
+              </a:rPr>
+              <a:t> la </a:t>
+            </a:r>
+            <a:r>
+              <a:rPr lang="en-US" dirty="0" err="1">
+                <a:latin typeface="Calibri" pitchFamily="34" charset="0"/>
+                <a:ea typeface="Calibri" pitchFamily="34" charset="-122"/>
+                <a:cs typeface="Calibri" pitchFamily="34" charset="-120"/>
+              </a:rPr>
+              <a:t>VaR</a:t>
+            </a:r>
+            <a:r>
+              <a:rPr lang="en-US" dirty="0">
+                <a:latin typeface="Calibri" pitchFamily="34" charset="0"/>
+                <a:ea typeface="Calibri" pitchFamily="34" charset="-122"/>
+                <a:cs typeface="Calibri" pitchFamily="34" charset="-120"/>
+              </a:rPr>
+              <a:t> de Lₙ(A,P) </a:t>
+            </a:r>
+            <a:r>
+              <a:rPr lang="en-US" dirty="0" err="1">
+                <a:latin typeface="Calibri" pitchFamily="34" charset="0"/>
+                <a:ea typeface="Calibri" pitchFamily="34" charset="-122"/>
+                <a:cs typeface="Calibri" pitchFamily="34" charset="-120"/>
+              </a:rPr>
+              <a:t>capturent</a:t>
+            </a:r>
+            <a:r>
+              <a:rPr lang="en-US" dirty="0">
+                <a:latin typeface="Calibri" pitchFamily="34" charset="0"/>
+                <a:ea typeface="Calibri" pitchFamily="34" charset="-122"/>
+                <a:cs typeface="Calibri" pitchFamily="34" charset="-120"/>
+              </a:rPr>
+              <a:t> la </a:t>
+            </a:r>
+            <a:r>
+              <a:rPr lang="en-US" dirty="0" err="1">
+                <a:latin typeface="Calibri" pitchFamily="34" charset="0"/>
+                <a:ea typeface="Calibri" pitchFamily="34" charset="-122"/>
+                <a:cs typeface="Calibri" pitchFamily="34" charset="-120"/>
+              </a:rPr>
+              <a:t>dépendance</a:t>
+            </a:r>
+            <a:r>
+              <a:rPr lang="en-US" dirty="0">
+                <a:latin typeface="Calibri" pitchFamily="34" charset="0"/>
+                <a:ea typeface="Calibri" pitchFamily="34" charset="-122"/>
+                <a:cs typeface="Calibri" pitchFamily="34" charset="-120"/>
+              </a:rPr>
+              <a:t> spatiale de Cₚ.</a:t>
+            </a:r>
+            <a:endParaRPr lang="en-US" dirty="0"/>
+          </a:p>
+          <a:p>
+            <a:endParaRPr lang="fr-FR" dirty="0"/>
+          </a:p>
+        </p:txBody>
+      </p:sp>
+    </p:spTree>
+    <p:extLst>
+      <p:ext uri="{BB962C8B-B14F-4D97-AF65-F5344CB8AC3E}">
+        <p14:creationId xmlns:p14="http://schemas.microsoft.com/office/powerpoint/2010/main" val="2502944535"/>
+      </p:ext>
+    </p:extLst>
+  </p:cSld>
+  <p:clrMapOvr>
+    <a:masterClrMapping/>
+  </p:clrMapOvr>
+</p:sld>
+</file>
+
+<file path=ppt/slides/slide5.xml><?xml version="1.0" encoding="utf-8"?>
+<p:sld xmlns:a="http://schemas.openxmlformats.org/drawingml/2006/main" xmlns:r="http://schemas.openxmlformats.org/officeDocument/2006/relationships" xmlns:p="http://schemas.openxmlformats.org/presentationml/2006/main">
+  <p:cSld>
+    <p:spTree>
+      <p:nvGrpSpPr>
+        <p:cNvPr id="1" name="">
+          <a:extLst>
+            <a:ext uri="{FF2B5EF4-FFF2-40B4-BE49-F238E27FC236}">
+              <a16:creationId xmlns:a16="http://schemas.microsoft.com/office/drawing/2014/main" id="{945B9F5F-F41F-3E5B-3367-65838A2220AF}"/>
+            </a:ext>
+          </a:extLst>
+        </p:cNvPr>
+        <p:cNvGrpSpPr/>
+        <p:nvPr/>
+      </p:nvGrpSpPr>
+      <p:grpSpPr>
+        <a:xfrm>
+          <a:off x="0" y="0"/>
+          <a:ext cx="0" cy="0"/>
+          <a:chOff x="0" y="0"/>
+          <a:chExt cx="0" cy="0"/>
+        </a:xfrm>
+      </p:grpSpPr>
+      <p:sp>
+        <p:nvSpPr>
+          <p:cNvPr id="3" name="Rectangle 2">
+            <a:extLst>
+              <a:ext uri="{FF2B5EF4-FFF2-40B4-BE49-F238E27FC236}">
+                <a16:creationId xmlns:a16="http://schemas.microsoft.com/office/drawing/2014/main" id="{FEA39110-6803-B194-B22F-A79BA9634C43}"/>
+              </a:ext>
+            </a:extLst>
+          </p:cNvPr>
+          <p:cNvSpPr/>
+          <p:nvPr/>
+        </p:nvSpPr>
+        <p:spPr>
+          <a:xfrm>
+            <a:off x="0" y="0"/>
+            <a:ext cx="12192000" cy="708091"/>
+          </a:xfrm>
+          <a:prstGeom prst="rect">
+            <a:avLst/>
+          </a:prstGeom>
+        </p:spPr>
+        <p:style>
+          <a:lnRef idx="2">
+            <a:schemeClr val="accent1">
+              <a:shade val="15000"/>
+            </a:schemeClr>
+          </a:lnRef>
+          <a:fillRef idx="1">
+            <a:schemeClr val="accent1"/>
+          </a:fillRef>
+          <a:effectRef idx="0">
+            <a:schemeClr val="accent1"/>
+          </a:effectRef>
+          <a:fontRef idx="minor">
+            <a:schemeClr val="lt1"/>
+          </a:fontRef>
+        </p:style>
+        <p:txBody>
+          <a:bodyPr rtlCol="0" anchor="ctr"/>
+          <a:lstStyle/>
+          <a:p>
+            <a:r>
+              <a:rPr lang="fr-FR" sz="2800" dirty="0"/>
+              <a:t>MESURE DE RISQUE SPATIAL</a:t>
+            </a:r>
+          </a:p>
+        </p:txBody>
+      </p:sp>
+      <p:sp>
+        <p:nvSpPr>
+          <p:cNvPr id="7" name="Rectangle 6">
+            <a:extLst>
+              <a:ext uri="{FF2B5EF4-FFF2-40B4-BE49-F238E27FC236}">
+                <a16:creationId xmlns:a16="http://schemas.microsoft.com/office/drawing/2014/main" id="{18647EDF-0B3F-E76C-82D1-1C482CF075FF}"/>
+              </a:ext>
+            </a:extLst>
+          </p:cNvPr>
+          <p:cNvSpPr/>
+          <p:nvPr/>
+        </p:nvSpPr>
+        <p:spPr>
+          <a:xfrm>
+            <a:off x="609598" y="1448839"/>
+            <a:ext cx="10308771" cy="4941075"/>
+          </a:xfrm>
+          <a:prstGeom prst="rect">
+            <a:avLst/>
+          </a:prstGeom>
+          <a:solidFill>
+            <a:schemeClr val="bg1"/>
+          </a:solidFill>
+        </p:spPr>
+        <p:style>
+          <a:lnRef idx="2">
+            <a:schemeClr val="accent1">
+              <a:shade val="15000"/>
+            </a:schemeClr>
+          </a:lnRef>
+          <a:fillRef idx="1">
+            <a:schemeClr val="accent1"/>
+          </a:fillRef>
+          <a:effectRef idx="0">
+            <a:schemeClr val="accent1"/>
+          </a:effectRef>
+          <a:fontRef idx="minor">
+            <a:schemeClr val="lt1"/>
+          </a:fontRef>
+        </p:style>
+        <p:txBody>
+          <a:bodyPr rtlCol="0" anchor="ctr"/>
+          <a:lstStyle/>
+          <a:p>
+            <a:pPr>
+              <a:spcAft>
+                <a:spcPts val="1600"/>
+              </a:spcAft>
+              <a:buSzPct val="100000"/>
+            </a:pPr>
+            <a:endParaRPr lang="en-US" sz="2000" b="1" dirty="0">
+              <a:solidFill>
+                <a:srgbClr val="5B6B78"/>
+              </a:solidFill>
+              <a:latin typeface="Cambria Math" pitchFamily="34" charset="0"/>
+              <a:ea typeface="Cambria Math" pitchFamily="34" charset="-122"/>
+              <a:cs typeface="Cambria Math" pitchFamily="34" charset="-120"/>
+            </a:endParaRPr>
+          </a:p>
+        </p:txBody>
+      </p:sp>
+      <mc:AlternateContent xmlns:mc="http://schemas.openxmlformats.org/markup-compatibility/2006">
+        <mc:Choice xmlns:a14="http://schemas.microsoft.com/office/drawing/2010/main" Requires="a14">
+          <p:sp>
+            <p:nvSpPr>
+              <p:cNvPr id="8" name="Rectangle : coins arrondis 7">
+                <a:extLst>
+                  <a:ext uri="{FF2B5EF4-FFF2-40B4-BE49-F238E27FC236}">
+                    <a16:creationId xmlns:a16="http://schemas.microsoft.com/office/drawing/2014/main" id="{B7CA52EB-4FC0-CF23-6129-563E8C33C0AC}"/>
+                  </a:ext>
+                </a:extLst>
+              </p:cNvPr>
+              <p:cNvSpPr/>
+              <p:nvPr/>
+            </p:nvSpPr>
+            <p:spPr>
+              <a:xfrm>
+                <a:off x="609598" y="1068359"/>
+                <a:ext cx="10308771" cy="380480"/>
+              </a:xfrm>
+              <a:prstGeom prst="roundRect">
+                <a:avLst/>
+              </a:prstGeom>
+            </p:spPr>
+            <p:style>
+              <a:lnRef idx="2">
+                <a:schemeClr val="accent1">
+                  <a:shade val="15000"/>
+                </a:schemeClr>
+              </a:lnRef>
+              <a:fillRef idx="1">
+                <a:schemeClr val="accent1"/>
+              </a:fillRef>
+              <a:effectRef idx="0">
+                <a:schemeClr val="accent1"/>
+              </a:effectRef>
+              <a:fontRef idx="minor">
+                <a:schemeClr val="lt1"/>
+              </a:fontRef>
+            </p:style>
+            <p:txBody>
+              <a:bodyPr rtlCol="0" anchor="ctr"/>
+              <a:lstStyle/>
+              <a:p>
+                <a:r>
+                  <a:rPr lang="fr-FR" sz="2400" dirty="0"/>
+                  <a:t>Trois axiomes pour </a:t>
+                </a:r>
+                <a14:m>
+                  <m:oMath xmlns:m="http://schemas.openxmlformats.org/officeDocument/2006/math">
+                    <m:sSub>
+                      <m:sSubPr>
+                        <m:ctrlPr>
+                          <a:rPr lang="fr-FR" sz="2400" b="1" i="1">
+                            <a:solidFill>
+                              <a:schemeClr val="bg1"/>
+                            </a:solidFill>
+                            <a:latin typeface="Cambria Math" panose="02040503050406030204" pitchFamily="18" charset="0"/>
+                          </a:rPr>
+                        </m:ctrlPr>
+                      </m:sSubPr>
+                      <m:e>
+                        <m:r>
+                          <a:rPr lang="fr-FR" sz="2400" b="1" i="1">
+                            <a:solidFill>
+                              <a:schemeClr val="bg1"/>
+                            </a:solidFill>
+                            <a:latin typeface="Cambria Math" panose="02040503050406030204" pitchFamily="18" charset="0"/>
+                          </a:rPr>
+                          <m:t>𝑹</m:t>
+                        </m:r>
+                      </m:e>
+                      <m:sub>
+                        <m:r>
+                          <a:rPr lang="fr-FR" sz="2400" b="1" i="1">
+                            <a:solidFill>
+                              <a:schemeClr val="bg1"/>
+                            </a:solidFill>
+                            <a:latin typeface="Cambria Math" panose="02040503050406030204" pitchFamily="18" charset="0"/>
+                          </a:rPr>
+                          <m:t>𝝅</m:t>
+                        </m:r>
+                      </m:sub>
+                    </m:sSub>
+                  </m:oMath>
+                </a14:m>
+                <a:r>
+                  <a:rPr lang="fr-FR" sz="2400" dirty="0"/>
+                  <a:t>(.,P):</a:t>
+                </a:r>
+              </a:p>
+            </p:txBody>
+          </p:sp>
+        </mc:Choice>
+        <mc:Fallback>
+          <p:sp>
+            <p:nvSpPr>
+              <p:cNvPr id="8" name="Rectangle : coins arrondis 7">
+                <a:extLst>
+                  <a:ext uri="{FF2B5EF4-FFF2-40B4-BE49-F238E27FC236}">
+                    <a16:creationId xmlns:a16="http://schemas.microsoft.com/office/drawing/2014/main" id="{B7CA52EB-4FC0-CF23-6129-563E8C33C0AC}"/>
+                  </a:ext>
+                </a:extLst>
+              </p:cNvPr>
+              <p:cNvSpPr>
+                <a:spLocks noRot="1" noChangeAspect="1" noMove="1" noResize="1" noEditPoints="1" noAdjustHandles="1" noChangeArrowheads="1" noChangeShapeType="1" noTextEdit="1"/>
+              </p:cNvSpPr>
+              <p:nvPr/>
+            </p:nvSpPr>
+            <p:spPr>
+              <a:xfrm>
+                <a:off x="609598" y="1068359"/>
+                <a:ext cx="10308771" cy="380480"/>
+              </a:xfrm>
+              <a:prstGeom prst="roundRect">
+                <a:avLst/>
+              </a:prstGeom>
+              <a:blipFill>
+                <a:blip r:embed="rId3"/>
+                <a:stretch>
+                  <a:fillRect l="-649" t="-19697" b="-40909"/>
+                </a:stretch>
+              </a:blipFill>
+            </p:spPr>
+            <p:txBody>
+              <a:bodyPr/>
+              <a:lstStyle/>
+              <a:p>
+                <a:r>
+                  <a:rPr lang="fr-FR">
+                    <a:noFill/>
+                  </a:rPr>
+                  <a:t> </a:t>
+                </a:r>
+              </a:p>
+            </p:txBody>
+          </p:sp>
+        </mc:Fallback>
+      </mc:AlternateContent>
+      <p:sp>
+        <p:nvSpPr>
+          <p:cNvPr id="2" name="Rectangle : coins arrondis 1">
+            <a:extLst>
+              <a:ext uri="{FF2B5EF4-FFF2-40B4-BE49-F238E27FC236}">
+                <a16:creationId xmlns:a16="http://schemas.microsoft.com/office/drawing/2014/main" id="{E6292000-D8D4-E90B-0654-2F92FD0862A2}"/>
+              </a:ext>
+            </a:extLst>
+          </p:cNvPr>
+          <p:cNvSpPr/>
+          <p:nvPr/>
+        </p:nvSpPr>
+        <p:spPr>
+          <a:xfrm>
+            <a:off x="849086" y="1741728"/>
+            <a:ext cx="8697682" cy="368547"/>
+          </a:xfrm>
+          <a:prstGeom prst="roundRect">
+            <a:avLst/>
+          </a:prstGeom>
+          <a:solidFill>
+            <a:schemeClr val="accent1"/>
+          </a:solidFill>
+        </p:spPr>
+        <p:style>
+          <a:lnRef idx="2">
+            <a:schemeClr val="accent1">
+              <a:shade val="15000"/>
+            </a:schemeClr>
+          </a:lnRef>
+          <a:fillRef idx="1">
+            <a:schemeClr val="accent1"/>
+          </a:fillRef>
+          <a:effectRef idx="0">
+            <a:schemeClr val="accent1"/>
+          </a:effectRef>
+          <a:fontRef idx="minor">
+            <a:schemeClr val="lt1"/>
+          </a:fontRef>
+        </p:style>
+        <p:txBody>
+          <a:bodyPr rtlCol="0" anchor="ctr"/>
+          <a:lstStyle/>
+          <a:p>
+            <a:r>
+              <a:rPr lang="fr-FR" b="1" dirty="0"/>
+              <a:t>Invariance par translation </a:t>
+            </a:r>
+          </a:p>
+        </p:txBody>
+      </p:sp>
+      <mc:AlternateContent xmlns:mc="http://schemas.openxmlformats.org/markup-compatibility/2006">
+        <mc:Choice xmlns:a14="http://schemas.microsoft.com/office/drawing/2010/main" Requires="a14">
+          <p:sp>
+            <p:nvSpPr>
+              <p:cNvPr id="5" name="Rectangle 4">
+                <a:extLst>
+                  <a:ext uri="{FF2B5EF4-FFF2-40B4-BE49-F238E27FC236}">
+                    <a16:creationId xmlns:a16="http://schemas.microsoft.com/office/drawing/2014/main" id="{B8FCB336-C455-D70C-A00D-C7C0CE1F84A0}"/>
+                  </a:ext>
+                </a:extLst>
+              </p:cNvPr>
+              <p:cNvSpPr/>
+              <p:nvPr/>
+            </p:nvSpPr>
+            <p:spPr>
+              <a:xfrm>
+                <a:off x="849087" y="2110275"/>
+                <a:ext cx="8697682" cy="729340"/>
+              </a:xfrm>
+              <a:prstGeom prst="rect">
+                <a:avLst/>
+              </a:prstGeom>
+              <a:solidFill>
+                <a:schemeClr val="bg1"/>
+              </a:solidFill>
+            </p:spPr>
+            <p:style>
+              <a:lnRef idx="2">
+                <a:schemeClr val="accent1">
+                  <a:shade val="15000"/>
+                </a:schemeClr>
+              </a:lnRef>
+              <a:fillRef idx="1">
+                <a:schemeClr val="accent1"/>
+              </a:fillRef>
+              <a:effectRef idx="0">
+                <a:schemeClr val="accent1"/>
+              </a:effectRef>
+              <a:fontRef idx="minor">
+                <a:schemeClr val="lt1"/>
+              </a:fontRef>
+            </p:style>
+            <p:txBody>
+              <a:bodyPr rtlCol="0" anchor="ctr"/>
+              <a:lstStyle/>
+              <a:p>
+                <a:r>
+                  <a:rPr lang="fr-FR" dirty="0">
+                    <a:solidFill>
+                      <a:schemeClr val="tx1"/>
+                    </a:solidFill>
+                  </a:rPr>
+                  <a:t>Soit </a:t>
+                </a:r>
+                <a14:m>
+                  <m:oMath xmlns:m="http://schemas.openxmlformats.org/officeDocument/2006/math">
+                    <m:r>
+                      <a:rPr lang="fr-FR" i="1" dirty="0" smtClean="0">
+                        <a:solidFill>
+                          <a:schemeClr val="tx1"/>
+                        </a:solidFill>
+                        <a:latin typeface="Cambria Math" panose="02040503050406030204" pitchFamily="18" charset="0"/>
+                      </a:rPr>
+                      <m:t>𝑣</m:t>
+                    </m:r>
+                    <m:r>
+                      <a:rPr lang="fr-FR" i="0" dirty="0">
+                        <a:solidFill>
+                          <a:schemeClr val="tx1"/>
+                        </a:solidFill>
+                        <a:latin typeface="Cambria Math" panose="02040503050406030204" pitchFamily="18" charset="0"/>
+                      </a:rPr>
+                      <m:t>∈</m:t>
+                    </m:r>
+                    <m:sSup>
+                      <m:sSupPr>
+                        <m:ctrlPr>
+                          <a:rPr lang="fr-FR" i="1" dirty="0">
+                            <a:solidFill>
+                              <a:schemeClr val="tx1"/>
+                            </a:solidFill>
+                            <a:latin typeface="Cambria Math" panose="02040503050406030204" pitchFamily="18" charset="0"/>
+                          </a:rPr>
+                        </m:ctrlPr>
+                      </m:sSupPr>
+                      <m:e>
+                        <m:r>
+                          <a:rPr lang="fr-FR" i="1" dirty="0">
+                            <a:solidFill>
+                              <a:schemeClr val="tx1"/>
+                            </a:solidFill>
+                            <a:latin typeface="Cambria Math" panose="02040503050406030204" pitchFamily="18" charset="0"/>
+                          </a:rPr>
+                          <m:t>𝑅</m:t>
+                        </m:r>
+                      </m:e>
+                      <m:sup>
+                        <m:r>
+                          <a:rPr lang="fr-FR" i="0" dirty="0">
+                            <a:solidFill>
+                              <a:schemeClr val="tx1"/>
+                            </a:solidFill>
+                            <a:latin typeface="Cambria Math" panose="02040503050406030204" pitchFamily="18" charset="0"/>
+                          </a:rPr>
+                          <m:t>2</m:t>
+                        </m:r>
+                      </m:sup>
+                    </m:sSup>
+                  </m:oMath>
+                </a14:m>
+                <a:r>
+                  <a:rPr lang="fr-FR" dirty="0">
+                    <a:solidFill>
+                      <a:schemeClr val="tx1"/>
+                    </a:solidFill>
+                  </a:rPr>
+                  <a:t>, </a:t>
+                </a:r>
+                <a14:m>
+                  <m:oMath xmlns:m="http://schemas.openxmlformats.org/officeDocument/2006/math">
+                    <m:sSub>
+                      <m:sSubPr>
+                        <m:ctrlPr>
+                          <a:rPr lang="fr-FR" b="1" i="1">
+                            <a:solidFill>
+                              <a:schemeClr val="tx1"/>
+                            </a:solidFill>
+                            <a:latin typeface="Cambria Math" panose="02040503050406030204" pitchFamily="18" charset="0"/>
+                          </a:rPr>
+                        </m:ctrlPr>
+                      </m:sSubPr>
+                      <m:e>
+                        <m:r>
+                          <a:rPr lang="fr-FR" b="1" i="1">
+                            <a:solidFill>
+                              <a:schemeClr val="tx1"/>
+                            </a:solidFill>
+                            <a:latin typeface="Cambria Math" panose="02040503050406030204" pitchFamily="18" charset="0"/>
+                          </a:rPr>
+                          <m:t>𝑹</m:t>
+                        </m:r>
+                      </m:e>
+                      <m:sub>
+                        <m:r>
+                          <a:rPr lang="fr-FR" b="1" i="1">
+                            <a:solidFill>
+                              <a:schemeClr val="tx1"/>
+                            </a:solidFill>
+                            <a:latin typeface="Cambria Math" panose="02040503050406030204" pitchFamily="18" charset="0"/>
+                          </a:rPr>
+                          <m:t>𝝅</m:t>
+                        </m:r>
+                      </m:sub>
+                    </m:sSub>
+                  </m:oMath>
+                </a14:m>
+                <a:r>
+                  <a:rPr lang="fr-FR" dirty="0">
+                    <a:solidFill>
+                      <a:schemeClr val="tx1"/>
+                    </a:solidFill>
+                  </a:rPr>
+                  <a:t>(A+ </a:t>
+                </a:r>
+                <a14:m>
+                  <m:oMath xmlns:m="http://schemas.openxmlformats.org/officeDocument/2006/math">
+                    <m:r>
+                      <a:rPr lang="fr-FR" i="1" dirty="0">
+                        <a:solidFill>
+                          <a:schemeClr val="tx1"/>
+                        </a:solidFill>
+                        <a:latin typeface="Cambria Math" panose="02040503050406030204" pitchFamily="18" charset="0"/>
+                      </a:rPr>
+                      <m:t>𝑣</m:t>
+                    </m:r>
+                  </m:oMath>
+                </a14:m>
+                <a:r>
+                  <a:rPr lang="fr-FR" dirty="0">
+                    <a:solidFill>
+                      <a:schemeClr val="tx1"/>
+                    </a:solidFill>
+                  </a:rPr>
+                  <a:t>,P)=</a:t>
+                </a:r>
+                <a:r>
+                  <a:rPr lang="fr-FR" b="1" dirty="0">
+                    <a:solidFill>
+                      <a:schemeClr val="tx1"/>
+                    </a:solidFill>
+                  </a:rPr>
+                  <a:t> </a:t>
+                </a:r>
+                <a14:m>
+                  <m:oMath xmlns:m="http://schemas.openxmlformats.org/officeDocument/2006/math">
+                    <m:sSub>
+                      <m:sSubPr>
+                        <m:ctrlPr>
+                          <a:rPr lang="fr-FR" b="1" i="1">
+                            <a:solidFill>
+                              <a:schemeClr val="tx1"/>
+                            </a:solidFill>
+                            <a:latin typeface="Cambria Math" panose="02040503050406030204" pitchFamily="18" charset="0"/>
+                          </a:rPr>
+                        </m:ctrlPr>
+                      </m:sSubPr>
+                      <m:e>
+                        <m:r>
+                          <a:rPr lang="fr-FR" b="1" i="1">
+                            <a:solidFill>
+                              <a:schemeClr val="tx1"/>
+                            </a:solidFill>
+                            <a:latin typeface="Cambria Math" panose="02040503050406030204" pitchFamily="18" charset="0"/>
+                          </a:rPr>
+                          <m:t>𝑹</m:t>
+                        </m:r>
+                      </m:e>
+                      <m:sub>
+                        <m:r>
+                          <a:rPr lang="fr-FR" b="1" i="1">
+                            <a:solidFill>
+                              <a:schemeClr val="tx1"/>
+                            </a:solidFill>
+                            <a:latin typeface="Cambria Math" panose="02040503050406030204" pitchFamily="18" charset="0"/>
+                          </a:rPr>
+                          <m:t>𝝅</m:t>
+                        </m:r>
+                      </m:sub>
+                    </m:sSub>
+                  </m:oMath>
+                </a14:m>
+                <a:r>
+                  <a:rPr lang="fr-FR" dirty="0">
+                    <a:solidFill>
+                      <a:schemeClr val="tx1"/>
+                    </a:solidFill>
+                  </a:rPr>
+                  <a:t>(A,P).</a:t>
+                </a:r>
+              </a:p>
+              <a:p>
+                <a:r>
+                  <a:rPr lang="en-US" dirty="0" err="1">
+                    <a:solidFill>
+                      <a:schemeClr val="tx1"/>
+                    </a:solidFill>
+                    <a:latin typeface="Calibri" pitchFamily="34" charset="0"/>
+                    <a:ea typeface="Calibri" pitchFamily="34" charset="-122"/>
+                    <a:cs typeface="Calibri" pitchFamily="34" charset="-120"/>
+                  </a:rPr>
+                  <a:t>Déplacer</a:t>
+                </a:r>
+                <a:r>
+                  <a:rPr lang="en-US" dirty="0">
+                    <a:solidFill>
+                      <a:schemeClr val="tx1"/>
+                    </a:solidFill>
+                    <a:latin typeface="Calibri" pitchFamily="34" charset="0"/>
+                    <a:ea typeface="Calibri" pitchFamily="34" charset="-122"/>
+                    <a:cs typeface="Calibri" pitchFamily="34" charset="-120"/>
+                  </a:rPr>
+                  <a:t> la région ne change pas le risque.</a:t>
+                </a:r>
+                <a:endParaRPr lang="fr-FR" dirty="0">
+                  <a:solidFill>
+                    <a:schemeClr val="tx1"/>
+                  </a:solidFill>
+                </a:endParaRPr>
+              </a:p>
+            </p:txBody>
+          </p:sp>
+        </mc:Choice>
+        <mc:Fallback>
+          <p:sp>
+            <p:nvSpPr>
+              <p:cNvPr id="5" name="Rectangle 4">
+                <a:extLst>
+                  <a:ext uri="{FF2B5EF4-FFF2-40B4-BE49-F238E27FC236}">
+                    <a16:creationId xmlns:a16="http://schemas.microsoft.com/office/drawing/2014/main" id="{B8FCB336-C455-D70C-A00D-C7C0CE1F84A0}"/>
+                  </a:ext>
+                </a:extLst>
+              </p:cNvPr>
+              <p:cNvSpPr>
+                <a:spLocks noRot="1" noChangeAspect="1" noMove="1" noResize="1" noEditPoints="1" noAdjustHandles="1" noChangeArrowheads="1" noChangeShapeType="1" noTextEdit="1"/>
+              </p:cNvSpPr>
+              <p:nvPr/>
+            </p:nvSpPr>
+            <p:spPr>
+              <a:xfrm>
+                <a:off x="849087" y="2110275"/>
+                <a:ext cx="8697682" cy="729340"/>
+              </a:xfrm>
+              <a:prstGeom prst="rect">
+                <a:avLst/>
+              </a:prstGeom>
+              <a:blipFill>
+                <a:blip r:embed="rId4"/>
+                <a:stretch>
+                  <a:fillRect l="-490" b="-4878"/>
+                </a:stretch>
+              </a:blipFill>
+            </p:spPr>
+            <p:txBody>
+              <a:bodyPr/>
+              <a:lstStyle/>
+              <a:p>
+                <a:r>
+                  <a:rPr lang="fr-FR">
+                    <a:noFill/>
+                  </a:rPr>
+                  <a:t> </a:t>
+                </a:r>
+              </a:p>
+            </p:txBody>
+          </p:sp>
+        </mc:Fallback>
+      </mc:AlternateContent>
+      <p:sp>
+        <p:nvSpPr>
+          <p:cNvPr id="9" name="Rectangle : coins arrondis 8">
+            <a:extLst>
+              <a:ext uri="{FF2B5EF4-FFF2-40B4-BE49-F238E27FC236}">
+                <a16:creationId xmlns:a16="http://schemas.microsoft.com/office/drawing/2014/main" id="{F9D545FC-71F5-6EE2-6C4E-C091610AAD19}"/>
+              </a:ext>
+            </a:extLst>
+          </p:cNvPr>
+          <p:cNvSpPr/>
+          <p:nvPr/>
+        </p:nvSpPr>
+        <p:spPr>
+          <a:xfrm>
+            <a:off x="849085" y="3057851"/>
+            <a:ext cx="8697684" cy="368547"/>
+          </a:xfrm>
+          <a:prstGeom prst="roundRect">
+            <a:avLst/>
+          </a:prstGeom>
+          <a:solidFill>
+            <a:schemeClr val="accent1"/>
+          </a:solidFill>
+        </p:spPr>
+        <p:style>
+          <a:lnRef idx="2">
+            <a:schemeClr val="accent1">
+              <a:shade val="15000"/>
+            </a:schemeClr>
+          </a:lnRef>
+          <a:fillRef idx="1">
+            <a:schemeClr val="accent1"/>
+          </a:fillRef>
+          <a:effectRef idx="0">
+            <a:schemeClr val="accent1"/>
+          </a:effectRef>
+          <a:fontRef idx="minor">
+            <a:schemeClr val="lt1"/>
+          </a:fontRef>
+        </p:style>
+        <p:txBody>
+          <a:bodyPr rtlCol="0" anchor="ctr"/>
+          <a:lstStyle/>
+          <a:p>
+            <a:r>
+              <a:rPr lang="fr-FR" b="1" dirty="0"/>
+              <a:t>Sous-additivité spatiale</a:t>
+            </a:r>
+          </a:p>
+        </p:txBody>
+      </p:sp>
+      <mc:AlternateContent xmlns:mc="http://schemas.openxmlformats.org/markup-compatibility/2006">
+        <mc:Choice xmlns:a14="http://schemas.microsoft.com/office/drawing/2010/main" Requires="a14">
+          <p:sp>
+            <p:nvSpPr>
+              <p:cNvPr id="11" name="Rectangle 10">
+                <a:extLst>
+                  <a:ext uri="{FF2B5EF4-FFF2-40B4-BE49-F238E27FC236}">
+                    <a16:creationId xmlns:a16="http://schemas.microsoft.com/office/drawing/2014/main" id="{EB38C6E2-B2CD-DCDF-EB4F-3E1B40E2DD32}"/>
+                  </a:ext>
+                </a:extLst>
+              </p:cNvPr>
+              <p:cNvSpPr/>
+              <p:nvPr/>
+            </p:nvSpPr>
+            <p:spPr>
+              <a:xfrm>
+                <a:off x="849084" y="3438332"/>
+                <a:ext cx="8697685" cy="1154404"/>
+              </a:xfrm>
+              <a:prstGeom prst="rect">
+                <a:avLst/>
+              </a:prstGeom>
+              <a:solidFill>
+                <a:schemeClr val="bg1"/>
+              </a:solidFill>
+            </p:spPr>
+            <p:style>
+              <a:lnRef idx="2">
+                <a:schemeClr val="accent1">
+                  <a:shade val="15000"/>
+                </a:schemeClr>
+              </a:lnRef>
+              <a:fillRef idx="1">
+                <a:schemeClr val="accent1"/>
+              </a:fillRef>
+              <a:effectRef idx="0">
+                <a:schemeClr val="accent1"/>
+              </a:effectRef>
+              <a:fontRef idx="minor">
+                <a:schemeClr val="lt1"/>
+              </a:fontRef>
+            </p:style>
+            <p:txBody>
+              <a:bodyPr rtlCol="0" anchor="ctr"/>
+              <a:lstStyle/>
+              <a:p>
+                <a:pPr>
+                  <a:lnSpc>
+                    <a:spcPct val="115000"/>
+                  </a:lnSpc>
+                </a:pPr>
+                <a14:m>
+                  <m:oMath xmlns:m="http://schemas.openxmlformats.org/officeDocument/2006/math">
+                    <m:sSub>
+                      <m:sSubPr>
+                        <m:ctrlPr>
+                          <a:rPr lang="fr-FR" b="1" i="1">
+                            <a:solidFill>
+                              <a:schemeClr val="tx1"/>
+                            </a:solidFill>
+                            <a:latin typeface="Cambria Math" panose="02040503050406030204" pitchFamily="18" charset="0"/>
+                          </a:rPr>
+                        </m:ctrlPr>
+                      </m:sSubPr>
+                      <m:e>
+                        <m:r>
+                          <a:rPr lang="fr-FR" b="1" i="1">
+                            <a:solidFill>
+                              <a:schemeClr val="tx1"/>
+                            </a:solidFill>
+                            <a:latin typeface="Cambria Math" panose="02040503050406030204" pitchFamily="18" charset="0"/>
+                          </a:rPr>
+                          <m:t>𝑹</m:t>
+                        </m:r>
+                      </m:e>
+                      <m:sub>
+                        <m:r>
+                          <a:rPr lang="fr-FR" b="1" i="1">
+                            <a:solidFill>
+                              <a:schemeClr val="tx1"/>
+                            </a:solidFill>
+                            <a:latin typeface="Cambria Math" panose="02040503050406030204" pitchFamily="18" charset="0"/>
+                          </a:rPr>
+                          <m:t>𝝅</m:t>
+                        </m:r>
+                      </m:sub>
+                    </m:sSub>
+                  </m:oMath>
+                </a14:m>
+                <a:r>
+                  <a:rPr lang="en-US" dirty="0">
+                    <a:solidFill>
+                      <a:schemeClr val="tx1"/>
+                    </a:solidFill>
+                    <a:latin typeface="Cambria Math" pitchFamily="34" charset="0"/>
+                    <a:ea typeface="Cambria Math" pitchFamily="34" charset="-122"/>
+                    <a:cs typeface="Cambria Math" pitchFamily="34" charset="-120"/>
+                  </a:rPr>
+                  <a:t>(A₁∪A₂,P) ≤ min{</a:t>
+                </a:r>
+                <a14:m>
+                  <m:oMath xmlns:m="http://schemas.openxmlformats.org/officeDocument/2006/math">
+                    <m:sSub>
+                      <m:sSubPr>
+                        <m:ctrlPr>
+                          <a:rPr lang="fr-FR" b="1" i="1">
+                            <a:solidFill>
+                              <a:schemeClr val="tx1"/>
+                            </a:solidFill>
+                            <a:latin typeface="Cambria Math" panose="02040503050406030204" pitchFamily="18" charset="0"/>
+                          </a:rPr>
+                        </m:ctrlPr>
+                      </m:sSubPr>
+                      <m:e>
+                        <m:r>
+                          <a:rPr lang="fr-FR" b="1" i="1">
+                            <a:solidFill>
+                              <a:schemeClr val="tx1"/>
+                            </a:solidFill>
+                            <a:latin typeface="Cambria Math" panose="02040503050406030204" pitchFamily="18" charset="0"/>
+                          </a:rPr>
+                          <m:t>𝑹</m:t>
+                        </m:r>
+                      </m:e>
+                      <m:sub>
+                        <m:r>
+                          <a:rPr lang="fr-FR" b="1" i="1">
+                            <a:solidFill>
+                              <a:schemeClr val="tx1"/>
+                            </a:solidFill>
+                            <a:latin typeface="Cambria Math" panose="02040503050406030204" pitchFamily="18" charset="0"/>
+                          </a:rPr>
+                          <m:t>𝝅</m:t>
+                        </m:r>
+                      </m:sub>
+                    </m:sSub>
+                  </m:oMath>
+                </a14:m>
+                <a:r>
+                  <a:rPr lang="en-US" dirty="0">
+                    <a:solidFill>
+                      <a:schemeClr val="tx1"/>
+                    </a:solidFill>
+                    <a:latin typeface="Cambria Math" pitchFamily="34" charset="0"/>
+                    <a:ea typeface="Cambria Math" pitchFamily="34" charset="-122"/>
+                    <a:cs typeface="Cambria Math" pitchFamily="34" charset="-120"/>
+                  </a:rPr>
+                  <a:t>(A₁,P), </a:t>
+                </a:r>
+                <a14:m>
+                  <m:oMath xmlns:m="http://schemas.openxmlformats.org/officeDocument/2006/math">
+                    <m:sSub>
+                      <m:sSubPr>
+                        <m:ctrlPr>
+                          <a:rPr lang="fr-FR" b="1" i="1">
+                            <a:solidFill>
+                              <a:schemeClr val="tx1"/>
+                            </a:solidFill>
+                            <a:latin typeface="Cambria Math" panose="02040503050406030204" pitchFamily="18" charset="0"/>
+                          </a:rPr>
+                        </m:ctrlPr>
+                      </m:sSubPr>
+                      <m:e>
+                        <m:r>
+                          <a:rPr lang="fr-FR" b="1" i="1">
+                            <a:solidFill>
+                              <a:schemeClr val="tx1"/>
+                            </a:solidFill>
+                            <a:latin typeface="Cambria Math" panose="02040503050406030204" pitchFamily="18" charset="0"/>
+                          </a:rPr>
+                          <m:t>𝑹</m:t>
+                        </m:r>
+                      </m:e>
+                      <m:sub>
+                        <m:r>
+                          <a:rPr lang="fr-FR" b="1" i="1">
+                            <a:solidFill>
+                              <a:schemeClr val="tx1"/>
+                            </a:solidFill>
+                            <a:latin typeface="Cambria Math" panose="02040503050406030204" pitchFamily="18" charset="0"/>
+                          </a:rPr>
+                          <m:t>𝝅</m:t>
+                        </m:r>
+                      </m:sub>
+                    </m:sSub>
+                  </m:oMath>
+                </a14:m>
+                <a:r>
+                  <a:rPr lang="en-US" dirty="0">
+                    <a:solidFill>
+                      <a:schemeClr val="tx1"/>
+                    </a:solidFill>
+                    <a:latin typeface="Cambria Math" pitchFamily="34" charset="0"/>
+                    <a:ea typeface="Cambria Math" pitchFamily="34" charset="-122"/>
+                    <a:cs typeface="Cambria Math" pitchFamily="34" charset="-120"/>
+                  </a:rPr>
+                  <a:t>(A₂,P)}.</a:t>
+                </a:r>
+              </a:p>
+              <a:p>
+                <a:pPr>
+                  <a:lnSpc>
+                    <a:spcPct val="115000"/>
+                  </a:lnSpc>
+                </a:pPr>
+                <a:r>
+                  <a:rPr lang="en-US" dirty="0">
+                    <a:solidFill>
+                      <a:schemeClr val="tx1"/>
+                    </a:solidFill>
+                    <a:latin typeface="Calibri" pitchFamily="34" charset="0"/>
+                    <a:ea typeface="Calibri" pitchFamily="34" charset="-122"/>
+                    <a:cs typeface="Calibri" pitchFamily="34" charset="-120"/>
+                  </a:rPr>
+                  <a:t>Diversification</a:t>
+                </a:r>
+                <a:r>
+                  <a:rPr lang="en-US" dirty="0">
+                    <a:solidFill>
+                      <a:srgbClr val="5B6B78"/>
+                    </a:solidFill>
+                    <a:latin typeface="Calibri" pitchFamily="34" charset="0"/>
+                    <a:ea typeface="Calibri" pitchFamily="34" charset="-122"/>
+                    <a:cs typeface="Calibri" pitchFamily="34" charset="-120"/>
+                  </a:rPr>
+                  <a:t> </a:t>
+                </a:r>
+                <a:r>
+                  <a:rPr lang="en-US" dirty="0">
+                    <a:solidFill>
+                      <a:schemeClr val="tx1"/>
+                    </a:solidFill>
+                    <a:latin typeface="Calibri" pitchFamily="34" charset="0"/>
+                    <a:ea typeface="Calibri" pitchFamily="34" charset="-122"/>
+                    <a:cs typeface="Calibri" pitchFamily="34" charset="-120"/>
+                  </a:rPr>
+                  <a:t>: </a:t>
+                </a:r>
+                <a:r>
+                  <a:rPr lang="en-US" dirty="0" err="1">
+                    <a:solidFill>
+                      <a:schemeClr val="tx1"/>
+                    </a:solidFill>
+                    <a:latin typeface="Calibri" pitchFamily="34" charset="0"/>
+                    <a:ea typeface="Calibri" pitchFamily="34" charset="-122"/>
+                    <a:cs typeface="Calibri" pitchFamily="34" charset="-120"/>
+                  </a:rPr>
+                  <a:t>réunir</a:t>
+                </a:r>
+                <a:r>
+                  <a:rPr lang="en-US" dirty="0">
+                    <a:solidFill>
+                      <a:schemeClr val="tx1"/>
+                    </a:solidFill>
+                    <a:latin typeface="Calibri" pitchFamily="34" charset="0"/>
+                    <a:ea typeface="Calibri" pitchFamily="34" charset="-122"/>
+                    <a:cs typeface="Calibri" pitchFamily="34" charset="-120"/>
+                  </a:rPr>
+                  <a:t> deux </a:t>
+                </a:r>
+                <a:r>
+                  <a:rPr lang="en-US" dirty="0" err="1">
+                    <a:solidFill>
+                      <a:schemeClr val="tx1"/>
+                    </a:solidFill>
+                    <a:latin typeface="Calibri" pitchFamily="34" charset="0"/>
+                    <a:ea typeface="Calibri" pitchFamily="34" charset="-122"/>
+                    <a:cs typeface="Calibri" pitchFamily="34" charset="-120"/>
+                  </a:rPr>
+                  <a:t>régions</a:t>
+                </a:r>
+                <a:r>
+                  <a:rPr lang="en-US" dirty="0">
+                    <a:solidFill>
+                      <a:schemeClr val="tx1"/>
+                    </a:solidFill>
+                    <a:latin typeface="Calibri" pitchFamily="34" charset="0"/>
+                    <a:ea typeface="Calibri" pitchFamily="34" charset="-122"/>
+                    <a:cs typeface="Calibri" pitchFamily="34" charset="-120"/>
+                  </a:rPr>
+                  <a:t> ne </a:t>
+                </a:r>
+                <a:r>
+                  <a:rPr lang="en-US" dirty="0" err="1">
+                    <a:solidFill>
+                      <a:schemeClr val="tx1"/>
+                    </a:solidFill>
+                    <a:latin typeface="Calibri" pitchFamily="34" charset="0"/>
+                    <a:ea typeface="Calibri" pitchFamily="34" charset="-122"/>
+                    <a:cs typeface="Calibri" pitchFamily="34" charset="-120"/>
+                  </a:rPr>
+                  <a:t>peut</a:t>
+                </a:r>
+                <a:r>
+                  <a:rPr lang="en-US" dirty="0">
+                    <a:solidFill>
+                      <a:schemeClr val="tx1"/>
+                    </a:solidFill>
+                    <a:latin typeface="Calibri" pitchFamily="34" charset="0"/>
+                    <a:ea typeface="Calibri" pitchFamily="34" charset="-122"/>
+                    <a:cs typeface="Calibri" pitchFamily="34" charset="-120"/>
+                  </a:rPr>
+                  <a:t> </a:t>
+                </a:r>
+                <a:r>
+                  <a:rPr lang="en-US" dirty="0" err="1">
+                    <a:solidFill>
+                      <a:schemeClr val="tx1"/>
+                    </a:solidFill>
+                    <a:latin typeface="Calibri" pitchFamily="34" charset="0"/>
+                    <a:ea typeface="Calibri" pitchFamily="34" charset="-122"/>
+                    <a:cs typeface="Calibri" pitchFamily="34" charset="-120"/>
+                  </a:rPr>
+                  <a:t>qu'améliorer</a:t>
+                </a:r>
+                <a:r>
+                  <a:rPr lang="en-US" dirty="0">
+                    <a:solidFill>
+                      <a:schemeClr val="tx1"/>
+                    </a:solidFill>
+                    <a:latin typeface="Calibri" pitchFamily="34" charset="0"/>
+                    <a:ea typeface="Calibri" pitchFamily="34" charset="-122"/>
+                    <a:cs typeface="Calibri" pitchFamily="34" charset="-120"/>
+                  </a:rPr>
+                  <a:t> (</a:t>
+                </a:r>
+                <a:r>
+                  <a:rPr lang="en-US" dirty="0" err="1">
+                    <a:solidFill>
+                      <a:schemeClr val="tx1"/>
+                    </a:solidFill>
+                    <a:latin typeface="Calibri" pitchFamily="34" charset="0"/>
+                    <a:ea typeface="Calibri" pitchFamily="34" charset="-122"/>
+                    <a:cs typeface="Calibri" pitchFamily="34" charset="-120"/>
+                  </a:rPr>
+                  <a:t>ou</a:t>
+                </a:r>
+                <a:r>
+                  <a:rPr lang="en-US" dirty="0">
+                    <a:solidFill>
+                      <a:schemeClr val="tx1"/>
+                    </a:solidFill>
+                    <a:latin typeface="Calibri" pitchFamily="34" charset="0"/>
+                    <a:ea typeface="Calibri" pitchFamily="34" charset="-122"/>
+                    <a:cs typeface="Calibri" pitchFamily="34" charset="-120"/>
+                  </a:rPr>
+                  <a:t> </a:t>
+                </a:r>
+                <a:r>
+                  <a:rPr lang="en-US" dirty="0" err="1">
+                    <a:solidFill>
+                      <a:schemeClr val="tx1"/>
+                    </a:solidFill>
+                    <a:latin typeface="Calibri" pitchFamily="34" charset="0"/>
+                    <a:ea typeface="Calibri" pitchFamily="34" charset="-122"/>
+                    <a:cs typeface="Calibri" pitchFamily="34" charset="-120"/>
+                  </a:rPr>
+                  <a:t>maintenir</a:t>
+                </a:r>
+                <a:r>
+                  <a:rPr lang="en-US" dirty="0">
+                    <a:solidFill>
+                      <a:schemeClr val="tx1"/>
+                    </a:solidFill>
+                    <a:latin typeface="Calibri" pitchFamily="34" charset="0"/>
+                    <a:ea typeface="Calibri" pitchFamily="34" charset="-122"/>
+                    <a:cs typeface="Calibri" pitchFamily="34" charset="-120"/>
+                  </a:rPr>
+                  <a:t>) le risque.</a:t>
+                </a:r>
+                <a:endParaRPr lang="en-US" dirty="0">
+                  <a:solidFill>
+                    <a:schemeClr val="tx1"/>
+                  </a:solidFill>
+                </a:endParaRPr>
+              </a:p>
+            </p:txBody>
+          </p:sp>
+        </mc:Choice>
+        <mc:Fallback>
+          <p:sp>
+            <p:nvSpPr>
+              <p:cNvPr id="11" name="Rectangle 10">
+                <a:extLst>
+                  <a:ext uri="{FF2B5EF4-FFF2-40B4-BE49-F238E27FC236}">
+                    <a16:creationId xmlns:a16="http://schemas.microsoft.com/office/drawing/2014/main" id="{EB38C6E2-B2CD-DCDF-EB4F-3E1B40E2DD32}"/>
+                  </a:ext>
+                </a:extLst>
+              </p:cNvPr>
+              <p:cNvSpPr>
+                <a:spLocks noRot="1" noChangeAspect="1" noMove="1" noResize="1" noEditPoints="1" noAdjustHandles="1" noChangeArrowheads="1" noChangeShapeType="1" noTextEdit="1"/>
+              </p:cNvSpPr>
+              <p:nvPr/>
+            </p:nvSpPr>
+            <p:spPr>
+              <a:xfrm>
+                <a:off x="849084" y="3438332"/>
+                <a:ext cx="8697685" cy="1154404"/>
+              </a:xfrm>
+              <a:prstGeom prst="rect">
+                <a:avLst/>
+              </a:prstGeom>
+              <a:blipFill>
+                <a:blip r:embed="rId5"/>
+                <a:stretch>
+                  <a:fillRect l="-490"/>
+                </a:stretch>
+              </a:blipFill>
+            </p:spPr>
+            <p:txBody>
+              <a:bodyPr/>
+              <a:lstStyle/>
+              <a:p>
+                <a:r>
+                  <a:rPr lang="fr-FR">
+                    <a:noFill/>
+                  </a:rPr>
+                  <a:t> </a:t>
+                </a:r>
+              </a:p>
+            </p:txBody>
+          </p:sp>
+        </mc:Fallback>
+      </mc:AlternateContent>
+      <p:sp>
+        <p:nvSpPr>
+          <p:cNvPr id="13" name="Rectangle : coins arrondis 12">
+            <a:extLst>
+              <a:ext uri="{FF2B5EF4-FFF2-40B4-BE49-F238E27FC236}">
+                <a16:creationId xmlns:a16="http://schemas.microsoft.com/office/drawing/2014/main" id="{C6720D0D-4DFE-B744-AC50-CC3FC6A22B7B}"/>
+              </a:ext>
+            </a:extLst>
+          </p:cNvPr>
+          <p:cNvSpPr/>
+          <p:nvPr/>
+        </p:nvSpPr>
+        <p:spPr>
+          <a:xfrm>
+            <a:off x="849084" y="4782976"/>
+            <a:ext cx="8697686" cy="380480"/>
+          </a:xfrm>
+          <a:prstGeom prst="roundRect">
+            <a:avLst/>
+          </a:prstGeom>
+          <a:solidFill>
+            <a:schemeClr val="accent1"/>
+          </a:solidFill>
+        </p:spPr>
+        <p:style>
+          <a:lnRef idx="2">
+            <a:schemeClr val="accent1">
+              <a:shade val="15000"/>
+            </a:schemeClr>
+          </a:lnRef>
+          <a:fillRef idx="1">
+            <a:schemeClr val="accent1"/>
+          </a:fillRef>
+          <a:effectRef idx="0">
+            <a:schemeClr val="accent1"/>
+          </a:effectRef>
+          <a:fontRef idx="minor">
+            <a:schemeClr val="lt1"/>
+          </a:fontRef>
+        </p:style>
+        <p:txBody>
+          <a:bodyPr rtlCol="0" anchor="ctr"/>
+          <a:lstStyle/>
+          <a:p>
+            <a:pPr>
+              <a:lnSpc>
+                <a:spcPct val="110000"/>
+              </a:lnSpc>
+            </a:pPr>
+            <a:r>
+              <a:rPr lang="en-US" b="1" dirty="0" err="1">
+                <a:solidFill>
+                  <a:schemeClr val="bg1"/>
+                </a:solidFill>
+                <a:latin typeface="Cambria" pitchFamily="34" charset="0"/>
+                <a:ea typeface="Cambria" pitchFamily="34" charset="-122"/>
+                <a:cs typeface="Cambria" pitchFamily="34" charset="-120"/>
+              </a:rPr>
+              <a:t>Homogénéité</a:t>
+            </a:r>
+            <a:r>
+              <a:rPr lang="en-US" b="1" dirty="0">
+                <a:solidFill>
+                  <a:schemeClr val="bg1"/>
+                </a:solidFill>
+                <a:latin typeface="Cambria" pitchFamily="34" charset="0"/>
+                <a:ea typeface="Cambria" pitchFamily="34" charset="-122"/>
+                <a:cs typeface="Cambria" pitchFamily="34" charset="-120"/>
+              </a:rPr>
+              <a:t> </a:t>
+            </a:r>
+            <a:r>
+              <a:rPr lang="en-US" b="1" dirty="0" err="1">
+                <a:solidFill>
+                  <a:schemeClr val="bg1"/>
+                </a:solidFill>
+                <a:latin typeface="Cambria" pitchFamily="34" charset="0"/>
+                <a:ea typeface="Cambria" pitchFamily="34" charset="-122"/>
+                <a:cs typeface="Cambria" pitchFamily="34" charset="-120"/>
+              </a:rPr>
+              <a:t>asymptotique</a:t>
+            </a:r>
+            <a:r>
+              <a:rPr lang="en-US" b="1" dirty="0">
+                <a:solidFill>
+                  <a:schemeClr val="bg1"/>
+                </a:solidFill>
+                <a:latin typeface="Cambria" pitchFamily="34" charset="0"/>
+                <a:ea typeface="Cambria" pitchFamily="34" charset="-122"/>
+                <a:cs typeface="Cambria" pitchFamily="34" charset="-120"/>
+              </a:rPr>
+              <a:t> </a:t>
+            </a:r>
+            <a:r>
+              <a:rPr lang="en-US" b="1" dirty="0" err="1">
+                <a:solidFill>
+                  <a:schemeClr val="bg1"/>
+                </a:solidFill>
+                <a:latin typeface="Cambria" pitchFamily="34" charset="0"/>
+                <a:ea typeface="Cambria" pitchFamily="34" charset="-122"/>
+                <a:cs typeface="Cambria" pitchFamily="34" charset="-120"/>
+              </a:rPr>
+              <a:t>d'ordre</a:t>
+            </a:r>
+            <a:r>
+              <a:rPr lang="en-US" b="1" dirty="0">
+                <a:solidFill>
+                  <a:schemeClr val="bg1"/>
+                </a:solidFill>
+                <a:latin typeface="Cambria" pitchFamily="34" charset="0"/>
+                <a:ea typeface="Cambria" pitchFamily="34" charset="-122"/>
+                <a:cs typeface="Cambria" pitchFamily="34" charset="-120"/>
+              </a:rPr>
+              <a:t> −α</a:t>
+            </a:r>
+            <a:endParaRPr lang="en-US" dirty="0">
+              <a:solidFill>
+                <a:schemeClr val="bg1"/>
+              </a:solidFill>
+            </a:endParaRPr>
+          </a:p>
+        </p:txBody>
+      </p:sp>
+      <mc:AlternateContent xmlns:mc="http://schemas.openxmlformats.org/markup-compatibility/2006">
+        <mc:Choice xmlns:a14="http://schemas.microsoft.com/office/drawing/2010/main" Requires="a14">
+          <p:sp>
+            <p:nvSpPr>
+              <p:cNvPr id="16" name="Rectangle 15">
+                <a:extLst>
+                  <a:ext uri="{FF2B5EF4-FFF2-40B4-BE49-F238E27FC236}">
+                    <a16:creationId xmlns:a16="http://schemas.microsoft.com/office/drawing/2014/main" id="{F01CE6F3-FCC5-6BE1-F3C1-CA0B64C464B2}"/>
+                  </a:ext>
+                </a:extLst>
+              </p:cNvPr>
+              <p:cNvSpPr/>
+              <p:nvPr/>
+            </p:nvSpPr>
+            <p:spPr>
+              <a:xfrm>
+                <a:off x="849085" y="5179518"/>
+                <a:ext cx="8697686" cy="919581"/>
+              </a:xfrm>
+              <a:prstGeom prst="rect">
+                <a:avLst/>
+              </a:prstGeom>
+              <a:solidFill>
+                <a:schemeClr val="bg1"/>
+              </a:solidFill>
+            </p:spPr>
+            <p:style>
+              <a:lnRef idx="2">
+                <a:schemeClr val="accent1">
+                  <a:shade val="15000"/>
+                </a:schemeClr>
+              </a:lnRef>
+              <a:fillRef idx="1">
+                <a:schemeClr val="accent1"/>
+              </a:fillRef>
+              <a:effectRef idx="0">
+                <a:schemeClr val="accent1"/>
+              </a:effectRef>
+              <a:fontRef idx="minor">
+                <a:schemeClr val="lt1"/>
+              </a:fontRef>
+            </p:style>
+            <p:txBody>
+              <a:bodyPr rtlCol="0" anchor="ctr"/>
+              <a:lstStyle/>
+              <a:p>
+                <a:pPr>
+                  <a:lnSpc>
+                    <a:spcPct val="115000"/>
+                  </a:lnSpc>
+                </a:pPr>
+                <a14:m>
+                  <m:oMath xmlns:m="http://schemas.openxmlformats.org/officeDocument/2006/math">
+                    <m:sSub>
+                      <m:sSubPr>
+                        <m:ctrlPr>
+                          <a:rPr lang="fr-FR" b="1" i="1">
+                            <a:solidFill>
+                              <a:schemeClr val="tx1"/>
+                            </a:solidFill>
+                            <a:latin typeface="Cambria Math" panose="02040503050406030204" pitchFamily="18" charset="0"/>
+                          </a:rPr>
+                        </m:ctrlPr>
+                      </m:sSubPr>
+                      <m:e>
+                        <m:r>
+                          <a:rPr lang="fr-FR" b="1" i="1">
+                            <a:solidFill>
+                              <a:schemeClr val="tx1"/>
+                            </a:solidFill>
+                            <a:latin typeface="Cambria Math" panose="02040503050406030204" pitchFamily="18" charset="0"/>
+                          </a:rPr>
+                          <m:t>𝑹</m:t>
+                        </m:r>
+                      </m:e>
+                      <m:sub>
+                        <m:r>
+                          <a:rPr lang="fr-FR" b="1" i="1">
+                            <a:solidFill>
+                              <a:schemeClr val="tx1"/>
+                            </a:solidFill>
+                            <a:latin typeface="Cambria Math" panose="02040503050406030204" pitchFamily="18" charset="0"/>
+                          </a:rPr>
+                          <m:t>𝝅</m:t>
+                        </m:r>
+                      </m:sub>
+                    </m:sSub>
+                  </m:oMath>
+                </a14:m>
+                <a:r>
+                  <a:rPr lang="en-US" dirty="0">
+                    <a:solidFill>
+                      <a:schemeClr val="tx1"/>
+                    </a:solidFill>
+                    <a:latin typeface="Cambria Math" pitchFamily="34" charset="0"/>
+                    <a:ea typeface="Cambria Math" pitchFamily="34" charset="-122"/>
+                    <a:cs typeface="Cambria Math" pitchFamily="34" charset="-120"/>
+                  </a:rPr>
+                  <a:t>(</a:t>
+                </a:r>
+                <a14:m>
+                  <m:oMath xmlns:m="http://schemas.openxmlformats.org/officeDocument/2006/math">
+                    <m:r>
+                      <a:rPr lang="en-US" i="1" dirty="0" smtClean="0">
+                        <a:solidFill>
+                          <a:schemeClr val="tx1"/>
+                        </a:solidFill>
+                        <a:latin typeface="Cambria Math" panose="02040503050406030204" pitchFamily="18" charset="0"/>
+                        <a:ea typeface="Cambria Math" pitchFamily="34" charset="-122"/>
+                      </a:rPr>
+                      <m:t>𝜆</m:t>
+                    </m:r>
+                  </m:oMath>
+                </a14:m>
+                <a:r>
+                  <a:rPr lang="en-US" dirty="0">
+                    <a:solidFill>
+                      <a:schemeClr val="tx1"/>
+                    </a:solidFill>
+                    <a:latin typeface="Cambria Math" pitchFamily="34" charset="0"/>
+                    <a:ea typeface="Cambria Math" pitchFamily="34" charset="-122"/>
+                    <a:cs typeface="Cambria Math" pitchFamily="34" charset="-120"/>
+                  </a:rPr>
+                  <a:t>A,P) =</a:t>
+                </a:r>
+                <a14:m>
+                  <m:oMath xmlns:m="http://schemas.openxmlformats.org/officeDocument/2006/math">
+                    <m:sSub>
+                      <m:sSubPr>
+                        <m:ctrlPr>
+                          <a:rPr lang="en-US" i="1" dirty="0">
+                            <a:solidFill>
+                              <a:schemeClr val="tx1"/>
+                            </a:solidFill>
+                            <a:latin typeface="Cambria Math" panose="02040503050406030204" pitchFamily="18" charset="0"/>
+                          </a:rPr>
+                        </m:ctrlPr>
+                      </m:sSubPr>
+                      <m:e>
+                        <m:r>
+                          <a:rPr lang="en-US" i="1" dirty="0">
+                            <a:solidFill>
+                              <a:schemeClr val="tx1"/>
+                            </a:solidFill>
+                            <a:latin typeface="Cambria Math" panose="02040503050406030204" pitchFamily="18" charset="0"/>
+                          </a:rPr>
+                          <m:t>𝑘</m:t>
+                        </m:r>
+                      </m:e>
+                      <m:sub>
+                        <m:r>
+                          <a:rPr lang="en-US" i="0" dirty="0">
+                            <a:solidFill>
+                              <a:schemeClr val="tx1"/>
+                            </a:solidFill>
+                            <a:latin typeface="Cambria Math" panose="02040503050406030204" pitchFamily="18" charset="0"/>
+                          </a:rPr>
+                          <m:t>1</m:t>
+                        </m:r>
+                      </m:sub>
+                    </m:sSub>
+                    <m:r>
+                      <a:rPr lang="en-US" i="0" dirty="0">
+                        <a:solidFill>
+                          <a:schemeClr val="tx1"/>
+                        </a:solidFill>
+                        <a:latin typeface="Cambria Math" panose="02040503050406030204" pitchFamily="18" charset="0"/>
+                      </a:rPr>
+                      <m:t>+</m:t>
+                    </m:r>
+                    <m:f>
+                      <m:fPr>
+                        <m:ctrlPr>
+                          <a:rPr lang="en-US" i="1" dirty="0">
+                            <a:solidFill>
+                              <a:schemeClr val="tx1"/>
+                            </a:solidFill>
+                            <a:latin typeface="Cambria Math" panose="02040503050406030204" pitchFamily="18" charset="0"/>
+                          </a:rPr>
+                        </m:ctrlPr>
+                      </m:fPr>
+                      <m:num>
+                        <m:sSub>
+                          <m:sSubPr>
+                            <m:ctrlPr>
+                              <a:rPr lang="en-US" i="1" dirty="0">
+                                <a:solidFill>
+                                  <a:schemeClr val="tx1"/>
+                                </a:solidFill>
+                                <a:latin typeface="Cambria Math" panose="02040503050406030204" pitchFamily="18" charset="0"/>
+                              </a:rPr>
+                            </m:ctrlPr>
+                          </m:sSubPr>
+                          <m:e>
+                            <m:r>
+                              <a:rPr lang="en-US" i="1" dirty="0">
+                                <a:solidFill>
+                                  <a:schemeClr val="tx1"/>
+                                </a:solidFill>
+                                <a:latin typeface="Cambria Math" panose="02040503050406030204" pitchFamily="18" charset="0"/>
+                              </a:rPr>
+                              <m:t>𝑘</m:t>
+                            </m:r>
+                          </m:e>
+                          <m:sub>
+                            <m:r>
+                              <a:rPr lang="en-US" i="0" dirty="0">
+                                <a:solidFill>
+                                  <a:schemeClr val="tx1"/>
+                                </a:solidFill>
+                                <a:latin typeface="Cambria Math" panose="02040503050406030204" pitchFamily="18" charset="0"/>
+                              </a:rPr>
+                              <m:t>2</m:t>
+                            </m:r>
+                          </m:sub>
+                        </m:sSub>
+                      </m:num>
+                      <m:den>
+                        <m:sSup>
+                          <m:sSupPr>
+                            <m:ctrlPr>
+                              <a:rPr lang="en-US" i="1" dirty="0">
+                                <a:solidFill>
+                                  <a:schemeClr val="tx1"/>
+                                </a:solidFill>
+                                <a:latin typeface="Cambria Math" panose="02040503050406030204" pitchFamily="18" charset="0"/>
+                              </a:rPr>
+                            </m:ctrlPr>
+                          </m:sSupPr>
+                          <m:e>
+                            <m:r>
+                              <a:rPr lang="en-US" i="1" dirty="0">
+                                <a:solidFill>
+                                  <a:schemeClr val="tx1"/>
+                                </a:solidFill>
+                                <a:latin typeface="Cambria Math" panose="02040503050406030204" pitchFamily="18" charset="0"/>
+                              </a:rPr>
+                              <m:t>𝜆</m:t>
+                            </m:r>
+                          </m:e>
+                          <m:sup>
+                            <m:r>
+                              <a:rPr lang="en-US" i="1" dirty="0">
+                                <a:solidFill>
+                                  <a:schemeClr val="tx1"/>
+                                </a:solidFill>
+                                <a:latin typeface="Cambria Math" panose="02040503050406030204" pitchFamily="18" charset="0"/>
+                              </a:rPr>
+                              <m:t>𝛼</m:t>
+                            </m:r>
+                          </m:sup>
+                        </m:sSup>
+                      </m:den>
+                    </m:f>
+                    <m:r>
+                      <a:rPr lang="en-US" i="0" dirty="0">
+                        <a:solidFill>
+                          <a:schemeClr val="tx1"/>
+                        </a:solidFill>
+                        <a:latin typeface="Cambria Math" panose="02040503050406030204" pitchFamily="18" charset="0"/>
+                      </a:rPr>
+                      <m:t>+</m:t>
+                    </m:r>
+                    <m:r>
+                      <a:rPr lang="en-US" i="1" dirty="0">
+                        <a:solidFill>
+                          <a:schemeClr val="tx1"/>
+                        </a:solidFill>
+                        <a:latin typeface="Cambria Math" panose="02040503050406030204" pitchFamily="18" charset="0"/>
+                      </a:rPr>
+                      <m:t>𝑂</m:t>
+                    </m:r>
+                    <m:d>
+                      <m:dPr>
+                        <m:ctrlPr>
+                          <a:rPr lang="en-US" i="1" dirty="0">
+                            <a:solidFill>
+                              <a:schemeClr val="tx1"/>
+                            </a:solidFill>
+                            <a:latin typeface="Cambria Math" panose="02040503050406030204" pitchFamily="18" charset="0"/>
+                          </a:rPr>
+                        </m:ctrlPr>
+                      </m:dPr>
+                      <m:e>
+                        <m:f>
+                          <m:fPr>
+                            <m:ctrlPr>
+                              <a:rPr lang="en-US" i="0" dirty="0">
+                                <a:solidFill>
+                                  <a:schemeClr val="tx1"/>
+                                </a:solidFill>
+                                <a:latin typeface="Cambria Math" panose="02040503050406030204" pitchFamily="18" charset="0"/>
+                              </a:rPr>
+                            </m:ctrlPr>
+                          </m:fPr>
+                          <m:num>
+                            <m:r>
+                              <a:rPr lang="en-US" i="0" dirty="0">
+                                <a:solidFill>
+                                  <a:schemeClr val="tx1"/>
+                                </a:solidFill>
+                                <a:latin typeface="Cambria Math" panose="02040503050406030204" pitchFamily="18" charset="0"/>
+                              </a:rPr>
+                              <m:t>1</m:t>
+                            </m:r>
+                          </m:num>
+                          <m:den>
+                            <m:sSup>
+                              <m:sSupPr>
+                                <m:ctrlPr>
+                                  <a:rPr lang="en-US" i="1" dirty="0">
+                                    <a:solidFill>
+                                      <a:schemeClr val="tx1"/>
+                                    </a:solidFill>
+                                    <a:latin typeface="Cambria Math" panose="02040503050406030204" pitchFamily="18" charset="0"/>
+                                  </a:rPr>
+                                </m:ctrlPr>
+                              </m:sSupPr>
+                              <m:e>
+                                <m:r>
+                                  <a:rPr lang="en-US" i="1" dirty="0">
+                                    <a:solidFill>
+                                      <a:schemeClr val="tx1"/>
+                                    </a:solidFill>
+                                    <a:latin typeface="Cambria Math" panose="02040503050406030204" pitchFamily="18" charset="0"/>
+                                  </a:rPr>
+                                  <m:t>𝜆</m:t>
+                                </m:r>
+                              </m:e>
+                              <m:sup>
+                                <m:r>
+                                  <a:rPr lang="en-US" i="1" dirty="0">
+                                    <a:solidFill>
+                                      <a:schemeClr val="tx1"/>
+                                    </a:solidFill>
+                                    <a:latin typeface="Cambria Math" panose="02040503050406030204" pitchFamily="18" charset="0"/>
+                                  </a:rPr>
+                                  <m:t>𝛼</m:t>
+                                </m:r>
+                              </m:sup>
+                            </m:sSup>
+                          </m:den>
+                        </m:f>
+                      </m:e>
+                    </m:d>
+                    <m:r>
+                      <a:rPr lang="fr-FR" b="0" i="0" dirty="0" smtClean="0">
+                        <a:solidFill>
+                          <a:schemeClr val="tx1"/>
+                        </a:solidFill>
+                        <a:latin typeface="Cambria Math" panose="02040503050406030204" pitchFamily="18" charset="0"/>
+                      </a:rPr>
+                      <m:t>, </m:t>
+                    </m:r>
+                    <m:r>
+                      <m:rPr>
+                        <m:sty m:val="p"/>
+                      </m:rPr>
+                      <a:rPr lang="fr-FR" b="0" i="0" dirty="0" smtClean="0">
+                        <a:solidFill>
+                          <a:schemeClr val="tx1"/>
+                        </a:solidFill>
+                        <a:latin typeface="Cambria Math" panose="02040503050406030204" pitchFamily="18" charset="0"/>
+                      </a:rPr>
+                      <m:t>lorsque</m:t>
+                    </m:r>
+                    <m:r>
+                      <a:rPr lang="fr-FR" b="0" i="0" dirty="0" smtClean="0">
+                        <a:solidFill>
+                          <a:schemeClr val="tx1"/>
+                        </a:solidFill>
+                        <a:latin typeface="Cambria Math" panose="02040503050406030204" pitchFamily="18" charset="0"/>
+                      </a:rPr>
+                      <m:t> </m:t>
+                    </m:r>
+                    <m:r>
+                      <a:rPr lang="en-US" i="1" dirty="0" smtClean="0">
+                        <a:solidFill>
+                          <a:schemeClr val="tx1"/>
+                        </a:solidFill>
+                        <a:latin typeface="Cambria Math" panose="02040503050406030204" pitchFamily="18" charset="0"/>
+                      </a:rPr>
+                      <m:t>𝜆</m:t>
+                    </m:r>
+                    <m:r>
+                      <a:rPr lang="en-US" i="0" dirty="0">
+                        <a:solidFill>
+                          <a:schemeClr val="tx1"/>
+                        </a:solidFill>
+                        <a:latin typeface="Cambria Math" panose="02040503050406030204" pitchFamily="18" charset="0"/>
+                      </a:rPr>
+                      <m:t>→∞</m:t>
+                    </m:r>
+                  </m:oMath>
+                </a14:m>
+                <a:r>
+                  <a:rPr lang="en-US" dirty="0">
+                    <a:solidFill>
+                      <a:schemeClr val="tx1"/>
+                    </a:solidFill>
+                  </a:rPr>
+                  <a:t>.</a:t>
+                </a:r>
+              </a:p>
+              <a:p>
+                <a:pPr>
+                  <a:lnSpc>
+                    <a:spcPct val="115000"/>
+                  </a:lnSpc>
+                </a:pPr>
+                <a:r>
+                  <a:rPr lang="en-US" dirty="0" err="1">
+                    <a:solidFill>
+                      <a:schemeClr val="tx1"/>
+                    </a:solidFill>
+                    <a:latin typeface="Calibri" pitchFamily="34" charset="0"/>
+                    <a:ea typeface="Calibri" pitchFamily="34" charset="-122"/>
+                    <a:cs typeface="Calibri" pitchFamily="34" charset="-120"/>
+                  </a:rPr>
+                  <a:t>Décrit</a:t>
+                </a:r>
+                <a:r>
+                  <a:rPr lang="en-US" dirty="0">
+                    <a:solidFill>
+                      <a:schemeClr val="tx1"/>
+                    </a:solidFill>
+                    <a:latin typeface="Calibri" pitchFamily="34" charset="0"/>
+                    <a:ea typeface="Calibri" pitchFamily="34" charset="-122"/>
+                    <a:cs typeface="Calibri" pitchFamily="34" charset="-120"/>
+                  </a:rPr>
+                  <a:t> la </a:t>
+                </a:r>
+                <a:r>
+                  <a:rPr lang="en-US" dirty="0" err="1">
+                    <a:solidFill>
+                      <a:schemeClr val="tx1"/>
+                    </a:solidFill>
+                    <a:latin typeface="Calibri" pitchFamily="34" charset="0"/>
+                    <a:ea typeface="Calibri" pitchFamily="34" charset="-122"/>
+                    <a:cs typeface="Calibri" pitchFamily="34" charset="-120"/>
+                  </a:rPr>
+                  <a:t>vitesse</a:t>
+                </a:r>
+                <a:r>
+                  <a:rPr lang="en-US" dirty="0">
+                    <a:solidFill>
+                      <a:schemeClr val="tx1"/>
+                    </a:solidFill>
+                    <a:latin typeface="Calibri" pitchFamily="34" charset="0"/>
+                    <a:ea typeface="Calibri" pitchFamily="34" charset="-122"/>
+                    <a:cs typeface="Calibri" pitchFamily="34" charset="-120"/>
+                  </a:rPr>
+                  <a:t> de convergence du risque </a:t>
+                </a:r>
+                <a:r>
+                  <a:rPr lang="en-US" dirty="0" err="1">
+                    <a:solidFill>
+                      <a:schemeClr val="tx1"/>
+                    </a:solidFill>
+                    <a:latin typeface="Calibri" pitchFamily="34" charset="0"/>
+                    <a:ea typeface="Calibri" pitchFamily="34" charset="-122"/>
+                    <a:cs typeface="Calibri" pitchFamily="34" charset="-120"/>
+                  </a:rPr>
+                  <a:t>quand</a:t>
+                </a:r>
+                <a:r>
+                  <a:rPr lang="en-US" dirty="0">
+                    <a:solidFill>
+                      <a:schemeClr val="tx1"/>
+                    </a:solidFill>
+                    <a:latin typeface="Calibri" pitchFamily="34" charset="0"/>
+                    <a:ea typeface="Calibri" pitchFamily="34" charset="-122"/>
+                    <a:cs typeface="Calibri" pitchFamily="34" charset="-120"/>
+                  </a:rPr>
+                  <a:t> la région </a:t>
+                </a:r>
+                <a:r>
+                  <a:rPr lang="en-US" dirty="0" err="1">
+                    <a:solidFill>
+                      <a:schemeClr val="tx1"/>
+                    </a:solidFill>
+                    <a:latin typeface="Calibri" pitchFamily="34" charset="0"/>
+                    <a:ea typeface="Calibri" pitchFamily="34" charset="-122"/>
+                    <a:cs typeface="Calibri" pitchFamily="34" charset="-120"/>
+                  </a:rPr>
+                  <a:t>s'agrandit</a:t>
+                </a:r>
+                <a:r>
+                  <a:rPr lang="en-US" dirty="0">
+                    <a:solidFill>
+                      <a:schemeClr val="tx1"/>
+                    </a:solidFill>
+                    <a:latin typeface="Calibri" pitchFamily="34" charset="0"/>
+                    <a:ea typeface="Calibri" pitchFamily="34" charset="-122"/>
+                    <a:cs typeface="Calibri" pitchFamily="34" charset="-120"/>
+                  </a:rPr>
+                  <a:t> (λ → ∞).</a:t>
+                </a:r>
+                <a:endParaRPr lang="en-US" dirty="0">
+                  <a:solidFill>
+                    <a:schemeClr val="tx1"/>
+                  </a:solidFill>
+                </a:endParaRPr>
+              </a:p>
+            </p:txBody>
+          </p:sp>
+        </mc:Choice>
+        <mc:Fallback>
+          <p:sp>
+            <p:nvSpPr>
+              <p:cNvPr id="16" name="Rectangle 15">
+                <a:extLst>
+                  <a:ext uri="{FF2B5EF4-FFF2-40B4-BE49-F238E27FC236}">
+                    <a16:creationId xmlns:a16="http://schemas.microsoft.com/office/drawing/2014/main" id="{F01CE6F3-FCC5-6BE1-F3C1-CA0B64C464B2}"/>
+                  </a:ext>
+                </a:extLst>
+              </p:cNvPr>
+              <p:cNvSpPr>
+                <a:spLocks noRot="1" noChangeAspect="1" noMove="1" noResize="1" noEditPoints="1" noAdjustHandles="1" noChangeArrowheads="1" noChangeShapeType="1" noTextEdit="1"/>
+              </p:cNvSpPr>
+              <p:nvPr/>
+            </p:nvSpPr>
+            <p:spPr>
+              <a:xfrm>
+                <a:off x="849085" y="5179518"/>
+                <a:ext cx="8697686" cy="919581"/>
+              </a:xfrm>
+              <a:prstGeom prst="rect">
+                <a:avLst/>
+              </a:prstGeom>
+              <a:blipFill>
+                <a:blip r:embed="rId6"/>
+                <a:stretch>
+                  <a:fillRect l="-490" b="-5195"/>
+                </a:stretch>
+              </a:blipFill>
+            </p:spPr>
+            <p:txBody>
+              <a:bodyPr/>
+              <a:lstStyle/>
+              <a:p>
+                <a:r>
+                  <a:rPr lang="fr-FR">
+                    <a:noFill/>
+                  </a:rPr>
+                  <a:t> </a:t>
+                </a:r>
+              </a:p>
+            </p:txBody>
+          </p:sp>
+        </mc:Fallback>
+      </mc:AlternateContent>
+    </p:spTree>
+    <p:extLst>
+      <p:ext uri="{BB962C8B-B14F-4D97-AF65-F5344CB8AC3E}">
+        <p14:creationId xmlns:p14="http://schemas.microsoft.com/office/powerpoint/2010/main" val="1522245764"/>
+      </p:ext>
+    </p:extLst>
+  </p:cSld>
+  <p:clrMapOvr>
+    <a:masterClrMapping/>
+  </p:clrMapOvr>
+</p:sld>
+</file>
+
+<file path=ppt/slides/slide6.xml><?xml version="1.0" encoding="utf-8"?>
+<p:sld xmlns:a="http://schemas.openxmlformats.org/drawingml/2006/main" xmlns:r="http://schemas.openxmlformats.org/officeDocument/2006/relationships" xmlns:p="http://schemas.openxmlformats.org/presentationml/2006/main">
+  <p:cSld>
+    <p:spTree>
+      <p:nvGrpSpPr>
+        <p:cNvPr id="1" name="">
+          <a:extLst>
+            <a:ext uri="{FF2B5EF4-FFF2-40B4-BE49-F238E27FC236}">
+              <a16:creationId xmlns:a16="http://schemas.microsoft.com/office/drawing/2014/main" id="{DB9F03EA-4ED2-FD89-3C2B-03C9413463D7}"/>
+            </a:ext>
+          </a:extLst>
+        </p:cNvPr>
+        <p:cNvGrpSpPr/>
+        <p:nvPr/>
+      </p:nvGrpSpPr>
+      <p:grpSpPr>
+        <a:xfrm>
+          <a:off x="0" y="0"/>
+          <a:ext cx="0" cy="0"/>
+          <a:chOff x="0" y="0"/>
+          <a:chExt cx="0" cy="0"/>
+        </a:xfrm>
+      </p:grpSpPr>
+      <p:sp>
+        <p:nvSpPr>
+          <p:cNvPr id="3" name="Rectangle 2">
+            <a:extLst>
+              <a:ext uri="{FF2B5EF4-FFF2-40B4-BE49-F238E27FC236}">
+                <a16:creationId xmlns:a16="http://schemas.microsoft.com/office/drawing/2014/main" id="{51E8A7A1-62B0-511F-6158-1128DE6CBFA4}"/>
+              </a:ext>
+            </a:extLst>
+          </p:cNvPr>
+          <p:cNvSpPr/>
+          <p:nvPr/>
+        </p:nvSpPr>
+        <p:spPr>
+          <a:xfrm>
+            <a:off x="0" y="0"/>
+            <a:ext cx="12192000" cy="708091"/>
+          </a:xfrm>
+          <a:prstGeom prst="rect">
+            <a:avLst/>
+          </a:prstGeom>
+        </p:spPr>
+        <p:style>
+          <a:lnRef idx="2">
+            <a:schemeClr val="accent1">
+              <a:shade val="15000"/>
+            </a:schemeClr>
+          </a:lnRef>
+          <a:fillRef idx="1">
+            <a:schemeClr val="accent1"/>
+          </a:fillRef>
+          <a:effectRef idx="0">
+            <a:schemeClr val="accent1"/>
+          </a:effectRef>
+          <a:fontRef idx="minor">
+            <a:schemeClr val="lt1"/>
+          </a:fontRef>
+        </p:style>
+        <p:txBody>
+          <a:bodyPr rtlCol="0" anchor="ctr"/>
+          <a:lstStyle/>
+          <a:p>
+            <a:r>
+              <a:rPr lang="fr-FR" sz="2800" dirty="0"/>
+              <a:t>MESURE DE RISQUE SPATIAL</a:t>
+            </a:r>
+          </a:p>
+        </p:txBody>
+      </p:sp>
+      <p:sp>
+        <p:nvSpPr>
+          <p:cNvPr id="7" name="Rectangle 6">
+            <a:extLst>
+              <a:ext uri="{FF2B5EF4-FFF2-40B4-BE49-F238E27FC236}">
+                <a16:creationId xmlns:a16="http://schemas.microsoft.com/office/drawing/2014/main" id="{F12E02D4-64B8-E9AA-318A-57D69EAADC2C}"/>
+              </a:ext>
+            </a:extLst>
+          </p:cNvPr>
+          <p:cNvSpPr/>
+          <p:nvPr/>
+        </p:nvSpPr>
+        <p:spPr>
+          <a:xfrm>
+            <a:off x="620485" y="1665513"/>
+            <a:ext cx="10308771" cy="3548744"/>
+          </a:xfrm>
+          <a:prstGeom prst="rect">
+            <a:avLst/>
+          </a:prstGeom>
+          <a:solidFill>
+            <a:schemeClr val="bg1"/>
+          </a:solidFill>
+        </p:spPr>
+        <p:style>
+          <a:lnRef idx="2">
+            <a:schemeClr val="accent1">
+              <a:shade val="15000"/>
+            </a:schemeClr>
+          </a:lnRef>
+          <a:fillRef idx="1">
+            <a:schemeClr val="accent1"/>
+          </a:fillRef>
+          <a:effectRef idx="0">
+            <a:schemeClr val="accent1"/>
+          </a:effectRef>
+          <a:fontRef idx="minor">
+            <a:schemeClr val="lt1"/>
+          </a:fontRef>
+        </p:style>
+        <p:txBody>
+          <a:bodyPr rtlCol="0" anchor="ctr"/>
+          <a:lstStyle/>
+          <a:p>
+            <a:pPr>
+              <a:spcAft>
+                <a:spcPts val="1600"/>
+              </a:spcAft>
+              <a:buSzPct val="100000"/>
+            </a:pPr>
+            <a:r>
+              <a:rPr lang="en-US" sz="3600" b="1" dirty="0">
+                <a:solidFill>
+                  <a:schemeClr val="tx1"/>
+                </a:solidFill>
+                <a:latin typeface="Cambria Math" pitchFamily="34" charset="0"/>
+                <a:ea typeface="Cambria Math" pitchFamily="34" charset="-122"/>
+                <a:cs typeface="Cambria Math" pitchFamily="34" charset="-120"/>
+              </a:rPr>
+              <a:t>        Cₚ(x) = E(x) · D( Z(x) )</a:t>
+            </a:r>
+          </a:p>
+          <a:p>
+            <a:pPr marL="457200" indent="-457200">
+              <a:spcAft>
+                <a:spcPts val="1600"/>
+              </a:spcAft>
+              <a:buSzPct val="100000"/>
+              <a:buFont typeface="Arial" panose="020B0604020202020204" pitchFamily="34" charset="0"/>
+              <a:buChar char="•"/>
+            </a:pPr>
+            <a:r>
+              <a:rPr lang="en-US" sz="2800" b="1" dirty="0">
+                <a:solidFill>
+                  <a:schemeClr val="tx1"/>
+                </a:solidFill>
+                <a:latin typeface="Cambria Math" pitchFamily="34" charset="0"/>
+                <a:ea typeface="Cambria Math" pitchFamily="34" charset="-122"/>
+                <a:cs typeface="Cambria Math" pitchFamily="34" charset="-120"/>
+              </a:rPr>
+              <a:t>E(x) : </a:t>
+            </a:r>
+            <a:r>
+              <a:rPr lang="en-US" sz="2400" dirty="0">
+                <a:solidFill>
+                  <a:schemeClr val="tx1"/>
+                </a:solidFill>
+                <a:latin typeface="Cambria Math" pitchFamily="34" charset="0"/>
+                <a:ea typeface="Cambria Math" pitchFamily="34" charset="-122"/>
+                <a:cs typeface="Cambria Math" pitchFamily="34" charset="-120"/>
+              </a:rPr>
+              <a:t>exposition;</a:t>
+            </a:r>
+          </a:p>
+          <a:p>
+            <a:pPr marL="457200" indent="-457200">
+              <a:spcAft>
+                <a:spcPts val="1600"/>
+              </a:spcAft>
+              <a:buSzPct val="100000"/>
+              <a:buFont typeface="Arial" panose="020B0604020202020204" pitchFamily="34" charset="0"/>
+              <a:buChar char="•"/>
+            </a:pPr>
+            <a:r>
+              <a:rPr lang="en-US" sz="2800" b="1" dirty="0">
+                <a:solidFill>
+                  <a:schemeClr val="tx1"/>
+                </a:solidFill>
+                <a:latin typeface="Cambria Math" pitchFamily="34" charset="0"/>
+                <a:ea typeface="Cambria Math" pitchFamily="34" charset="-122"/>
+                <a:cs typeface="Cambria Math" pitchFamily="34" charset="-120"/>
+              </a:rPr>
+              <a:t>D</a:t>
+            </a:r>
+            <a:r>
+              <a:rPr lang="en-US" sz="2400" b="1" dirty="0">
+                <a:solidFill>
+                  <a:schemeClr val="tx1"/>
+                </a:solidFill>
+                <a:latin typeface="Cambria Math" pitchFamily="34" charset="0"/>
+                <a:ea typeface="Cambria Math" pitchFamily="34" charset="-122"/>
+                <a:cs typeface="Cambria Math" pitchFamily="34" charset="-120"/>
+              </a:rPr>
+              <a:t>(</a:t>
+            </a:r>
+            <a:r>
+              <a:rPr lang="en-US" sz="2800" b="1" dirty="0">
+                <a:solidFill>
+                  <a:schemeClr val="tx1"/>
+                </a:solidFill>
+                <a:latin typeface="Cambria Math" pitchFamily="34" charset="0"/>
+                <a:ea typeface="Cambria Math" pitchFamily="34" charset="-122"/>
+                <a:cs typeface="Cambria Math" pitchFamily="34" charset="-120"/>
+              </a:rPr>
+              <a:t>x</a:t>
+            </a:r>
+            <a:r>
+              <a:rPr lang="en-US" sz="2400" b="1" dirty="0">
+                <a:solidFill>
+                  <a:schemeClr val="tx1"/>
+                </a:solidFill>
+                <a:latin typeface="Cambria Math" pitchFamily="34" charset="0"/>
+                <a:ea typeface="Cambria Math" pitchFamily="34" charset="-122"/>
+                <a:cs typeface="Cambria Math" pitchFamily="34" charset="-120"/>
+              </a:rPr>
+              <a:t>) : </a:t>
+            </a:r>
+            <a:r>
+              <a:rPr lang="en-US" sz="2400" dirty="0">
+                <a:solidFill>
+                  <a:schemeClr val="tx1"/>
+                </a:solidFill>
+                <a:latin typeface="Cambria Math" pitchFamily="34" charset="0"/>
+                <a:ea typeface="Cambria Math" pitchFamily="34" charset="-122"/>
+                <a:cs typeface="Cambria Math" pitchFamily="34" charset="-120"/>
+              </a:rPr>
+              <a:t>function de </a:t>
+            </a:r>
+            <a:r>
+              <a:rPr lang="en-US" sz="2400" dirty="0" err="1">
+                <a:solidFill>
+                  <a:schemeClr val="tx1"/>
+                </a:solidFill>
+                <a:latin typeface="Cambria Math" pitchFamily="34" charset="0"/>
+                <a:ea typeface="Cambria Math" pitchFamily="34" charset="-122"/>
+                <a:cs typeface="Cambria Math" pitchFamily="34" charset="-120"/>
+              </a:rPr>
+              <a:t>dommage</a:t>
+            </a:r>
+            <a:r>
+              <a:rPr lang="en-US" sz="2400" dirty="0">
+                <a:solidFill>
+                  <a:schemeClr val="tx1"/>
+                </a:solidFill>
+                <a:latin typeface="Cambria Math" pitchFamily="34" charset="0"/>
+                <a:ea typeface="Cambria Math" pitchFamily="34" charset="-122"/>
+                <a:cs typeface="Cambria Math" pitchFamily="34" charset="-120"/>
+              </a:rPr>
+              <a:t>;</a:t>
+            </a:r>
+          </a:p>
+          <a:p>
+            <a:pPr marL="457200" indent="-457200">
+              <a:spcAft>
+                <a:spcPts val="1600"/>
+              </a:spcAft>
+              <a:buSzPct val="100000"/>
+              <a:buFont typeface="Arial" panose="020B0604020202020204" pitchFamily="34" charset="0"/>
+              <a:buChar char="•"/>
+            </a:pPr>
+            <a:r>
+              <a:rPr lang="en-US" sz="2800" b="1" dirty="0">
+                <a:solidFill>
+                  <a:schemeClr val="tx1"/>
+                </a:solidFill>
+                <a:latin typeface="Cambria Math" pitchFamily="34" charset="0"/>
+                <a:ea typeface="Cambria Math" pitchFamily="34" charset="-122"/>
+                <a:cs typeface="Cambria Math" pitchFamily="34" charset="-120"/>
+              </a:rPr>
+              <a:t>Z</a:t>
+            </a:r>
+            <a:r>
+              <a:rPr lang="en-US" sz="2400" b="1" dirty="0">
+                <a:solidFill>
+                  <a:schemeClr val="tx1"/>
+                </a:solidFill>
+                <a:latin typeface="Cambria Math" pitchFamily="34" charset="0"/>
+                <a:ea typeface="Cambria Math" pitchFamily="34" charset="-122"/>
+                <a:cs typeface="Cambria Math" pitchFamily="34" charset="-120"/>
+              </a:rPr>
+              <a:t>(</a:t>
+            </a:r>
+            <a:r>
+              <a:rPr lang="en-US" sz="2800" b="1" dirty="0">
+                <a:solidFill>
+                  <a:schemeClr val="tx1"/>
+                </a:solidFill>
+                <a:latin typeface="Cambria Math" pitchFamily="34" charset="0"/>
+                <a:ea typeface="Cambria Math" pitchFamily="34" charset="-122"/>
+                <a:cs typeface="Cambria Math" pitchFamily="34" charset="-120"/>
+              </a:rPr>
+              <a:t>x</a:t>
+            </a:r>
+            <a:r>
+              <a:rPr lang="en-US" sz="2400" b="1" dirty="0">
+                <a:solidFill>
+                  <a:schemeClr val="tx1"/>
+                </a:solidFill>
+                <a:latin typeface="Cambria Math" pitchFamily="34" charset="0"/>
+                <a:ea typeface="Cambria Math" pitchFamily="34" charset="-122"/>
+                <a:cs typeface="Cambria Math" pitchFamily="34" charset="-120"/>
+              </a:rPr>
+              <a:t>) :</a:t>
+            </a:r>
+            <a:r>
+              <a:rPr lang="en-US" sz="2400" dirty="0">
+                <a:solidFill>
+                  <a:schemeClr val="tx1"/>
+                </a:solidFill>
+                <a:latin typeface="Cambria Math" pitchFamily="34" charset="0"/>
+                <a:ea typeface="Cambria Math" pitchFamily="34" charset="-122"/>
+                <a:cs typeface="Cambria Math" pitchFamily="34" charset="-120"/>
+              </a:rPr>
+              <a:t> </a:t>
+            </a:r>
+            <a:r>
+              <a:rPr lang="en-US" sz="2400" dirty="0" err="1">
+                <a:solidFill>
+                  <a:schemeClr val="tx1"/>
+                </a:solidFill>
+                <a:latin typeface="Cambria Math" pitchFamily="34" charset="0"/>
+                <a:ea typeface="Cambria Math" pitchFamily="34" charset="-122"/>
+                <a:cs typeface="Cambria Math" pitchFamily="34" charset="-120"/>
+              </a:rPr>
+              <a:t>aléa</a:t>
+            </a:r>
+            <a:r>
+              <a:rPr lang="en-US" sz="2400" dirty="0">
+                <a:solidFill>
+                  <a:schemeClr val="tx1"/>
+                </a:solidFill>
+                <a:latin typeface="Cambria Math" pitchFamily="34" charset="0"/>
+                <a:ea typeface="Cambria Math" pitchFamily="34" charset="-122"/>
+                <a:cs typeface="Cambria Math" pitchFamily="34" charset="-120"/>
+              </a:rPr>
+              <a:t> </a:t>
+            </a:r>
+            <a:r>
+              <a:rPr lang="en-US" sz="2400" dirty="0" err="1">
+                <a:solidFill>
+                  <a:schemeClr val="tx1"/>
+                </a:solidFill>
+                <a:latin typeface="Cambria Math" pitchFamily="34" charset="0"/>
+                <a:ea typeface="Cambria Math" pitchFamily="34" charset="-122"/>
+                <a:cs typeface="Cambria Math" pitchFamily="34" charset="-120"/>
+              </a:rPr>
+              <a:t>environnementaux</a:t>
+            </a:r>
+            <a:endParaRPr lang="en-US" sz="2400" dirty="0">
               <a:solidFill>
                 <a:schemeClr val="tx1"/>
               </a:solidFill>
@@ -5287,10 +9129,58 @@
           </a:p>
         </p:txBody>
       </p:sp>
+      <p:sp>
+        <p:nvSpPr>
+          <p:cNvPr id="8" name="Rectangle : coins arrondis 7">
+            <a:extLst>
+              <a:ext uri="{FF2B5EF4-FFF2-40B4-BE49-F238E27FC236}">
+                <a16:creationId xmlns:a16="http://schemas.microsoft.com/office/drawing/2014/main" id="{61E20970-1556-B15C-0A10-A20E94BF6981}"/>
+              </a:ext>
+            </a:extLst>
+          </p:cNvPr>
+          <p:cNvSpPr/>
+          <p:nvPr/>
+        </p:nvSpPr>
+        <p:spPr>
+          <a:xfrm>
+            <a:off x="620485" y="1208314"/>
+            <a:ext cx="10308771" cy="446834"/>
+          </a:xfrm>
+          <a:prstGeom prst="roundRect">
+            <a:avLst/>
+          </a:prstGeom>
+        </p:spPr>
+        <p:style>
+          <a:lnRef idx="2">
+            <a:schemeClr val="accent1">
+              <a:shade val="15000"/>
+            </a:schemeClr>
+          </a:lnRef>
+          <a:fillRef idx="1">
+            <a:schemeClr val="accent1"/>
+          </a:fillRef>
+          <a:effectRef idx="0">
+            <a:schemeClr val="accent1"/>
+          </a:effectRef>
+          <a:fontRef idx="minor">
+            <a:schemeClr val="lt1"/>
+          </a:fontRef>
+        </p:style>
+        <p:txBody>
+          <a:bodyPr rtlCol="0" anchor="ctr"/>
+          <a:lstStyle/>
+          <a:p>
+            <a:r>
+              <a:rPr lang="fr-FR" sz="2400" dirty="0"/>
+              <a:t>Modèle général du processus de coût</a:t>
+            </a:r>
+          </a:p>
+        </p:txBody>
+      </p:sp>
     </p:spTree>
     <p:extLst>
       <p:ext uri="{BB962C8B-B14F-4D97-AF65-F5344CB8AC3E}">
-        <p14:creationId xmlns:p14="http://schemas.microsoft.com/office/powerpoint/2010/main" val="2024187343"/>
+        <p14:creationId xmlns:p14="http://schemas.microsoft.com/office/powerpoint/2010/main" val="2537610083"/>
       </p:ext>
     </p:extLst>
   </p:cSld>
@@ -5613,4 +9503,319 @@
     </a:ext>
   </a:extLst>
 </a:theme>
+</file>
+
+<file path=ppt/theme/theme2.xml><?xml version="1.0" encoding="utf-8"?>
+<a:theme xmlns:a="http://schemas.openxmlformats.org/drawingml/2006/main" name="Thème Office">
+  <a:themeElements>
+    <a:clrScheme name="Office">
+      <a:dk1>
+        <a:sysClr val="windowText" lastClr="000000"/>
+      </a:dk1>
+      <a:lt1>
+        <a:sysClr val="window" lastClr="FFFFFF"/>
+      </a:lt1>
+      <a:dk2>
+        <a:srgbClr val="0E2841"/>
+      </a:dk2>
+      <a:lt2>
+        <a:srgbClr val="E8E8E8"/>
+      </a:lt2>
+      <a:accent1>
+        <a:srgbClr val="156082"/>
+      </a:accent1>
+      <a:accent2>
+        <a:srgbClr val="E97132"/>
+      </a:accent2>
+      <a:accent3>
+        <a:srgbClr val="196B24"/>
+      </a:accent3>
+      <a:accent4>
+        <a:srgbClr val="0F9ED5"/>
+      </a:accent4>
+      <a:accent5>
+        <a:srgbClr val="A02B93"/>
+      </a:accent5>
+      <a:accent6>
+        <a:srgbClr val="4EA72E"/>
+      </a:accent6>
+      <a:hlink>
+        <a:srgbClr val="467886"/>
+      </a:hlink>
+      <a:folHlink>
+        <a:srgbClr val="96607D"/>
+      </a:folHlink>
+    </a:clrScheme>
+    <a:fontScheme name="Office">
+      <a:majorFont>
+        <a:latin typeface="Aptos Display" panose="02110004020202020204"/>
+        <a:ea typeface=""/>
+        <a:cs typeface=""/>
+        <a:font script="Jpan" typeface="游ゴシック Light"/>
+        <a:font script="Hang" typeface="맑은 고딕"/>
+        <a:font script="Hans" typeface="等线 Light"/>
+        <a:font script="Hant" typeface="新細明體"/>
+        <a:font script="Arab" typeface="Times New Roman"/>
+        <a:font script="Hebr" typeface="Times New Roman"/>
+        <a:font script="Thai" typeface="Angsana New"/>
+        <a:font script="Ethi" typeface="Nyala"/>
+        <a:font script="Beng" typeface="Vrinda"/>
+        <a:font script="Gujr" typeface="Shruti"/>
+        <a:font script="Khmr" typeface="MoolBoran"/>
+        <a:font script="Knda" typeface="Tunga"/>
+        <a:font script="Guru" typeface="Raavi"/>
+        <a:font script="Cans" typeface="Euphemia"/>
+        <a:font script="Cher" typeface="Plantagenet Cherokee"/>
+        <a:font script="Yiii" typeface="Microsoft Yi Baiti"/>
+        <a:font script="Tibt" typeface="Microsoft Himalaya"/>
+        <a:font script="Thaa" typeface="MV Boli"/>
+        <a:font script="Deva" typeface="Mangal"/>
+        <a:font script="Telu" typeface="Gautami"/>
+        <a:font script="Taml" typeface="Latha"/>
+        <a:font script="Syrc" typeface="Estrangelo Edessa"/>
+        <a:font script="Orya" typeface="Kalinga"/>
+        <a:font script="Mlym" typeface="Kartika"/>
+        <a:font script="Laoo" typeface="DokChampa"/>
+        <a:font script="Sinh" typeface="Iskoola Pota"/>
+        <a:font script="Mong" typeface="Mongolian Baiti"/>
+        <a:font script="Viet" typeface="Times New Roman"/>
+        <a:font script="Uigh" typeface="Microsoft Uighur"/>
+        <a:font script="Geor" typeface="Sylfaen"/>
+        <a:font script="Armn" typeface="Arial"/>
+        <a:font script="Bugi" typeface="Leelawadee UI"/>
+        <a:font script="Bopo" typeface="Microsoft JhengHei"/>
+        <a:font script="Java" typeface="Javanese Text"/>
+        <a:font script="Lisu" typeface="Segoe UI"/>
+        <a:font script="Mymr" typeface="Myanmar Text"/>
+        <a:font script="Nkoo" typeface="Ebrima"/>
+        <a:font script="Olck" typeface="Nirmala UI"/>
+        <a:font script="Osma" typeface="Ebrima"/>
+        <a:font script="Phag" typeface="Phagspa"/>
+        <a:font script="Syrn" typeface="Estrangelo Edessa"/>
+        <a:font script="Syrj" typeface="Estrangelo Edessa"/>
+        <a:font script="Syre" typeface="Estrangelo Edessa"/>
+        <a:font script="Sora" typeface="Nirmala UI"/>
+        <a:font script="Tale" typeface="Microsoft Tai Le"/>
+        <a:font script="Talu" typeface="Microsoft New Tai Lue"/>
+        <a:font script="Tfng" typeface="Ebrima"/>
+      </a:majorFont>
+      <a:minorFont>
+        <a:latin typeface="Aptos" panose="02110004020202020204"/>
+        <a:ea typeface=""/>
+        <a:cs typeface=""/>
+        <a:font script="Jpan" typeface="游ゴシック"/>
+        <a:font script="Hang" typeface="맑은 고딕"/>
+        <a:font script="Hans" typeface="等线"/>
+        <a:font script="Hant" typeface="新細明體"/>
+        <a:font script="Arab" typeface="Arial"/>
+        <a:font script="Hebr" typeface="Arial"/>
+        <a:font script="Thai" typeface="Cordia New"/>
+        <a:font script="Ethi" typeface="Nyala"/>
+        <a:font script="Beng" typeface="Vrinda"/>
+        <a:font script="Gujr" typeface="Shruti"/>
+        <a:font script="Khmr" typeface="DaunPenh"/>
+        <a:font script="Knda" typeface="Tunga"/>
+        <a:font script="Guru" typeface="Raavi"/>
+        <a:font script="Cans" typeface="Euphemia"/>
+        <a:font script="Cher" typeface="Plantagenet Cherokee"/>
+        <a:font script="Yiii" typeface="Microsoft Yi Baiti"/>
+        <a:font script="Tibt" typeface="Microsoft Himalaya"/>
+        <a:font script="Thaa" typeface="MV Boli"/>
+        <a:font script="Deva" typeface="Mangal"/>
+        <a:font script="Telu" typeface="Gautami"/>
+        <a:font script="Taml" typeface="Latha"/>
+        <a:font script="Syrc" typeface="Estrangelo Edessa"/>
+        <a:font script="Orya" typeface="Kalinga"/>
+        <a:font script="Mlym" typeface="Kartika"/>
+        <a:font script="Laoo" typeface="DokChampa"/>
+        <a:font script="Sinh" typeface="Iskoola Pota"/>
+        <a:font script="Mong" typeface="Mongolian Baiti"/>
+        <a:font script="Viet" typeface="Arial"/>
+        <a:font script="Uigh" typeface="Microsoft Uighur"/>
+        <a:font script="Geor" typeface="Sylfaen"/>
+        <a:font script="Armn" typeface="Arial"/>
+        <a:font script="Bugi" typeface="Leelawadee UI"/>
+        <a:font script="Bopo" typeface="Microsoft JhengHei"/>
+        <a:font script="Java" typeface="Javanese Text"/>
+        <a:font script="Lisu" typeface="Segoe UI"/>
+        <a:font script="Mymr" typeface="Myanmar Text"/>
+        <a:font script="Nkoo" typeface="Ebrima"/>
+        <a:font script="Olck" typeface="Nirmala UI"/>
+        <a:font script="Osma" typeface="Ebrima"/>
+        <a:font script="Phag" typeface="Phagspa"/>
+        <a:font script="Syrn" typeface="Estrangelo Edessa"/>
+        <a:font script="Syrj" typeface="Estrangelo Edessa"/>
+        <a:font script="Syre" typeface="Estrangelo Edessa"/>
+        <a:font script="Sora" typeface="Nirmala UI"/>
+        <a:font script="Tale" typeface="Microsoft Tai Le"/>
+        <a:font script="Talu" typeface="Microsoft New Tai Lue"/>
+        <a:font script="Tfng" typeface="Ebrima"/>
+      </a:minorFont>
+    </a:fontScheme>
+    <a:fmtScheme name="Office">
+      <a:fillStyleLst>
+        <a:solidFill>
+          <a:schemeClr val="phClr"/>
+        </a:solidFill>
+        <a:gradFill rotWithShape="1">
+          <a:gsLst>
+            <a:gs pos="0">
+              <a:schemeClr val="phClr">
+                <a:lumMod val="110000"/>
+                <a:satMod val="105000"/>
+                <a:tint val="67000"/>
+              </a:schemeClr>
+            </a:gs>
+            <a:gs pos="50000">
+              <a:schemeClr val="phClr">
+                <a:lumMod val="105000"/>
+                <a:satMod val="103000"/>
+                <a:tint val="73000"/>
+              </a:schemeClr>
+            </a:gs>
+            <a:gs pos="100000">
+              <a:schemeClr val="phClr">
+                <a:lumMod val="105000"/>
+                <a:satMod val="109000"/>
+                <a:tint val="81000"/>
+              </a:schemeClr>
+            </a:gs>
+          </a:gsLst>
+          <a:lin ang="5400000" scaled="0"/>
+        </a:gradFill>
+        <a:gradFill rotWithShape="1">
+          <a:gsLst>
+            <a:gs pos="0">
+              <a:schemeClr val="phClr">
+                <a:satMod val="103000"/>
+                <a:lumMod val="102000"/>
+                <a:tint val="94000"/>
+              </a:schemeClr>
+            </a:gs>
+            <a:gs pos="50000">
+              <a:schemeClr val="phClr">
+                <a:satMod val="110000"/>
+                <a:lumMod val="100000"/>
+                <a:shade val="100000"/>
+              </a:schemeClr>
+            </a:gs>
+            <a:gs pos="100000">
+              <a:schemeClr val="phClr">
+                <a:lumMod val="99000"/>
+                <a:satMod val="120000"/>
+                <a:shade val="78000"/>
+              </a:schemeClr>
+            </a:gs>
+          </a:gsLst>
+          <a:lin ang="5400000" scaled="0"/>
+        </a:gradFill>
+      </a:fillStyleLst>
+      <a:lnStyleLst>
+        <a:ln w="12700" cap="flat" cmpd="sng" algn="ctr">
+          <a:solidFill>
+            <a:schemeClr val="phClr"/>
+          </a:solidFill>
+          <a:prstDash val="solid"/>
+          <a:miter lim="800000"/>
+        </a:ln>
+        <a:ln w="19050" cap="flat" cmpd="sng" algn="ctr">
+          <a:solidFill>
+            <a:schemeClr val="phClr"/>
+          </a:solidFill>
+          <a:prstDash val="solid"/>
+          <a:miter lim="800000"/>
+        </a:ln>
+        <a:ln w="25400" cap="flat" cmpd="sng" algn="ctr">
+          <a:solidFill>
+            <a:schemeClr val="phClr"/>
+          </a:solidFill>
+          <a:prstDash val="solid"/>
+          <a:miter lim="800000"/>
+        </a:ln>
+      </a:lnStyleLst>
+      <a:effectStyleLst>
+        <a:effectStyle>
+          <a:effectLst/>
+        </a:effectStyle>
+        <a:effectStyle>
+          <a:effectLst/>
+        </a:effectStyle>
+        <a:effectStyle>
+          <a:effectLst>
+            <a:outerShdw blurRad="57150" dist="19050" dir="5400000" algn="ctr" rotWithShape="0">
+              <a:srgbClr val="000000">
+                <a:alpha val="63000"/>
+              </a:srgbClr>
+            </a:outerShdw>
+          </a:effectLst>
+        </a:effectStyle>
+      </a:effectStyleLst>
+      <a:bgFillStyleLst>
+        <a:solidFill>
+          <a:schemeClr val="phClr"/>
+        </a:solidFill>
+        <a:solidFill>
+          <a:schemeClr val="phClr">
+            <a:tint val="95000"/>
+            <a:satMod val="170000"/>
+          </a:schemeClr>
+        </a:solidFill>
+        <a:gradFill rotWithShape="1">
+          <a:gsLst>
+            <a:gs pos="0">
+              <a:schemeClr val="phClr">
+                <a:tint val="93000"/>
+                <a:satMod val="150000"/>
+                <a:shade val="98000"/>
+                <a:lumMod val="102000"/>
+              </a:schemeClr>
+            </a:gs>
+            <a:gs pos="50000">
+              <a:schemeClr val="phClr">
+                <a:tint val="98000"/>
+                <a:satMod val="130000"/>
+                <a:shade val="90000"/>
+                <a:lumMod val="103000"/>
+              </a:schemeClr>
+            </a:gs>
+            <a:gs pos="100000">
+              <a:schemeClr val="phClr">
+                <a:shade val="63000"/>
+                <a:satMod val="120000"/>
+              </a:schemeClr>
+            </a:gs>
+          </a:gsLst>
+          <a:lin ang="5400000" scaled="0"/>
+        </a:gradFill>
+      </a:bgFillStyleLst>
+    </a:fmtScheme>
+  </a:themeElements>
+  <a:objectDefaults>
+    <a:lnDef>
+      <a:spPr/>
+      <a:bodyPr/>
+      <a:lstStyle/>
+      <a:style>
+        <a:lnRef idx="2">
+          <a:schemeClr val="accent1"/>
+        </a:lnRef>
+        <a:fillRef idx="0">
+          <a:schemeClr val="accent1"/>
+        </a:fillRef>
+        <a:effectRef idx="1">
+          <a:schemeClr val="accent1"/>
+        </a:effectRef>
+        <a:fontRef idx="minor">
+          <a:schemeClr val="tx1"/>
+        </a:fontRef>
+      </a:style>
+    </a:lnDef>
+  </a:objectDefaults>
+  <a:extraClrSchemeLst/>
+  <a:extLst>
+    <a:ext uri="{05A4C25C-085E-4340-85A3-A5531E510DB2}">
+      <thm15:themeFamily xmlns:thm15="http://schemas.microsoft.com/office/thememl/2012/main" name="Office Theme" id="{2E142A2C-CD16-42D6-873A-C26D2A0506FA}" vid="{1BDDFF52-6CD6-40A5-AB3C-68EB2F1E4D0A}"/>
+    </a:ext>
+  </a:extLst>
+</a:theme>
 </file>
</xml_diff>

<commit_message>
Partie coefficient d'extremal ajouté
</commit_message>
<xml_diff>
--- a/pptx/presentation.pptx
+++ b/pptx/presentation.pptx
@@ -8,6 +8,10 @@
     <p:sldId id="257" r:id="rId2"/>
     <p:sldId id="256" r:id="rId3"/>
     <p:sldId id="258" r:id="rId4"/>
+    <p:sldId id="259" r:id="rId5"/>
+    <p:sldId id="260" r:id="rId6"/>
+    <p:sldId id="262" r:id="rId7"/>
+    <p:sldId id="261" r:id="rId8"/>
   </p:sldIdLst>
   <p:sldSz cx="12192000" cy="6858000"/>
   <p:notesSz cx="6858000" cy="9144000"/>
@@ -3427,7 +3431,7 @@
         <p:spPr>
           <a:xfrm>
             <a:off x="2992618" y="2377161"/>
-            <a:ext cx="6810391" cy="954107"/>
+            <a:ext cx="7252819" cy="954107"/>
           </a:xfrm>
           <a:prstGeom prst="rect">
             <a:avLst/>
@@ -3442,13 +3446,13 @@
           <a:p>
             <a:r>
               <a:rPr lang="fr-FR" sz="2800" b="1" dirty="0"/>
-              <a:t>BEYE CHEIKH – KEBE MAMADOU LAMINE</a:t>
+              <a:t>BEYE CHEIKH   –     KEBE MAMADOU LAMINE</a:t>
             </a:r>
           </a:p>
           <a:p>
             <a:r>
               <a:rPr lang="fr-FR" sz="2800" b="1" dirty="0"/>
-              <a:t>KEBE MBAYE – SENE ABDOULAYE </a:t>
+              <a:t>KEBE MBAYE     –      SENE ABDOULAYE </a:t>
             </a:r>
           </a:p>
         </p:txBody>
@@ -3578,8 +3582,8 @@
           <a:chExt cx="0" cy="0"/>
         </a:xfrm>
       </p:grpSpPr>
-      <mc:AlternateContent xmlns:mc="http://schemas.openxmlformats.org/markup-compatibility/2006">
-        <mc:Choice xmlns:a14="http://schemas.microsoft.com/office/drawing/2010/main" Requires="a14">
+      <mc:AlternateContent xmlns:mc="http://schemas.openxmlformats.org/markup-compatibility/2006" xmlns:a14="http://schemas.microsoft.com/office/drawing/2010/main">
+        <mc:Choice Requires="a14">
           <p:sp>
             <p:nvSpPr>
               <p:cNvPr id="2" name="ZoneTexte 1">
@@ -3608,6 +3612,7 @@
               </a:bodyPr>
               <a:lstStyle/>
               <a:p>
+                <a:pPr/>
                 <a14:m>
                   <m:oMathPara xmlns:m="http://schemas.openxmlformats.org/officeDocument/2006/math">
                     <m:oMath>
@@ -3680,7 +3685,7 @@
             </p:txBody>
           </p:sp>
         </mc:Choice>
-        <mc:Fallback>
+        <mc:Fallback xmlns="">
           <p:sp>
             <p:nvSpPr>
               <p:cNvPr id="2" name="ZoneTexte 1">
@@ -4199,8 +4204,8 @@
           </a:p>
         </p:txBody>
       </p:sp>
-      <mc:AlternateContent xmlns:mc="http://schemas.openxmlformats.org/markup-compatibility/2006">
-        <mc:Choice xmlns:a14="http://schemas.microsoft.com/office/drawing/2010/main" Requires="a14">
+      <mc:AlternateContent xmlns:mc="http://schemas.openxmlformats.org/markup-compatibility/2006" xmlns:a14="http://schemas.microsoft.com/office/drawing/2010/main">
+        <mc:Choice Requires="a14">
           <p:sp>
             <p:nvSpPr>
               <p:cNvPr id="7" name="Rectangle 6">
@@ -5001,7 +5006,7 @@
             </p:txBody>
           </p:sp>
         </mc:Choice>
-        <mc:Fallback>
+        <mc:Fallback xmlns="">
           <p:sp>
             <p:nvSpPr>
               <p:cNvPr id="7" name="Rectangle 6">
@@ -5291,6 +5296,2260 @@
     <p:extLst>
       <p:ext uri="{BB962C8B-B14F-4D97-AF65-F5344CB8AC3E}">
         <p14:creationId xmlns:p14="http://schemas.microsoft.com/office/powerpoint/2010/main" val="2024187343"/>
+      </p:ext>
+    </p:extLst>
+  </p:cSld>
+  <p:clrMapOvr>
+    <a:masterClrMapping/>
+  </p:clrMapOvr>
+</p:sld>
+</file>
+
+<file path=ppt/slides/slide4.xml><?xml version="1.0" encoding="utf-8"?>
+<p:sld xmlns:a="http://schemas.openxmlformats.org/drawingml/2006/main" xmlns:r="http://schemas.openxmlformats.org/officeDocument/2006/relationships" xmlns:p="http://schemas.openxmlformats.org/presentationml/2006/main">
+  <p:cSld>
+    <p:spTree>
+      <p:nvGrpSpPr>
+        <p:cNvPr id="1" name="">
+          <a:extLst>
+            <a:ext uri="{FF2B5EF4-FFF2-40B4-BE49-F238E27FC236}">
+              <a16:creationId xmlns:a16="http://schemas.microsoft.com/office/drawing/2014/main" id="{F7BFA7D6-6AF8-BA04-8D8D-8A03CFB0DD41}"/>
+            </a:ext>
+          </a:extLst>
+        </p:cNvPr>
+        <p:cNvGrpSpPr/>
+        <p:nvPr/>
+      </p:nvGrpSpPr>
+      <p:grpSpPr>
+        <a:xfrm>
+          <a:off x="0" y="0"/>
+          <a:ext cx="0" cy="0"/>
+          <a:chOff x="0" y="0"/>
+          <a:chExt cx="0" cy="0"/>
+        </a:xfrm>
+      </p:grpSpPr>
+      <p:sp>
+        <p:nvSpPr>
+          <p:cNvPr id="3" name="Rectangle 2">
+            <a:extLst>
+              <a:ext uri="{FF2B5EF4-FFF2-40B4-BE49-F238E27FC236}">
+                <a16:creationId xmlns:a16="http://schemas.microsoft.com/office/drawing/2014/main" id="{60A07869-8A3B-E19E-E10E-9A9C619038C3}"/>
+              </a:ext>
+            </a:extLst>
+          </p:cNvPr>
+          <p:cNvSpPr/>
+          <p:nvPr/>
+        </p:nvSpPr>
+        <p:spPr>
+          <a:xfrm>
+            <a:off x="0" y="0"/>
+            <a:ext cx="12192000" cy="708091"/>
+          </a:xfrm>
+          <a:prstGeom prst="rect">
+            <a:avLst/>
+          </a:prstGeom>
+        </p:spPr>
+        <p:style>
+          <a:lnRef idx="2">
+            <a:schemeClr val="accent1">
+              <a:shade val="15000"/>
+            </a:schemeClr>
+          </a:lnRef>
+          <a:fillRef idx="1">
+            <a:schemeClr val="accent1"/>
+          </a:fillRef>
+          <a:effectRef idx="0">
+            <a:schemeClr val="accent1"/>
+          </a:effectRef>
+          <a:fontRef idx="minor">
+            <a:schemeClr val="lt1"/>
+          </a:fontRef>
+        </p:style>
+        <p:txBody>
+          <a:bodyPr rtlCol="0" anchor="ctr"/>
+          <a:lstStyle/>
+          <a:p>
+            <a:r>
+              <a:rPr lang="fr-FR" sz="2800" dirty="0"/>
+              <a:t>Coefficient Extrémal: mesurer la </a:t>
+            </a:r>
+            <a:r>
+              <a:rPr lang="fr-FR" sz="2800" dirty="0" err="1"/>
+              <a:t>dépensdanace</a:t>
+            </a:r>
+            <a:r>
+              <a:rPr lang="fr-FR" sz="2800" dirty="0"/>
+              <a:t> des </a:t>
+            </a:r>
+            <a:r>
+              <a:rPr lang="fr-FR" sz="2800" dirty="0" err="1"/>
+              <a:t>extremes</a:t>
+            </a:r>
+            <a:endParaRPr lang="fr-FR" sz="2800" dirty="0"/>
+          </a:p>
+        </p:txBody>
+      </p:sp>
+      <p:sp>
+        <p:nvSpPr>
+          <p:cNvPr id="7" name="Rectangle 6">
+            <a:extLst>
+              <a:ext uri="{FF2B5EF4-FFF2-40B4-BE49-F238E27FC236}">
+                <a16:creationId xmlns:a16="http://schemas.microsoft.com/office/drawing/2014/main" id="{7B0DABE4-926D-3C75-9EDA-C41FEFD6F519}"/>
+              </a:ext>
+            </a:extLst>
+          </p:cNvPr>
+          <p:cNvSpPr/>
+          <p:nvPr/>
+        </p:nvSpPr>
+        <p:spPr>
+          <a:xfrm>
+            <a:off x="620485" y="1584132"/>
+            <a:ext cx="10308771" cy="3205579"/>
+          </a:xfrm>
+          <a:prstGeom prst="rect">
+            <a:avLst/>
+          </a:prstGeom>
+          <a:solidFill>
+            <a:schemeClr val="bg1"/>
+          </a:solidFill>
+        </p:spPr>
+        <p:style>
+          <a:lnRef idx="2">
+            <a:schemeClr val="accent1">
+              <a:shade val="15000"/>
+            </a:schemeClr>
+          </a:lnRef>
+          <a:fillRef idx="1">
+            <a:schemeClr val="accent1"/>
+          </a:fillRef>
+          <a:effectRef idx="0">
+            <a:schemeClr val="accent1"/>
+          </a:effectRef>
+          <a:fontRef idx="minor">
+            <a:schemeClr val="lt1"/>
+          </a:fontRef>
+        </p:style>
+        <p:txBody>
+          <a:bodyPr rtlCol="0" anchor="ctr"/>
+          <a:lstStyle/>
+          <a:p>
+            <a:pPr marL="228600" indent="-228600">
+              <a:spcAft>
+                <a:spcPts val="1600"/>
+              </a:spcAft>
+              <a:buSzPct val="100000"/>
+              <a:buChar char="•"/>
+            </a:pPr>
+            <a:endParaRPr lang="en-US" sz="2000" b="1" dirty="0">
+              <a:solidFill>
+                <a:srgbClr val="1B2430"/>
+              </a:solidFill>
+              <a:latin typeface="Calibri" pitchFamily="34" charset="0"/>
+              <a:ea typeface="Calibri" pitchFamily="34" charset="-122"/>
+              <a:cs typeface="Calibri" pitchFamily="34" charset="-120"/>
+            </a:endParaRPr>
+          </a:p>
+          <a:p>
+            <a:pPr>
+              <a:spcAft>
+                <a:spcPts val="1600"/>
+              </a:spcAft>
+              <a:buSzPct val="100000"/>
+            </a:pPr>
+            <a:r>
+              <a:rPr lang="en-US" sz="2400" dirty="0">
+                <a:solidFill>
+                  <a:srgbClr val="1B2430"/>
+                </a:solidFill>
+                <a:latin typeface="Calibri" pitchFamily="34" charset="0"/>
+                <a:ea typeface="Calibri" pitchFamily="34" charset="-122"/>
+                <a:cs typeface="Calibri" pitchFamily="34" charset="-120"/>
+              </a:rPr>
+              <a:t>Deux </a:t>
+            </a:r>
+            <a:r>
+              <a:rPr lang="en-US" sz="2400" dirty="0" err="1">
+                <a:solidFill>
+                  <a:srgbClr val="1B2430"/>
+                </a:solidFill>
+                <a:latin typeface="Calibri" pitchFamily="34" charset="0"/>
+                <a:ea typeface="Calibri" pitchFamily="34" charset="-122"/>
+                <a:cs typeface="Calibri" pitchFamily="34" charset="-120"/>
+              </a:rPr>
+              <a:t>localisations</a:t>
+            </a:r>
+            <a:r>
+              <a:rPr lang="en-US" sz="2400" dirty="0">
+                <a:solidFill>
+                  <a:srgbClr val="1B2430"/>
+                </a:solidFill>
+                <a:latin typeface="Calibri" pitchFamily="34" charset="0"/>
+                <a:ea typeface="Calibri" pitchFamily="34" charset="-122"/>
+                <a:cs typeface="Calibri" pitchFamily="34" charset="-120"/>
+              </a:rPr>
+              <a:t> </a:t>
+            </a:r>
+            <a:r>
+              <a:rPr lang="en-US" sz="2400" b="1" dirty="0">
+                <a:solidFill>
+                  <a:srgbClr val="1B2430"/>
+                </a:solidFill>
+                <a:latin typeface="Calibri" pitchFamily="34" charset="0"/>
+                <a:ea typeface="Calibri" pitchFamily="34" charset="-122"/>
+                <a:cs typeface="Calibri" pitchFamily="34" charset="-120"/>
+              </a:rPr>
+              <a:t>x1</a:t>
+            </a:r>
+            <a:r>
+              <a:rPr lang="en-US" sz="2400" dirty="0">
+                <a:solidFill>
+                  <a:srgbClr val="1B2430"/>
+                </a:solidFill>
+                <a:latin typeface="Calibri" pitchFamily="34" charset="0"/>
+                <a:ea typeface="Calibri" pitchFamily="34" charset="-122"/>
+                <a:cs typeface="Calibri" pitchFamily="34" charset="-120"/>
+              </a:rPr>
+              <a:t> et </a:t>
+            </a:r>
+            <a:r>
+              <a:rPr lang="en-US" sz="2400" b="1" dirty="0">
+                <a:solidFill>
+                  <a:srgbClr val="1B2430"/>
+                </a:solidFill>
+                <a:latin typeface="Calibri" pitchFamily="34" charset="0"/>
+                <a:ea typeface="Calibri" pitchFamily="34" charset="-122"/>
+                <a:cs typeface="Calibri" pitchFamily="34" charset="-120"/>
+              </a:rPr>
+              <a:t>x2</a:t>
+            </a:r>
+            <a:r>
+              <a:rPr lang="en-US" sz="2400" dirty="0">
+                <a:solidFill>
+                  <a:srgbClr val="1B2430"/>
+                </a:solidFill>
+                <a:latin typeface="Calibri" pitchFamily="34" charset="0"/>
+                <a:ea typeface="Calibri" pitchFamily="34" charset="-122"/>
+                <a:cs typeface="Calibri" pitchFamily="34" charset="-120"/>
+              </a:rPr>
+              <a:t> dans un processus max-stable simple </a:t>
+            </a:r>
+            <a:r>
+              <a:rPr lang="en-US" sz="2000" dirty="0">
+                <a:solidFill>
+                  <a:srgbClr val="1B2430"/>
+                </a:solidFill>
+                <a:latin typeface="Calibri" pitchFamily="34" charset="0"/>
+                <a:ea typeface="Calibri" pitchFamily="34" charset="-122"/>
+                <a:cs typeface="Calibri" pitchFamily="34" charset="-120"/>
+              </a:rPr>
+              <a:t>.</a:t>
+            </a:r>
+          </a:p>
+          <a:p>
+            <a:pPr marL="228600" indent="-228600">
+              <a:spcAft>
+                <a:spcPts val="1600"/>
+              </a:spcAft>
+              <a:buSzPct val="100000"/>
+              <a:buChar char="•"/>
+            </a:pPr>
+            <a:endParaRPr lang="en-US" sz="2000" dirty="0"/>
+          </a:p>
+          <a:p>
+            <a:pPr>
+              <a:spcAft>
+                <a:spcPts val="1600"/>
+              </a:spcAft>
+              <a:buSzPct val="100000"/>
+            </a:pPr>
+            <a:endParaRPr lang="en-US" sz="2000" b="1" dirty="0">
+              <a:solidFill>
+                <a:srgbClr val="1B2430"/>
+              </a:solidFill>
+              <a:latin typeface="Calibri" pitchFamily="34" charset="0"/>
+              <a:ea typeface="Calibri" pitchFamily="34" charset="-122"/>
+              <a:cs typeface="Calibri" pitchFamily="34" charset="-120"/>
+            </a:endParaRPr>
+          </a:p>
+          <a:p>
+            <a:pPr>
+              <a:spcAft>
+                <a:spcPts val="1600"/>
+              </a:spcAft>
+              <a:buSzPct val="100000"/>
+            </a:pPr>
+            <a:r>
+              <a:rPr lang="en-US" sz="1600" b="1" dirty="0">
+                <a:solidFill>
+                  <a:srgbClr val="1B2430"/>
+                </a:solidFill>
+                <a:latin typeface="Calibri" pitchFamily="34" charset="0"/>
+                <a:ea typeface="Calibri" pitchFamily="34" charset="-122"/>
+                <a:cs typeface="Calibri" pitchFamily="34" charset="-120"/>
+              </a:rPr>
+              <a:t>Dependance parfait                               </a:t>
+            </a:r>
+            <a:r>
+              <a:rPr lang="en-US" sz="1600" b="1" dirty="0" err="1">
+                <a:solidFill>
+                  <a:srgbClr val="1B2430"/>
+                </a:solidFill>
+                <a:latin typeface="Calibri" pitchFamily="34" charset="0"/>
+                <a:ea typeface="Calibri" pitchFamily="34" charset="-122"/>
+                <a:cs typeface="Calibri" pitchFamily="34" charset="-120"/>
+              </a:rPr>
+              <a:t>Dépendance</a:t>
+            </a:r>
+            <a:r>
+              <a:rPr lang="en-US" sz="1600" b="1" dirty="0">
+                <a:solidFill>
+                  <a:srgbClr val="1B2430"/>
+                </a:solidFill>
+                <a:latin typeface="Calibri" pitchFamily="34" charset="0"/>
+                <a:ea typeface="Calibri" pitchFamily="34" charset="-122"/>
+                <a:cs typeface="Calibri" pitchFamily="34" charset="-120"/>
+              </a:rPr>
+              <a:t> </a:t>
+            </a:r>
+            <a:r>
+              <a:rPr lang="en-US" sz="1600" b="1" dirty="0" err="1">
+                <a:solidFill>
+                  <a:srgbClr val="1B2430"/>
+                </a:solidFill>
+                <a:latin typeface="Calibri" pitchFamily="34" charset="0"/>
+                <a:ea typeface="Calibri" pitchFamily="34" charset="-122"/>
+                <a:cs typeface="Calibri" pitchFamily="34" charset="-120"/>
+              </a:rPr>
+              <a:t>intermédiare</a:t>
+            </a:r>
+            <a:r>
+              <a:rPr lang="en-US" sz="1600" b="1" dirty="0">
+                <a:solidFill>
+                  <a:srgbClr val="1B2430"/>
+                </a:solidFill>
+                <a:latin typeface="Calibri" pitchFamily="34" charset="0"/>
+                <a:ea typeface="Calibri" pitchFamily="34" charset="-122"/>
+                <a:cs typeface="Calibri" pitchFamily="34" charset="-120"/>
+              </a:rPr>
+              <a:t>                                                   </a:t>
+            </a:r>
+            <a:r>
+              <a:rPr lang="en-US" sz="1600" b="1" dirty="0" err="1">
+                <a:solidFill>
+                  <a:srgbClr val="1B2430"/>
+                </a:solidFill>
+                <a:latin typeface="Calibri" pitchFamily="34" charset="0"/>
+                <a:ea typeface="Calibri" pitchFamily="34" charset="-122"/>
+                <a:cs typeface="Calibri" pitchFamily="34" charset="-120"/>
+              </a:rPr>
+              <a:t>Indépendance</a:t>
+            </a:r>
+            <a:r>
+              <a:rPr lang="en-US" sz="1600" b="1" dirty="0">
+                <a:solidFill>
+                  <a:srgbClr val="1B2430"/>
+                </a:solidFill>
+                <a:latin typeface="Calibri" pitchFamily="34" charset="0"/>
+                <a:ea typeface="Calibri" pitchFamily="34" charset="-122"/>
+                <a:cs typeface="Calibri" pitchFamily="34" charset="-120"/>
+              </a:rPr>
+              <a:t> des extreme</a:t>
+            </a:r>
+          </a:p>
+          <a:p>
+            <a:pPr>
+              <a:spcAft>
+                <a:spcPts val="1600"/>
+              </a:spcAft>
+              <a:buSzPct val="100000"/>
+            </a:pPr>
+            <a:r>
+              <a:rPr lang="en-US" sz="1600" b="1" dirty="0">
+                <a:solidFill>
+                  <a:srgbClr val="1B2430"/>
+                </a:solidFill>
+                <a:latin typeface="Calibri" pitchFamily="34" charset="0"/>
+                <a:ea typeface="Calibri" pitchFamily="34" charset="-122"/>
+                <a:cs typeface="Calibri" pitchFamily="34" charset="-120"/>
+              </a:rPr>
+              <a:t>des extremes</a:t>
+            </a:r>
+          </a:p>
+          <a:p>
+            <a:pPr marL="228600" indent="-228600">
+              <a:spcAft>
+                <a:spcPts val="1600"/>
+              </a:spcAft>
+              <a:buSzPct val="100000"/>
+              <a:buChar char="•"/>
+            </a:pPr>
+            <a:endParaRPr lang="en-US" sz="2000" dirty="0"/>
+          </a:p>
+        </p:txBody>
+      </p:sp>
+      <p:sp>
+        <p:nvSpPr>
+          <p:cNvPr id="8" name="Rectangle : coins arrondis 7">
+            <a:extLst>
+              <a:ext uri="{FF2B5EF4-FFF2-40B4-BE49-F238E27FC236}">
+                <a16:creationId xmlns:a16="http://schemas.microsoft.com/office/drawing/2014/main" id="{8A3AAD72-73F4-AD71-831D-645A4A6418F8}"/>
+              </a:ext>
+            </a:extLst>
+          </p:cNvPr>
+          <p:cNvSpPr/>
+          <p:nvPr/>
+        </p:nvSpPr>
+        <p:spPr>
+          <a:xfrm>
+            <a:off x="620483" y="1181358"/>
+            <a:ext cx="10308771" cy="380480"/>
+          </a:xfrm>
+          <a:prstGeom prst="roundRect">
+            <a:avLst/>
+          </a:prstGeom>
+        </p:spPr>
+        <p:style>
+          <a:lnRef idx="2">
+            <a:schemeClr val="accent1">
+              <a:shade val="15000"/>
+            </a:schemeClr>
+          </a:lnRef>
+          <a:fillRef idx="1">
+            <a:schemeClr val="accent1"/>
+          </a:fillRef>
+          <a:effectRef idx="0">
+            <a:schemeClr val="accent1"/>
+          </a:effectRef>
+          <a:fontRef idx="minor">
+            <a:schemeClr val="lt1"/>
+          </a:fontRef>
+        </p:style>
+        <p:txBody>
+          <a:bodyPr rtlCol="0" anchor="ctr"/>
+          <a:lstStyle/>
+          <a:p>
+            <a:r>
+              <a:rPr lang="fr-FR" sz="2400" dirty="0"/>
+              <a:t>Définition </a:t>
+            </a:r>
+          </a:p>
+        </p:txBody>
+      </p:sp>
+      <p:sp>
+        <p:nvSpPr>
+          <p:cNvPr id="15" name="Rectangle : coins arrondis 14">
+            <a:extLst>
+              <a:ext uri="{FF2B5EF4-FFF2-40B4-BE49-F238E27FC236}">
+                <a16:creationId xmlns:a16="http://schemas.microsoft.com/office/drawing/2014/main" id="{BC12E178-D70E-4B83-0C6B-27F99052A1AB}"/>
+              </a:ext>
+            </a:extLst>
+          </p:cNvPr>
+          <p:cNvSpPr/>
+          <p:nvPr/>
+        </p:nvSpPr>
+        <p:spPr>
+          <a:xfrm>
+            <a:off x="620484" y="4812006"/>
+            <a:ext cx="10308771" cy="380480"/>
+          </a:xfrm>
+          <a:prstGeom prst="roundRect">
+            <a:avLst/>
+          </a:prstGeom>
+        </p:spPr>
+        <p:style>
+          <a:lnRef idx="2">
+            <a:schemeClr val="accent1">
+              <a:shade val="15000"/>
+            </a:schemeClr>
+          </a:lnRef>
+          <a:fillRef idx="1">
+            <a:schemeClr val="accent1"/>
+          </a:fillRef>
+          <a:effectRef idx="0">
+            <a:schemeClr val="accent1"/>
+          </a:effectRef>
+          <a:fontRef idx="minor">
+            <a:schemeClr val="lt1"/>
+          </a:fontRef>
+        </p:style>
+        <p:txBody>
+          <a:bodyPr rtlCol="0" anchor="ctr"/>
+          <a:lstStyle/>
+          <a:p>
+            <a:r>
+              <a:rPr lang="fr-FR" sz="2400" dirty="0"/>
+              <a:t>Conséquence</a:t>
+            </a:r>
+          </a:p>
+        </p:txBody>
+      </p:sp>
+      <p:sp>
+        <p:nvSpPr>
+          <p:cNvPr id="17" name="Rectangle 16">
+            <a:extLst>
+              <a:ext uri="{FF2B5EF4-FFF2-40B4-BE49-F238E27FC236}">
+                <a16:creationId xmlns:a16="http://schemas.microsoft.com/office/drawing/2014/main" id="{7BF7FDBC-0CD8-DAF3-9223-A2B2214CCF1E}"/>
+              </a:ext>
+            </a:extLst>
+          </p:cNvPr>
+          <p:cNvSpPr/>
+          <p:nvPr/>
+        </p:nvSpPr>
+        <p:spPr>
+          <a:xfrm>
+            <a:off x="620484" y="5214780"/>
+            <a:ext cx="10308771" cy="1067319"/>
+          </a:xfrm>
+          <a:prstGeom prst="rect">
+            <a:avLst/>
+          </a:prstGeom>
+          <a:solidFill>
+            <a:schemeClr val="bg1"/>
+          </a:solidFill>
+        </p:spPr>
+        <p:style>
+          <a:lnRef idx="2">
+            <a:schemeClr val="accent1">
+              <a:shade val="15000"/>
+            </a:schemeClr>
+          </a:lnRef>
+          <a:fillRef idx="1">
+            <a:schemeClr val="accent1"/>
+          </a:fillRef>
+          <a:effectRef idx="0">
+            <a:schemeClr val="accent1"/>
+          </a:effectRef>
+          <a:fontRef idx="minor">
+            <a:schemeClr val="lt1"/>
+          </a:fontRef>
+        </p:style>
+        <p:txBody>
+          <a:bodyPr rtlCol="0" anchor="ctr"/>
+          <a:lstStyle/>
+          <a:p>
+            <a:pPr>
+              <a:lnSpc>
+                <a:spcPct val="125000"/>
+              </a:lnSpc>
+            </a:pPr>
+            <a:r>
+              <a:rPr lang="en-US" sz="2000" dirty="0">
+                <a:solidFill>
+                  <a:schemeClr val="tx1"/>
+                </a:solidFill>
+              </a:rPr>
+              <a:t>Si le processus est </a:t>
+            </a:r>
+            <a:r>
+              <a:rPr lang="en-US" sz="2000" dirty="0" err="1">
+                <a:solidFill>
+                  <a:schemeClr val="tx1"/>
+                </a:solidFill>
+              </a:rPr>
+              <a:t>isotrope</a:t>
+            </a:r>
+            <a:r>
+              <a:rPr lang="en-US" sz="2000" dirty="0">
+                <a:solidFill>
+                  <a:schemeClr val="tx1"/>
+                </a:solidFill>
+              </a:rPr>
+              <a:t> ,</a:t>
+            </a:r>
+            <a:r>
+              <a:rPr lang="el-GR" sz="2000" dirty="0">
+                <a:solidFill>
+                  <a:schemeClr val="tx2">
+                    <a:lumMod val="75000"/>
+                  </a:schemeClr>
+                </a:solidFill>
+              </a:rPr>
+              <a:t>Θ</a:t>
+            </a:r>
+            <a:r>
+              <a:rPr lang="fr-FR" sz="2000" dirty="0">
+                <a:solidFill>
+                  <a:schemeClr val="tx2">
+                    <a:lumMod val="75000"/>
+                  </a:schemeClr>
+                </a:solidFill>
+              </a:rPr>
+              <a:t> </a:t>
+            </a:r>
+            <a:r>
+              <a:rPr lang="en-US" sz="2000" dirty="0">
+                <a:solidFill>
+                  <a:schemeClr val="tx1"/>
+                </a:solidFill>
+              </a:rPr>
+              <a:t>depend </a:t>
+            </a:r>
+            <a:r>
+              <a:rPr lang="en-US" sz="2000" dirty="0" err="1">
+                <a:solidFill>
+                  <a:schemeClr val="tx1"/>
+                </a:solidFill>
+              </a:rPr>
+              <a:t>seulement</a:t>
+            </a:r>
+            <a:r>
+              <a:rPr lang="en-US" sz="2000" dirty="0">
+                <a:solidFill>
+                  <a:schemeClr val="tx1"/>
+                </a:solidFill>
+              </a:rPr>
+              <a:t> de la distance  h=||x1-x2||</a:t>
+            </a:r>
+          </a:p>
+        </p:txBody>
+      </p:sp>
+      <p:pic>
+        <p:nvPicPr>
+          <p:cNvPr id="4" name="Image 3">
+            <a:extLst>
+              <a:ext uri="{FF2B5EF4-FFF2-40B4-BE49-F238E27FC236}">
+                <a16:creationId xmlns:a16="http://schemas.microsoft.com/office/drawing/2014/main" id="{C8942208-A6BE-1CAB-30A0-4C91F4F55D28}"/>
+              </a:ext>
+            </a:extLst>
+          </p:cNvPr>
+          <p:cNvPicPr>
+            <a:picLocks noChangeAspect="1"/>
+          </p:cNvPicPr>
+          <p:nvPr/>
+        </p:nvPicPr>
+        <p:blipFill>
+          <a:blip r:embed="rId2">
+            <a:extLst>
+              <a:ext uri="{28A0092B-C50C-407E-A947-70E740481C1C}">
+                <a14:useLocalDpi xmlns:a14="http://schemas.microsoft.com/office/drawing/2010/main" val="0"/>
+              </a:ext>
+            </a:extLst>
+          </a:blip>
+          <a:stretch>
+            <a:fillRect/>
+          </a:stretch>
+        </p:blipFill>
+        <p:spPr>
+          <a:xfrm>
+            <a:off x="2948027" y="2564326"/>
+            <a:ext cx="4054191" cy="707922"/>
+          </a:xfrm>
+          <a:prstGeom prst="rect">
+            <a:avLst/>
+          </a:prstGeom>
+        </p:spPr>
+      </p:pic>
+      <p:sp>
+        <p:nvSpPr>
+          <p:cNvPr id="6" name="TextBox 4">
+            <a:extLst>
+              <a:ext uri="{FF2B5EF4-FFF2-40B4-BE49-F238E27FC236}">
+                <a16:creationId xmlns:a16="http://schemas.microsoft.com/office/drawing/2014/main" id="{70A60DCE-4656-B8FB-D038-FAD60571034B}"/>
+              </a:ext>
+            </a:extLst>
+          </p:cNvPr>
+          <p:cNvSpPr txBox="1"/>
+          <p:nvPr/>
+        </p:nvSpPr>
+        <p:spPr>
+          <a:xfrm>
+            <a:off x="51464" y="3127262"/>
+            <a:ext cx="2926080" cy="830997"/>
+          </a:xfrm>
+          <a:prstGeom prst="rect">
+            <a:avLst/>
+          </a:prstGeom>
+          <a:noFill/>
+        </p:spPr>
+        <p:txBody>
+          <a:bodyPr wrap="square" anchor="ctr">
+            <a:spAutoFit/>
+          </a:bodyPr>
+          <a:lstStyle/>
+          <a:p>
+            <a:pPr algn="ctr">
+              <a:defRPr sz="2400" b="1">
+                <a:solidFill>
+                  <a:srgbClr val="EA580C"/>
+                </a:solidFill>
+              </a:defRPr>
+            </a:pPr>
+            <a:r>
+              <a:rPr dirty="0">
+                <a:solidFill>
+                  <a:schemeClr val="tx2">
+                    <a:lumMod val="75000"/>
+                  </a:schemeClr>
+                </a:solidFill>
+              </a:rPr>
+              <a:t>Θ = 1</a:t>
+            </a:r>
+            <a:endParaRPr lang="fr-FR" dirty="0">
+              <a:solidFill>
+                <a:schemeClr val="tx2">
+                  <a:lumMod val="75000"/>
+                </a:schemeClr>
+              </a:solidFill>
+            </a:endParaRPr>
+          </a:p>
+          <a:p>
+            <a:pPr algn="ctr">
+              <a:defRPr sz="2400" b="1">
+                <a:solidFill>
+                  <a:srgbClr val="EA580C"/>
+                </a:solidFill>
+              </a:defRPr>
+            </a:pPr>
+            <a:endParaRPr dirty="0">
+              <a:solidFill>
+                <a:schemeClr val="tx2">
+                  <a:lumMod val="75000"/>
+                </a:schemeClr>
+              </a:solidFill>
+            </a:endParaRPr>
+          </a:p>
+        </p:txBody>
+      </p:sp>
+      <p:sp>
+        <p:nvSpPr>
+          <p:cNvPr id="10" name="TextBox 5">
+            <a:extLst>
+              <a:ext uri="{FF2B5EF4-FFF2-40B4-BE49-F238E27FC236}">
+                <a16:creationId xmlns:a16="http://schemas.microsoft.com/office/drawing/2014/main" id="{370B8396-81B7-FA11-7218-3434A2956428}"/>
+              </a:ext>
+            </a:extLst>
+          </p:cNvPr>
+          <p:cNvSpPr txBox="1"/>
+          <p:nvPr/>
+        </p:nvSpPr>
+        <p:spPr>
+          <a:xfrm>
+            <a:off x="3510568" y="3192808"/>
+            <a:ext cx="2926080" cy="461665"/>
+          </a:xfrm>
+          <a:prstGeom prst="rect">
+            <a:avLst/>
+          </a:prstGeom>
+          <a:noFill/>
+        </p:spPr>
+        <p:txBody>
+          <a:bodyPr wrap="square" anchor="ctr">
+            <a:spAutoFit/>
+          </a:bodyPr>
+          <a:lstStyle/>
+          <a:p>
+            <a:pPr algn="ctr">
+              <a:defRPr sz="2400" b="1">
+                <a:solidFill>
+                  <a:srgbClr val="2563EB"/>
+                </a:solidFill>
+              </a:defRPr>
+            </a:pPr>
+            <a:r>
+              <a:rPr dirty="0">
+                <a:solidFill>
+                  <a:schemeClr val="tx2">
+                    <a:lumMod val="75000"/>
+                  </a:schemeClr>
+                </a:solidFill>
+              </a:rPr>
+              <a:t>1 &lt; Θ &lt; 2</a:t>
+            </a:r>
+          </a:p>
+        </p:txBody>
+      </p:sp>
+      <p:sp>
+        <p:nvSpPr>
+          <p:cNvPr id="12" name="TextBox 6">
+            <a:extLst>
+              <a:ext uri="{FF2B5EF4-FFF2-40B4-BE49-F238E27FC236}">
+                <a16:creationId xmlns:a16="http://schemas.microsoft.com/office/drawing/2014/main" id="{B3AD0C5B-5F73-B594-CED0-6327404C6A0B}"/>
+              </a:ext>
+            </a:extLst>
+          </p:cNvPr>
+          <p:cNvSpPr txBox="1"/>
+          <p:nvPr/>
+        </p:nvSpPr>
+        <p:spPr>
+          <a:xfrm>
+            <a:off x="7502697" y="3192808"/>
+            <a:ext cx="2926080" cy="461665"/>
+          </a:xfrm>
+          <a:prstGeom prst="rect">
+            <a:avLst/>
+          </a:prstGeom>
+          <a:noFill/>
+        </p:spPr>
+        <p:txBody>
+          <a:bodyPr wrap="square" anchor="ctr">
+            <a:spAutoFit/>
+          </a:bodyPr>
+          <a:lstStyle/>
+          <a:p>
+            <a:pPr algn="ctr">
+              <a:defRPr sz="2400" b="1">
+                <a:solidFill>
+                  <a:srgbClr val="16A34A"/>
+                </a:solidFill>
+              </a:defRPr>
+            </a:pPr>
+            <a:r>
+              <a:rPr dirty="0">
+                <a:solidFill>
+                  <a:schemeClr val="tx2">
+                    <a:lumMod val="75000"/>
+                  </a:schemeClr>
+                </a:solidFill>
+              </a:rPr>
+              <a:t>Θ = 2</a:t>
+            </a:r>
+          </a:p>
+        </p:txBody>
+      </p:sp>
+    </p:spTree>
+    <p:extLst>
+      <p:ext uri="{BB962C8B-B14F-4D97-AF65-F5344CB8AC3E}">
+        <p14:creationId xmlns:p14="http://schemas.microsoft.com/office/powerpoint/2010/main" val="1859687788"/>
+      </p:ext>
+    </p:extLst>
+  </p:cSld>
+  <p:clrMapOvr>
+    <a:masterClrMapping/>
+  </p:clrMapOvr>
+</p:sld>
+</file>
+
+<file path=ppt/slides/slide5.xml><?xml version="1.0" encoding="utf-8"?>
+<p:sld xmlns:a="http://schemas.openxmlformats.org/drawingml/2006/main" xmlns:r="http://schemas.openxmlformats.org/officeDocument/2006/relationships" xmlns:p="http://schemas.openxmlformats.org/presentationml/2006/main">
+  <p:cSld>
+    <p:spTree>
+      <p:nvGrpSpPr>
+        <p:cNvPr id="1" name="">
+          <a:extLst>
+            <a:ext uri="{FF2B5EF4-FFF2-40B4-BE49-F238E27FC236}">
+              <a16:creationId xmlns:a16="http://schemas.microsoft.com/office/drawing/2014/main" id="{67779B07-953B-2B10-7BF4-378F78333DF9}"/>
+            </a:ext>
+          </a:extLst>
+        </p:cNvPr>
+        <p:cNvGrpSpPr/>
+        <p:nvPr/>
+      </p:nvGrpSpPr>
+      <p:grpSpPr>
+        <a:xfrm>
+          <a:off x="0" y="0"/>
+          <a:ext cx="0" cy="0"/>
+          <a:chOff x="0" y="0"/>
+          <a:chExt cx="0" cy="0"/>
+        </a:xfrm>
+      </p:grpSpPr>
+      <p:sp>
+        <p:nvSpPr>
+          <p:cNvPr id="3" name="Rectangle 2">
+            <a:extLst>
+              <a:ext uri="{FF2B5EF4-FFF2-40B4-BE49-F238E27FC236}">
+                <a16:creationId xmlns:a16="http://schemas.microsoft.com/office/drawing/2014/main" id="{AC61F060-6595-0E78-927C-C78299D53263}"/>
+              </a:ext>
+            </a:extLst>
+          </p:cNvPr>
+          <p:cNvSpPr/>
+          <p:nvPr/>
+        </p:nvSpPr>
+        <p:spPr>
+          <a:xfrm>
+            <a:off x="0" y="0"/>
+            <a:ext cx="12192000" cy="708091"/>
+          </a:xfrm>
+          <a:prstGeom prst="rect">
+            <a:avLst/>
+          </a:prstGeom>
+        </p:spPr>
+        <p:style>
+          <a:lnRef idx="2">
+            <a:schemeClr val="accent1">
+              <a:shade val="15000"/>
+            </a:schemeClr>
+          </a:lnRef>
+          <a:fillRef idx="1">
+            <a:schemeClr val="accent1"/>
+          </a:fillRef>
+          <a:effectRef idx="0">
+            <a:schemeClr val="accent1"/>
+          </a:effectRef>
+          <a:fontRef idx="minor">
+            <a:schemeClr val="lt1"/>
+          </a:fontRef>
+        </p:style>
+        <p:txBody>
+          <a:bodyPr rtlCol="0" anchor="ctr"/>
+          <a:lstStyle/>
+          <a:p>
+            <a:r>
+              <a:rPr lang="fr-FR" sz="2800" dirty="0"/>
+              <a:t>Coefficient Extrémal: mesurer la </a:t>
+            </a:r>
+            <a:r>
+              <a:rPr lang="fr-FR" sz="2800" dirty="0" err="1"/>
+              <a:t>dépensdanace</a:t>
+            </a:r>
+            <a:r>
+              <a:rPr lang="fr-FR" sz="2800" dirty="0"/>
+              <a:t> des </a:t>
+            </a:r>
+            <a:r>
+              <a:rPr lang="fr-FR" sz="2800" dirty="0" err="1"/>
+              <a:t>extremes</a:t>
+            </a:r>
+            <a:endParaRPr lang="fr-FR" sz="2800" dirty="0"/>
+          </a:p>
+        </p:txBody>
+      </p:sp>
+      <p:sp>
+        <p:nvSpPr>
+          <p:cNvPr id="7" name="Rectangle 6">
+            <a:extLst>
+              <a:ext uri="{FF2B5EF4-FFF2-40B4-BE49-F238E27FC236}">
+                <a16:creationId xmlns:a16="http://schemas.microsoft.com/office/drawing/2014/main" id="{0FBCF152-08CE-45E2-B805-A45F593323B2}"/>
+              </a:ext>
+            </a:extLst>
+          </p:cNvPr>
+          <p:cNvSpPr/>
+          <p:nvPr/>
+        </p:nvSpPr>
+        <p:spPr>
+          <a:xfrm>
+            <a:off x="620485" y="1665513"/>
+            <a:ext cx="10308771" cy="2939143"/>
+          </a:xfrm>
+          <a:prstGeom prst="rect">
+            <a:avLst/>
+          </a:prstGeom>
+          <a:solidFill>
+            <a:schemeClr val="bg1"/>
+          </a:solidFill>
+        </p:spPr>
+        <p:style>
+          <a:lnRef idx="2">
+            <a:schemeClr val="accent1">
+              <a:shade val="15000"/>
+            </a:schemeClr>
+          </a:lnRef>
+          <a:fillRef idx="1">
+            <a:schemeClr val="accent1"/>
+          </a:fillRef>
+          <a:effectRef idx="0">
+            <a:schemeClr val="accent1"/>
+          </a:effectRef>
+          <a:fontRef idx="minor">
+            <a:schemeClr val="lt1"/>
+          </a:fontRef>
+        </p:style>
+        <p:txBody>
+          <a:bodyPr rtlCol="0" anchor="ctr"/>
+          <a:lstStyle/>
+          <a:p>
+            <a:pPr marL="228600" indent="-228600">
+              <a:spcAft>
+                <a:spcPts val="1600"/>
+              </a:spcAft>
+              <a:buSzPct val="100000"/>
+              <a:buChar char="•"/>
+            </a:pPr>
+            <a:endParaRPr lang="en-US" sz="2000" b="1" dirty="0">
+              <a:solidFill>
+                <a:srgbClr val="1B2430"/>
+              </a:solidFill>
+              <a:latin typeface="Calibri" pitchFamily="34" charset="0"/>
+              <a:ea typeface="Calibri" pitchFamily="34" charset="-122"/>
+              <a:cs typeface="Calibri" pitchFamily="34" charset="-120"/>
+            </a:endParaRPr>
+          </a:p>
+          <a:p>
+            <a:pPr>
+              <a:spcAft>
+                <a:spcPts val="1600"/>
+              </a:spcAft>
+              <a:buSzPct val="100000"/>
+            </a:pPr>
+            <a:endParaRPr lang="en-US" sz="2000" dirty="0">
+              <a:solidFill>
+                <a:srgbClr val="1B2430"/>
+              </a:solidFill>
+              <a:latin typeface="Calibri" pitchFamily="34" charset="0"/>
+              <a:ea typeface="Calibri" pitchFamily="34" charset="-122"/>
+              <a:cs typeface="Calibri" pitchFamily="34" charset="-120"/>
+            </a:endParaRPr>
+          </a:p>
+          <a:p>
+            <a:pPr marL="228600" indent="-228600">
+              <a:spcAft>
+                <a:spcPts val="1600"/>
+              </a:spcAft>
+              <a:buSzPct val="100000"/>
+              <a:buChar char="•"/>
+            </a:pPr>
+            <a:endParaRPr lang="en-US" sz="2000" dirty="0"/>
+          </a:p>
+          <a:p>
+            <a:pPr marL="228600" indent="-228600">
+              <a:spcAft>
+                <a:spcPts val="1600"/>
+              </a:spcAft>
+              <a:buSzPct val="100000"/>
+              <a:buChar char="•"/>
+            </a:pPr>
+            <a:endParaRPr lang="en-US" sz="2000" dirty="0"/>
+          </a:p>
+        </p:txBody>
+      </p:sp>
+      <p:sp>
+        <p:nvSpPr>
+          <p:cNvPr id="8" name="Rectangle : coins arrondis 7">
+            <a:extLst>
+              <a:ext uri="{FF2B5EF4-FFF2-40B4-BE49-F238E27FC236}">
+                <a16:creationId xmlns:a16="http://schemas.microsoft.com/office/drawing/2014/main" id="{3438E18B-DCBB-13F0-AFDC-09CF7A0771A6}"/>
+              </a:ext>
+            </a:extLst>
+          </p:cNvPr>
+          <p:cNvSpPr/>
+          <p:nvPr/>
+        </p:nvSpPr>
+        <p:spPr>
+          <a:xfrm>
+            <a:off x="620483" y="1181358"/>
+            <a:ext cx="10308771" cy="380480"/>
+          </a:xfrm>
+          <a:prstGeom prst="roundRect">
+            <a:avLst/>
+          </a:prstGeom>
+        </p:spPr>
+        <p:style>
+          <a:lnRef idx="2">
+            <a:schemeClr val="accent1">
+              <a:shade val="15000"/>
+            </a:schemeClr>
+          </a:lnRef>
+          <a:fillRef idx="1">
+            <a:schemeClr val="accent1"/>
+          </a:fillRef>
+          <a:effectRef idx="0">
+            <a:schemeClr val="accent1"/>
+          </a:effectRef>
+          <a:fontRef idx="minor">
+            <a:schemeClr val="lt1"/>
+          </a:fontRef>
+        </p:style>
+        <p:txBody>
+          <a:bodyPr rtlCol="0" anchor="ctr"/>
+          <a:lstStyle/>
+          <a:p>
+            <a:r>
+              <a:rPr lang="fr-FR" sz="2400" dirty="0">
+                <a:solidFill>
+                  <a:schemeClr val="bg1"/>
+                </a:solidFill>
+              </a:rPr>
+              <a:t>Pourquoi </a:t>
+            </a:r>
+            <a:r>
+              <a:rPr lang="el-GR" sz="2400" dirty="0">
+                <a:solidFill>
+                  <a:schemeClr val="bg1"/>
+                </a:solidFill>
+              </a:rPr>
+              <a:t>Θ</a:t>
+            </a:r>
+            <a:r>
+              <a:rPr lang="fr-FR" sz="2400" dirty="0">
+                <a:solidFill>
+                  <a:schemeClr val="bg1"/>
+                </a:solidFill>
+              </a:rPr>
+              <a:t> est important pour la </a:t>
+            </a:r>
+            <a:r>
+              <a:rPr lang="fr-FR" sz="2400" dirty="0" err="1">
+                <a:solidFill>
+                  <a:schemeClr val="bg1"/>
+                </a:solidFill>
+              </a:rPr>
+              <a:t>diversifiaction</a:t>
+            </a:r>
+            <a:r>
+              <a:rPr lang="fr-FR" sz="2400" dirty="0">
+                <a:solidFill>
+                  <a:schemeClr val="bg1"/>
+                </a:solidFill>
+              </a:rPr>
+              <a:t> spatiale </a:t>
+            </a:r>
+          </a:p>
+        </p:txBody>
+      </p:sp>
+      <p:sp>
+        <p:nvSpPr>
+          <p:cNvPr id="15" name="Rectangle : coins arrondis 14">
+            <a:extLst>
+              <a:ext uri="{FF2B5EF4-FFF2-40B4-BE49-F238E27FC236}">
+                <a16:creationId xmlns:a16="http://schemas.microsoft.com/office/drawing/2014/main" id="{0E3EE252-4B34-CA09-4386-F49CDEF8F74E}"/>
+              </a:ext>
+            </a:extLst>
+          </p:cNvPr>
+          <p:cNvSpPr/>
+          <p:nvPr/>
+        </p:nvSpPr>
+        <p:spPr>
+          <a:xfrm>
+            <a:off x="620484" y="4812006"/>
+            <a:ext cx="10308771" cy="380480"/>
+          </a:xfrm>
+          <a:prstGeom prst="roundRect">
+            <a:avLst/>
+          </a:prstGeom>
+        </p:spPr>
+        <p:style>
+          <a:lnRef idx="2">
+            <a:schemeClr val="accent1">
+              <a:shade val="15000"/>
+            </a:schemeClr>
+          </a:lnRef>
+          <a:fillRef idx="1">
+            <a:schemeClr val="accent1"/>
+          </a:fillRef>
+          <a:effectRef idx="0">
+            <a:schemeClr val="accent1"/>
+          </a:effectRef>
+          <a:fontRef idx="minor">
+            <a:schemeClr val="lt1"/>
+          </a:fontRef>
+        </p:style>
+        <p:txBody>
+          <a:bodyPr rtlCol="0" anchor="ctr"/>
+          <a:lstStyle/>
+          <a:p>
+            <a:r>
+              <a:rPr lang="fr-FR" sz="2400" dirty="0"/>
+              <a:t>Interprétation actuarielle</a:t>
+            </a:r>
+          </a:p>
+        </p:txBody>
+      </p:sp>
+      <p:sp>
+        <p:nvSpPr>
+          <p:cNvPr id="17" name="Rectangle 16">
+            <a:extLst>
+              <a:ext uri="{FF2B5EF4-FFF2-40B4-BE49-F238E27FC236}">
+                <a16:creationId xmlns:a16="http://schemas.microsoft.com/office/drawing/2014/main" id="{FA00B62D-10CA-94FD-6D4F-89B06BA2EBA3}"/>
+              </a:ext>
+            </a:extLst>
+          </p:cNvPr>
+          <p:cNvSpPr/>
+          <p:nvPr/>
+        </p:nvSpPr>
+        <p:spPr>
+          <a:xfrm>
+            <a:off x="620484" y="5214780"/>
+            <a:ext cx="10308771" cy="1067319"/>
+          </a:xfrm>
+          <a:prstGeom prst="rect">
+            <a:avLst/>
+          </a:prstGeom>
+          <a:solidFill>
+            <a:schemeClr val="bg1"/>
+          </a:solidFill>
+        </p:spPr>
+        <p:style>
+          <a:lnRef idx="2">
+            <a:schemeClr val="accent1">
+              <a:shade val="15000"/>
+            </a:schemeClr>
+          </a:lnRef>
+          <a:fillRef idx="1">
+            <a:schemeClr val="accent1"/>
+          </a:fillRef>
+          <a:effectRef idx="0">
+            <a:schemeClr val="accent1"/>
+          </a:effectRef>
+          <a:fontRef idx="minor">
+            <a:schemeClr val="lt1"/>
+          </a:fontRef>
+        </p:style>
+        <p:txBody>
+          <a:bodyPr rtlCol="0" anchor="ctr"/>
+          <a:lstStyle/>
+          <a:p>
+            <a:pPr>
+              <a:lnSpc>
+                <a:spcPct val="125000"/>
+              </a:lnSpc>
+            </a:pPr>
+            <a:r>
+              <a:rPr lang="en-US" sz="2000" dirty="0" err="1">
+                <a:solidFill>
+                  <a:schemeClr val="tx1"/>
+                </a:solidFill>
+              </a:rPr>
+              <a:t>Éloigner</a:t>
+            </a:r>
+            <a:r>
+              <a:rPr lang="en-US" sz="2000" dirty="0">
+                <a:solidFill>
+                  <a:schemeClr val="tx1"/>
+                </a:solidFill>
+              </a:rPr>
+              <a:t> les </a:t>
+            </a:r>
+            <a:r>
+              <a:rPr lang="en-US" sz="2000" dirty="0" err="1">
+                <a:solidFill>
+                  <a:schemeClr val="tx1"/>
+                </a:solidFill>
+              </a:rPr>
+              <a:t>risque</a:t>
+            </a:r>
+            <a:r>
+              <a:rPr lang="en-US" sz="2000" dirty="0">
+                <a:solidFill>
+                  <a:schemeClr val="tx1"/>
+                </a:solidFill>
+              </a:rPr>
+              <a:t> </a:t>
+            </a:r>
+            <a:r>
+              <a:rPr lang="en-US" sz="2000" dirty="0" err="1">
+                <a:solidFill>
+                  <a:schemeClr val="tx1"/>
+                </a:solidFill>
+              </a:rPr>
+              <a:t>géographiquement</a:t>
+            </a:r>
+            <a:r>
+              <a:rPr lang="en-US" sz="2000" dirty="0">
+                <a:solidFill>
+                  <a:schemeClr val="tx1"/>
+                </a:solidFill>
+              </a:rPr>
+              <a:t> </a:t>
+            </a:r>
+            <a:r>
+              <a:rPr lang="en-US" sz="2000" dirty="0" err="1">
+                <a:solidFill>
+                  <a:schemeClr val="tx1"/>
+                </a:solidFill>
+              </a:rPr>
+              <a:t>peut</a:t>
+            </a:r>
+            <a:r>
+              <a:rPr lang="en-US" sz="2000" dirty="0">
+                <a:solidFill>
+                  <a:schemeClr val="tx1"/>
+                </a:solidFill>
+              </a:rPr>
+              <a:t> </a:t>
+            </a:r>
+            <a:r>
+              <a:rPr lang="en-US" sz="2000" dirty="0" err="1">
+                <a:solidFill>
+                  <a:schemeClr val="tx1"/>
+                </a:solidFill>
+              </a:rPr>
+              <a:t>réduire</a:t>
+            </a:r>
+            <a:r>
+              <a:rPr lang="en-US" sz="2000" dirty="0">
+                <a:solidFill>
+                  <a:schemeClr val="tx1"/>
+                </a:solidFill>
+              </a:rPr>
+              <a:t> la variance du </a:t>
+            </a:r>
+            <a:r>
+              <a:rPr lang="en-US" sz="2000" dirty="0" err="1">
+                <a:solidFill>
+                  <a:schemeClr val="tx1"/>
+                </a:solidFill>
+              </a:rPr>
+              <a:t>portefeuille</a:t>
+            </a:r>
+            <a:r>
+              <a:rPr lang="en-US" sz="2000" dirty="0">
+                <a:solidFill>
+                  <a:schemeClr val="tx1"/>
+                </a:solidFill>
+              </a:rPr>
+              <a:t> -&gt; diversification </a:t>
+            </a:r>
+            <a:r>
+              <a:rPr lang="en-US" sz="2000" dirty="0" err="1">
+                <a:solidFill>
+                  <a:schemeClr val="tx1"/>
+                </a:solidFill>
+              </a:rPr>
+              <a:t>spatiale</a:t>
+            </a:r>
+            <a:r>
+              <a:rPr lang="en-US" sz="2000" dirty="0">
+                <a:solidFill>
+                  <a:schemeClr val="tx1"/>
+                </a:solidFill>
+              </a:rPr>
+              <a:t> </a:t>
+            </a:r>
+          </a:p>
+        </p:txBody>
+      </p:sp>
+      <p:sp>
+        <p:nvSpPr>
+          <p:cNvPr id="10" name="TextBox 5">
+            <a:extLst>
+              <a:ext uri="{FF2B5EF4-FFF2-40B4-BE49-F238E27FC236}">
+                <a16:creationId xmlns:a16="http://schemas.microsoft.com/office/drawing/2014/main" id="{B469D427-61C4-942C-7FB7-C47B2B1EBD66}"/>
+              </a:ext>
+            </a:extLst>
+          </p:cNvPr>
+          <p:cNvSpPr txBox="1"/>
+          <p:nvPr/>
+        </p:nvSpPr>
+        <p:spPr>
+          <a:xfrm>
+            <a:off x="3169920" y="1871509"/>
+            <a:ext cx="2926080" cy="307777"/>
+          </a:xfrm>
+          <a:prstGeom prst="rect">
+            <a:avLst/>
+          </a:prstGeom>
+          <a:noFill/>
+        </p:spPr>
+        <p:txBody>
+          <a:bodyPr wrap="square" anchor="ctr">
+            <a:spAutoFit/>
+          </a:bodyPr>
+          <a:lstStyle/>
+          <a:p>
+            <a:pPr algn="ctr">
+              <a:defRPr sz="2400" b="1">
+                <a:solidFill>
+                  <a:srgbClr val="2563EB"/>
+                </a:solidFill>
+              </a:defRPr>
+            </a:pPr>
+            <a:r>
+              <a:rPr lang="fr-FR" sz="1400" dirty="0">
+                <a:solidFill>
+                  <a:schemeClr val="tx2">
+                    <a:lumMod val="75000"/>
+                  </a:schemeClr>
+                </a:solidFill>
+              </a:rPr>
+              <a:t>Quand la distance h augmente </a:t>
+            </a:r>
+            <a:endParaRPr lang="el-GR" sz="1400" dirty="0">
+              <a:solidFill>
+                <a:schemeClr val="tx2">
+                  <a:lumMod val="75000"/>
+                </a:schemeClr>
+              </a:solidFill>
+            </a:endParaRPr>
+          </a:p>
+        </p:txBody>
+      </p:sp>
+      <p:sp>
+        <p:nvSpPr>
+          <p:cNvPr id="5" name="TextBox 5">
+            <a:extLst>
+              <a:ext uri="{FF2B5EF4-FFF2-40B4-BE49-F238E27FC236}">
+                <a16:creationId xmlns:a16="http://schemas.microsoft.com/office/drawing/2014/main" id="{880C5325-A2D7-2CEE-1D7D-B321A76A6DE7}"/>
+              </a:ext>
+            </a:extLst>
+          </p:cNvPr>
+          <p:cNvSpPr txBox="1"/>
+          <p:nvPr/>
+        </p:nvSpPr>
+        <p:spPr>
+          <a:xfrm>
+            <a:off x="1002889" y="3343523"/>
+            <a:ext cx="3421627" cy="800219"/>
+          </a:xfrm>
+          <a:prstGeom prst="rect">
+            <a:avLst/>
+          </a:prstGeom>
+          <a:noFill/>
+        </p:spPr>
+        <p:txBody>
+          <a:bodyPr wrap="square" anchor="ctr">
+            <a:spAutoFit/>
+          </a:bodyPr>
+          <a:lstStyle/>
+          <a:p>
+            <a:pPr algn="ctr">
+              <a:defRPr sz="2300" b="1">
+                <a:solidFill>
+                  <a:srgbClr val="16A34A"/>
+                </a:solidFill>
+              </a:defRPr>
+            </a:pPr>
+            <a:r>
+              <a:rPr dirty="0">
+                <a:solidFill>
+                  <a:schemeClr val="accent1">
+                    <a:lumMod val="50000"/>
+                  </a:schemeClr>
+                </a:solidFill>
+              </a:rPr>
+              <a:t>Θ(h) → 2</a:t>
+            </a:r>
+            <a:br>
+              <a:rPr dirty="0">
+                <a:solidFill>
+                  <a:schemeClr val="accent1">
+                    <a:lumMod val="50000"/>
+                  </a:schemeClr>
+                </a:solidFill>
+              </a:rPr>
+            </a:br>
+            <a:r>
+              <a:rPr dirty="0">
+                <a:solidFill>
+                  <a:schemeClr val="accent1">
+                    <a:lumMod val="50000"/>
+                  </a:schemeClr>
+                </a:solidFill>
+              </a:rPr>
+              <a:t>à grande distance</a:t>
+            </a:r>
+          </a:p>
+        </p:txBody>
+      </p:sp>
+      <p:sp>
+        <p:nvSpPr>
+          <p:cNvPr id="11" name="TextBox 5">
+            <a:extLst>
+              <a:ext uri="{FF2B5EF4-FFF2-40B4-BE49-F238E27FC236}">
+                <a16:creationId xmlns:a16="http://schemas.microsoft.com/office/drawing/2014/main" id="{31896830-3941-29E1-558E-4AB2C8C6B0B8}"/>
+              </a:ext>
+            </a:extLst>
+          </p:cNvPr>
+          <p:cNvSpPr txBox="1"/>
+          <p:nvPr/>
+        </p:nvSpPr>
+        <p:spPr>
+          <a:xfrm>
+            <a:off x="6990734" y="3343522"/>
+            <a:ext cx="3759223" cy="800219"/>
+          </a:xfrm>
+          <a:prstGeom prst="rect">
+            <a:avLst/>
+          </a:prstGeom>
+          <a:noFill/>
+        </p:spPr>
+        <p:txBody>
+          <a:bodyPr wrap="square" anchor="ctr">
+            <a:spAutoFit/>
+          </a:bodyPr>
+          <a:lstStyle/>
+          <a:p>
+            <a:pPr algn="ctr">
+              <a:defRPr sz="2300" b="1">
+                <a:solidFill>
+                  <a:srgbClr val="16A34A"/>
+                </a:solidFill>
+              </a:defRPr>
+            </a:pPr>
+            <a:r>
+              <a:rPr lang="fr-FR" dirty="0">
+                <a:solidFill>
+                  <a:schemeClr val="accent1">
+                    <a:lumMod val="50000"/>
+                  </a:schemeClr>
+                </a:solidFill>
+              </a:rPr>
+              <a:t>R2(</a:t>
+            </a:r>
+            <a:r>
+              <a:rPr lang="el-GR" dirty="0">
+                <a:solidFill>
+                  <a:schemeClr val="accent1">
+                    <a:lumMod val="50000"/>
+                  </a:schemeClr>
+                </a:solidFill>
+              </a:rPr>
+              <a:t>λ</a:t>
+            </a:r>
+            <a:r>
+              <a:rPr lang="fr-FR" dirty="0">
+                <a:solidFill>
+                  <a:schemeClr val="accent1">
+                    <a:lumMod val="50000"/>
+                  </a:schemeClr>
+                </a:solidFill>
+              </a:rPr>
+              <a:t>A)</a:t>
+            </a:r>
+            <a:r>
+              <a:rPr dirty="0">
+                <a:solidFill>
+                  <a:schemeClr val="accent1">
+                    <a:lumMod val="50000"/>
+                  </a:schemeClr>
+                </a:solidFill>
+              </a:rPr>
+              <a:t> →</a:t>
+            </a:r>
+            <a:r>
+              <a:rPr lang="fr-FR" dirty="0">
+                <a:solidFill>
+                  <a:schemeClr val="accent1">
+                    <a:lumMod val="50000"/>
+                  </a:schemeClr>
+                </a:solidFill>
+              </a:rPr>
+              <a:t>0</a:t>
+            </a:r>
+          </a:p>
+          <a:p>
+            <a:pPr algn="ctr">
+              <a:defRPr sz="2300" b="1">
+                <a:solidFill>
+                  <a:srgbClr val="16A34A"/>
+                </a:solidFill>
+              </a:defRPr>
+            </a:pPr>
+            <a:r>
+              <a:rPr lang="fr-FR" dirty="0">
+                <a:solidFill>
+                  <a:schemeClr val="accent1">
+                    <a:lumMod val="50000"/>
+                  </a:schemeClr>
+                </a:solidFill>
+              </a:rPr>
+              <a:t>Quand la région  s’agrandit</a:t>
+            </a:r>
+            <a:endParaRPr dirty="0">
+              <a:solidFill>
+                <a:schemeClr val="accent1">
+                  <a:lumMod val="50000"/>
+                </a:schemeClr>
+              </a:solidFill>
+            </a:endParaRPr>
+          </a:p>
+        </p:txBody>
+      </p:sp>
+      <p:sp>
+        <p:nvSpPr>
+          <p:cNvPr id="19" name="Flèche : droite 18">
+            <a:extLst>
+              <a:ext uri="{FF2B5EF4-FFF2-40B4-BE49-F238E27FC236}">
+                <a16:creationId xmlns:a16="http://schemas.microsoft.com/office/drawing/2014/main" id="{38671B34-76E5-EBFA-AD20-80365DA1CD67}"/>
+              </a:ext>
+            </a:extLst>
+          </p:cNvPr>
+          <p:cNvSpPr/>
+          <p:nvPr/>
+        </p:nvSpPr>
+        <p:spPr>
+          <a:xfrm>
+            <a:off x="1445342" y="2306115"/>
+            <a:ext cx="7678994" cy="854565"/>
+          </a:xfrm>
+          <a:prstGeom prst="rightArrow">
+            <a:avLst/>
+          </a:prstGeom>
+        </p:spPr>
+        <p:style>
+          <a:lnRef idx="2">
+            <a:schemeClr val="accent1">
+              <a:shade val="15000"/>
+            </a:schemeClr>
+          </a:lnRef>
+          <a:fillRef idx="1">
+            <a:schemeClr val="accent1"/>
+          </a:fillRef>
+          <a:effectRef idx="0">
+            <a:schemeClr val="accent1"/>
+          </a:effectRef>
+          <a:fontRef idx="minor">
+            <a:schemeClr val="lt1"/>
+          </a:fontRef>
+        </p:style>
+        <p:txBody>
+          <a:bodyPr rtlCol="0" anchor="ctr"/>
+          <a:lstStyle/>
+          <a:p>
+            <a:pPr algn="ctr"/>
+            <a:r>
+              <a:rPr lang="el-GR" dirty="0">
+                <a:solidFill>
+                  <a:schemeClr val="bg1"/>
+                </a:solidFill>
+              </a:rPr>
+              <a:t>Θ</a:t>
+            </a:r>
+            <a:r>
+              <a:rPr lang="fr-FR" dirty="0"/>
+              <a:t>(h) augmente vers 2  ⟶  dépendance extrémale diminue</a:t>
+            </a:r>
+          </a:p>
+        </p:txBody>
+      </p:sp>
+    </p:spTree>
+    <p:extLst>
+      <p:ext uri="{BB962C8B-B14F-4D97-AF65-F5344CB8AC3E}">
+        <p14:creationId xmlns:p14="http://schemas.microsoft.com/office/powerpoint/2010/main" val="3730420769"/>
+      </p:ext>
+    </p:extLst>
+  </p:cSld>
+  <p:clrMapOvr>
+    <a:masterClrMapping/>
+  </p:clrMapOvr>
+</p:sld>
+</file>
+
+<file path=ppt/slides/slide6.xml><?xml version="1.0" encoding="utf-8"?>
+<p:sld xmlns:a="http://schemas.openxmlformats.org/drawingml/2006/main" xmlns:r="http://schemas.openxmlformats.org/officeDocument/2006/relationships" xmlns:p="http://schemas.openxmlformats.org/presentationml/2006/main">
+  <p:cSld>
+    <p:spTree>
+      <p:nvGrpSpPr>
+        <p:cNvPr id="1" name="">
+          <a:extLst>
+            <a:ext uri="{FF2B5EF4-FFF2-40B4-BE49-F238E27FC236}">
+              <a16:creationId xmlns:a16="http://schemas.microsoft.com/office/drawing/2014/main" id="{623E7370-5DE3-71AF-9F5F-D851C8D88CBB}"/>
+            </a:ext>
+          </a:extLst>
+        </p:cNvPr>
+        <p:cNvGrpSpPr/>
+        <p:nvPr/>
+      </p:nvGrpSpPr>
+      <p:grpSpPr>
+        <a:xfrm>
+          <a:off x="0" y="0"/>
+          <a:ext cx="0" cy="0"/>
+          <a:chOff x="0" y="0"/>
+          <a:chExt cx="0" cy="0"/>
+        </a:xfrm>
+      </p:grpSpPr>
+      <p:sp>
+        <p:nvSpPr>
+          <p:cNvPr id="3" name="Rectangle 2">
+            <a:extLst>
+              <a:ext uri="{FF2B5EF4-FFF2-40B4-BE49-F238E27FC236}">
+                <a16:creationId xmlns:a16="http://schemas.microsoft.com/office/drawing/2014/main" id="{074506C5-8FE0-D3A3-EC37-60876B8D947F}"/>
+              </a:ext>
+            </a:extLst>
+          </p:cNvPr>
+          <p:cNvSpPr/>
+          <p:nvPr/>
+        </p:nvSpPr>
+        <p:spPr>
+          <a:xfrm>
+            <a:off x="0" y="0"/>
+            <a:ext cx="12192000" cy="708091"/>
+          </a:xfrm>
+          <a:prstGeom prst="rect">
+            <a:avLst/>
+          </a:prstGeom>
+        </p:spPr>
+        <p:style>
+          <a:lnRef idx="2">
+            <a:schemeClr val="accent1">
+              <a:shade val="15000"/>
+            </a:schemeClr>
+          </a:lnRef>
+          <a:fillRef idx="1">
+            <a:schemeClr val="accent1"/>
+          </a:fillRef>
+          <a:effectRef idx="0">
+            <a:schemeClr val="accent1"/>
+          </a:effectRef>
+          <a:fontRef idx="minor">
+            <a:schemeClr val="lt1"/>
+          </a:fontRef>
+        </p:style>
+        <p:txBody>
+          <a:bodyPr rtlCol="0" anchor="ctr"/>
+          <a:lstStyle/>
+          <a:p>
+            <a:r>
+              <a:rPr lang="fr-FR" sz="2800" dirty="0"/>
+              <a:t>Coefficient Extrémal: mesurer la </a:t>
+            </a:r>
+            <a:r>
+              <a:rPr lang="fr-FR" sz="2800" dirty="0" err="1"/>
+              <a:t>dépensdanace</a:t>
+            </a:r>
+            <a:r>
+              <a:rPr lang="fr-FR" sz="2800" dirty="0"/>
+              <a:t> des </a:t>
+            </a:r>
+            <a:r>
+              <a:rPr lang="fr-FR" sz="2800" dirty="0" err="1"/>
+              <a:t>extremes</a:t>
+            </a:r>
+            <a:endParaRPr lang="fr-FR" sz="2800" dirty="0"/>
+          </a:p>
+        </p:txBody>
+      </p:sp>
+      <p:sp>
+        <p:nvSpPr>
+          <p:cNvPr id="7" name="Rectangle 6">
+            <a:extLst>
+              <a:ext uri="{FF2B5EF4-FFF2-40B4-BE49-F238E27FC236}">
+                <a16:creationId xmlns:a16="http://schemas.microsoft.com/office/drawing/2014/main" id="{CC256E6E-56F8-F466-7578-368F126BFD69}"/>
+              </a:ext>
+            </a:extLst>
+          </p:cNvPr>
+          <p:cNvSpPr/>
+          <p:nvPr/>
+        </p:nvSpPr>
+        <p:spPr>
+          <a:xfrm>
+            <a:off x="620482" y="1572281"/>
+            <a:ext cx="10308771" cy="2939143"/>
+          </a:xfrm>
+          <a:prstGeom prst="rect">
+            <a:avLst/>
+          </a:prstGeom>
+          <a:solidFill>
+            <a:schemeClr val="bg1"/>
+          </a:solidFill>
+        </p:spPr>
+        <p:style>
+          <a:lnRef idx="2">
+            <a:schemeClr val="accent1">
+              <a:shade val="15000"/>
+            </a:schemeClr>
+          </a:lnRef>
+          <a:fillRef idx="1">
+            <a:schemeClr val="accent1"/>
+          </a:fillRef>
+          <a:effectRef idx="0">
+            <a:schemeClr val="accent1"/>
+          </a:effectRef>
+          <a:fontRef idx="minor">
+            <a:schemeClr val="lt1"/>
+          </a:fontRef>
+        </p:style>
+        <p:txBody>
+          <a:bodyPr rtlCol="0" anchor="ctr"/>
+          <a:lstStyle/>
+          <a:p>
+            <a:pPr marL="228600" indent="-228600">
+              <a:spcAft>
+                <a:spcPts val="1600"/>
+              </a:spcAft>
+              <a:buSzPct val="100000"/>
+              <a:buChar char="•"/>
+            </a:pPr>
+            <a:endParaRPr lang="en-US" sz="2000" b="1" dirty="0">
+              <a:solidFill>
+                <a:srgbClr val="1B2430"/>
+              </a:solidFill>
+              <a:latin typeface="Calibri" pitchFamily="34" charset="0"/>
+              <a:ea typeface="Calibri" pitchFamily="34" charset="-122"/>
+              <a:cs typeface="Calibri" pitchFamily="34" charset="-120"/>
+            </a:endParaRPr>
+          </a:p>
+          <a:p>
+            <a:pPr>
+              <a:spcAft>
+                <a:spcPts val="1600"/>
+              </a:spcAft>
+              <a:buSzPct val="100000"/>
+            </a:pPr>
+            <a:endParaRPr lang="en-US" sz="2000" dirty="0">
+              <a:solidFill>
+                <a:srgbClr val="1B2430"/>
+              </a:solidFill>
+              <a:latin typeface="Calibri" pitchFamily="34" charset="0"/>
+              <a:ea typeface="Calibri" pitchFamily="34" charset="-122"/>
+              <a:cs typeface="Calibri" pitchFamily="34" charset="-120"/>
+            </a:endParaRPr>
+          </a:p>
+          <a:p>
+            <a:pPr marL="228600" indent="-228600">
+              <a:spcAft>
+                <a:spcPts val="1600"/>
+              </a:spcAft>
+              <a:buSzPct val="100000"/>
+              <a:buChar char="•"/>
+            </a:pPr>
+            <a:endParaRPr lang="en-US" sz="2000" dirty="0"/>
+          </a:p>
+          <a:p>
+            <a:pPr marL="228600" indent="-228600">
+              <a:spcAft>
+                <a:spcPts val="1600"/>
+              </a:spcAft>
+              <a:buSzPct val="100000"/>
+              <a:buChar char="•"/>
+            </a:pPr>
+            <a:endParaRPr lang="en-US" sz="2000" dirty="0"/>
+          </a:p>
+        </p:txBody>
+      </p:sp>
+      <p:sp>
+        <p:nvSpPr>
+          <p:cNvPr id="8" name="Rectangle : coins arrondis 7">
+            <a:extLst>
+              <a:ext uri="{FF2B5EF4-FFF2-40B4-BE49-F238E27FC236}">
+                <a16:creationId xmlns:a16="http://schemas.microsoft.com/office/drawing/2014/main" id="{ABD5614B-84E8-00EE-A2A1-362C047A67E2}"/>
+              </a:ext>
+            </a:extLst>
+          </p:cNvPr>
+          <p:cNvSpPr/>
+          <p:nvPr/>
+        </p:nvSpPr>
+        <p:spPr>
+          <a:xfrm>
+            <a:off x="620483" y="1181358"/>
+            <a:ext cx="10308771" cy="380480"/>
+          </a:xfrm>
+          <a:prstGeom prst="roundRect">
+            <a:avLst/>
+          </a:prstGeom>
+        </p:spPr>
+        <p:style>
+          <a:lnRef idx="2">
+            <a:schemeClr val="accent1">
+              <a:shade val="15000"/>
+            </a:schemeClr>
+          </a:lnRef>
+          <a:fillRef idx="1">
+            <a:schemeClr val="accent1"/>
+          </a:fillRef>
+          <a:effectRef idx="0">
+            <a:schemeClr val="accent1"/>
+          </a:effectRef>
+          <a:fontRef idx="minor">
+            <a:schemeClr val="lt1"/>
+          </a:fontRef>
+        </p:style>
+        <p:txBody>
+          <a:bodyPr rtlCol="0" anchor="ctr"/>
+          <a:lstStyle/>
+          <a:p>
+            <a:r>
+              <a:rPr lang="fr-FR" sz="2400" dirty="0">
+                <a:solidFill>
+                  <a:schemeClr val="bg1"/>
+                </a:solidFill>
+              </a:rPr>
+              <a:t>Lien avec le </a:t>
+            </a:r>
+            <a:r>
+              <a:rPr lang="fr-FR" sz="2400" dirty="0" err="1">
+                <a:solidFill>
+                  <a:schemeClr val="bg1"/>
+                </a:solidFill>
+              </a:rPr>
+              <a:t>mixing</a:t>
+            </a:r>
+            <a:endParaRPr lang="fr-FR" sz="2400" dirty="0">
+              <a:solidFill>
+                <a:schemeClr val="bg1"/>
+              </a:solidFill>
+            </a:endParaRPr>
+          </a:p>
+        </p:txBody>
+      </p:sp>
+      <p:sp>
+        <p:nvSpPr>
+          <p:cNvPr id="15" name="Rectangle : coins arrondis 14">
+            <a:extLst>
+              <a:ext uri="{FF2B5EF4-FFF2-40B4-BE49-F238E27FC236}">
+                <a16:creationId xmlns:a16="http://schemas.microsoft.com/office/drawing/2014/main" id="{8278DCFF-8D10-33E7-0B64-9CD59C92CDE2}"/>
+              </a:ext>
+            </a:extLst>
+          </p:cNvPr>
+          <p:cNvSpPr/>
+          <p:nvPr/>
+        </p:nvSpPr>
+        <p:spPr>
+          <a:xfrm>
+            <a:off x="620481" y="4670190"/>
+            <a:ext cx="10308771" cy="380480"/>
+          </a:xfrm>
+          <a:prstGeom prst="roundRect">
+            <a:avLst/>
+          </a:prstGeom>
+        </p:spPr>
+        <p:style>
+          <a:lnRef idx="2">
+            <a:schemeClr val="accent1">
+              <a:shade val="15000"/>
+            </a:schemeClr>
+          </a:lnRef>
+          <a:fillRef idx="1">
+            <a:schemeClr val="accent1"/>
+          </a:fillRef>
+          <a:effectRef idx="0">
+            <a:schemeClr val="accent1"/>
+          </a:effectRef>
+          <a:fontRef idx="minor">
+            <a:schemeClr val="lt1"/>
+          </a:fontRef>
+        </p:style>
+        <p:txBody>
+          <a:bodyPr rtlCol="0" anchor="ctr"/>
+          <a:lstStyle/>
+          <a:p>
+            <a:r>
+              <a:rPr lang="fr-FR" sz="2400" dirty="0"/>
+              <a:t>En somme </a:t>
+            </a:r>
+          </a:p>
+        </p:txBody>
+      </p:sp>
+      <p:sp>
+        <p:nvSpPr>
+          <p:cNvPr id="17" name="Rectangle 16">
+            <a:extLst>
+              <a:ext uri="{FF2B5EF4-FFF2-40B4-BE49-F238E27FC236}">
+                <a16:creationId xmlns:a16="http://schemas.microsoft.com/office/drawing/2014/main" id="{7A994698-6494-BB87-318A-0F8E3D11F5B1}"/>
+              </a:ext>
+            </a:extLst>
+          </p:cNvPr>
+          <p:cNvSpPr/>
+          <p:nvPr/>
+        </p:nvSpPr>
+        <p:spPr>
+          <a:xfrm>
+            <a:off x="620481" y="5163051"/>
+            <a:ext cx="10308771" cy="1067319"/>
+          </a:xfrm>
+          <a:prstGeom prst="rect">
+            <a:avLst/>
+          </a:prstGeom>
+          <a:solidFill>
+            <a:schemeClr val="bg1"/>
+          </a:solidFill>
+        </p:spPr>
+        <p:style>
+          <a:lnRef idx="2">
+            <a:schemeClr val="accent1">
+              <a:shade val="15000"/>
+            </a:schemeClr>
+          </a:lnRef>
+          <a:fillRef idx="1">
+            <a:schemeClr val="accent1"/>
+          </a:fillRef>
+          <a:effectRef idx="0">
+            <a:schemeClr val="accent1"/>
+          </a:effectRef>
+          <a:fontRef idx="minor">
+            <a:schemeClr val="lt1"/>
+          </a:fontRef>
+        </p:style>
+        <p:txBody>
+          <a:bodyPr rtlCol="0" anchor="ctr"/>
+          <a:lstStyle/>
+          <a:p>
+            <a:pPr>
+              <a:lnSpc>
+                <a:spcPct val="125000"/>
+              </a:lnSpc>
+            </a:pPr>
+            <a:endParaRPr lang="en-US" sz="2000" dirty="0">
+              <a:solidFill>
+                <a:schemeClr val="tx1"/>
+              </a:solidFill>
+            </a:endParaRPr>
+          </a:p>
+        </p:txBody>
+      </p:sp>
+      <p:sp>
+        <p:nvSpPr>
+          <p:cNvPr id="4" name="TextBox 3">
+            <a:extLst>
+              <a:ext uri="{FF2B5EF4-FFF2-40B4-BE49-F238E27FC236}">
+                <a16:creationId xmlns:a16="http://schemas.microsoft.com/office/drawing/2014/main" id="{4FFD7AC9-1E1D-E672-B223-B8FA4574475E}"/>
+              </a:ext>
+            </a:extLst>
+          </p:cNvPr>
+          <p:cNvSpPr txBox="1"/>
+          <p:nvPr/>
+        </p:nvSpPr>
+        <p:spPr>
+          <a:xfrm>
+            <a:off x="2231923" y="1975218"/>
+            <a:ext cx="5525729" cy="523220"/>
+          </a:xfrm>
+          <a:prstGeom prst="rect">
+            <a:avLst/>
+          </a:prstGeom>
+          <a:noFill/>
+        </p:spPr>
+        <p:txBody>
+          <a:bodyPr wrap="square" anchor="ctr">
+            <a:spAutoFit/>
+          </a:bodyPr>
+          <a:lstStyle/>
+          <a:p>
+            <a:pPr algn="ctr">
+              <a:defRPr sz="2800" b="1">
+                <a:solidFill>
+                  <a:srgbClr val="162A46"/>
+                </a:solidFill>
+              </a:defRPr>
+            </a:pPr>
+            <a:r>
+              <a:rPr dirty="0">
+                <a:solidFill>
+                  <a:schemeClr val="accent1">
+                    <a:lumMod val="50000"/>
+                  </a:schemeClr>
+                </a:solidFill>
+              </a:rPr>
+              <a:t>r(h) = 2 − Θ(h)</a:t>
+            </a:r>
+          </a:p>
+        </p:txBody>
+      </p:sp>
+      <p:sp>
+        <p:nvSpPr>
+          <p:cNvPr id="9" name="TextBox 4">
+            <a:extLst>
+              <a:ext uri="{FF2B5EF4-FFF2-40B4-BE49-F238E27FC236}">
+                <a16:creationId xmlns:a16="http://schemas.microsoft.com/office/drawing/2014/main" id="{DCA9BA43-8C8D-C51B-FD8B-EE9B8B04E139}"/>
+              </a:ext>
+            </a:extLst>
+          </p:cNvPr>
+          <p:cNvSpPr txBox="1"/>
+          <p:nvPr/>
+        </p:nvSpPr>
+        <p:spPr>
+          <a:xfrm>
+            <a:off x="731519" y="2899201"/>
+            <a:ext cx="8441977" cy="830997"/>
+          </a:xfrm>
+          <a:prstGeom prst="rect">
+            <a:avLst/>
+          </a:prstGeom>
+          <a:noFill/>
+        </p:spPr>
+        <p:txBody>
+          <a:bodyPr wrap="square" anchor="ctr">
+            <a:spAutoFit/>
+          </a:bodyPr>
+          <a:lstStyle/>
+          <a:p>
+            <a:pPr algn="ctr">
+              <a:defRPr sz="1700" b="0">
+                <a:solidFill>
+                  <a:srgbClr val="191919"/>
+                </a:solidFill>
+              </a:defRPr>
+            </a:pPr>
+            <a:r>
+              <a:rPr sz="2400" dirty="0"/>
+              <a:t>Θ(h) → 2  ⇔  r(h) → 0</a:t>
+            </a:r>
+            <a:br>
+              <a:rPr sz="2400" dirty="0"/>
+            </a:br>
+            <a:r>
+              <a:rPr sz="2400" dirty="0"/>
+              <a:t>Dans le cadre de </a:t>
+            </a:r>
+            <a:r>
+              <a:rPr sz="2400" dirty="0" err="1"/>
+              <a:t>l’article</a:t>
+            </a:r>
+            <a:r>
+              <a:rPr sz="2400" dirty="0"/>
+              <a:t>, </a:t>
+            </a:r>
+            <a:r>
+              <a:rPr sz="2400" dirty="0" err="1"/>
+              <a:t>cela</a:t>
+            </a:r>
+            <a:r>
+              <a:rPr sz="2400" dirty="0"/>
+              <a:t> </a:t>
+            </a:r>
+            <a:r>
+              <a:rPr sz="2400" dirty="0" err="1"/>
+              <a:t>caractérise</a:t>
+            </a:r>
+            <a:r>
+              <a:rPr sz="2400" dirty="0"/>
+              <a:t> le mixing.</a:t>
+            </a:r>
+          </a:p>
+        </p:txBody>
+      </p:sp>
+      <p:sp>
+        <p:nvSpPr>
+          <p:cNvPr id="13" name="TextBox 12">
+            <a:extLst>
+              <a:ext uri="{FF2B5EF4-FFF2-40B4-BE49-F238E27FC236}">
+                <a16:creationId xmlns:a16="http://schemas.microsoft.com/office/drawing/2014/main" id="{E81C70A6-4555-A880-F161-8560BE0CF83F}"/>
+              </a:ext>
+            </a:extLst>
+          </p:cNvPr>
+          <p:cNvSpPr txBox="1"/>
+          <p:nvPr/>
+        </p:nvSpPr>
+        <p:spPr>
+          <a:xfrm>
+            <a:off x="1032387" y="5373546"/>
+            <a:ext cx="9896868" cy="646331"/>
+          </a:xfrm>
+          <a:prstGeom prst="rect">
+            <a:avLst/>
+          </a:prstGeom>
+          <a:noFill/>
+        </p:spPr>
+        <p:txBody>
+          <a:bodyPr wrap="square" anchor="ctr">
+            <a:spAutoFit/>
+          </a:bodyPr>
+          <a:lstStyle/>
+          <a:p>
+            <a:pPr algn="ctr">
+              <a:defRPr sz="1800" b="1">
+                <a:solidFill>
+                  <a:srgbClr val="162A46"/>
+                </a:solidFill>
+              </a:defRPr>
+            </a:pPr>
+            <a:r>
+              <a:rPr dirty="0"/>
+              <a:t> Θ </a:t>
+            </a:r>
+            <a:r>
+              <a:rPr dirty="0" err="1"/>
+              <a:t>relie</a:t>
+            </a:r>
+            <a:r>
+              <a:rPr dirty="0"/>
+              <a:t> </a:t>
+            </a:r>
+            <a:r>
+              <a:rPr dirty="0" err="1"/>
+              <a:t>dépendance</a:t>
+            </a:r>
+            <a:r>
+              <a:rPr dirty="0"/>
+              <a:t> des </a:t>
+            </a:r>
+            <a:r>
+              <a:rPr dirty="0" err="1"/>
+              <a:t>extrêmes</a:t>
+            </a:r>
+            <a:r>
+              <a:rPr dirty="0"/>
+              <a:t>, </a:t>
+            </a:r>
+            <a:r>
+              <a:rPr dirty="0" err="1"/>
+              <a:t>propriétés</a:t>
+            </a:r>
+            <a:r>
+              <a:rPr dirty="0"/>
+              <a:t> du processus max-stable et diversification </a:t>
+            </a:r>
+            <a:r>
+              <a:rPr dirty="0" err="1"/>
+              <a:t>géographique</a:t>
+            </a:r>
+            <a:r>
+              <a:rPr dirty="0"/>
+              <a:t> du </a:t>
+            </a:r>
+            <a:r>
+              <a:rPr dirty="0" err="1"/>
+              <a:t>risque</a:t>
+            </a:r>
+            <a:r>
+              <a:rPr dirty="0"/>
+              <a:t>.</a:t>
+            </a:r>
+          </a:p>
+        </p:txBody>
+      </p:sp>
+    </p:spTree>
+    <p:extLst>
+      <p:ext uri="{BB962C8B-B14F-4D97-AF65-F5344CB8AC3E}">
+        <p14:creationId xmlns:p14="http://schemas.microsoft.com/office/powerpoint/2010/main" val="2627067818"/>
+      </p:ext>
+    </p:extLst>
+  </p:cSld>
+  <p:clrMapOvr>
+    <a:masterClrMapping/>
+  </p:clrMapOvr>
+</p:sld>
+</file>
+
+<file path=ppt/slides/slide7.xml><?xml version="1.0" encoding="utf-8"?>
+<p:sld xmlns:a="http://schemas.openxmlformats.org/drawingml/2006/main" xmlns:r="http://schemas.openxmlformats.org/officeDocument/2006/relationships" xmlns:p="http://schemas.openxmlformats.org/presentationml/2006/main">
+  <p:cSld>
+    <p:spTree>
+      <p:nvGrpSpPr>
+        <p:cNvPr id="1" name=""/>
+        <p:cNvGrpSpPr/>
+        <p:nvPr/>
+      </p:nvGrpSpPr>
+      <p:grpSpPr>
+        <a:xfrm>
+          <a:off x="0" y="0"/>
+          <a:ext cx="0" cy="0"/>
+          <a:chOff x="0" y="0"/>
+          <a:chExt cx="0" cy="0"/>
+        </a:xfrm>
+      </p:grpSpPr>
+      <p:sp>
+        <p:nvSpPr>
+          <p:cNvPr id="2" name="Titre 1">
+            <a:extLst>
+              <a:ext uri="{FF2B5EF4-FFF2-40B4-BE49-F238E27FC236}">
+                <a16:creationId xmlns:a16="http://schemas.microsoft.com/office/drawing/2014/main" id="{3D9A3DCA-4EB3-A4E1-5AC2-FB271AF6B60B}"/>
+              </a:ext>
+            </a:extLst>
+          </p:cNvPr>
+          <p:cNvSpPr>
+            <a:spLocks noGrp="1"/>
+          </p:cNvSpPr>
+          <p:nvPr>
+            <p:ph type="title"/>
+          </p:nvPr>
+        </p:nvSpPr>
+        <p:spPr/>
+        <p:txBody>
+          <a:bodyPr/>
+          <a:lstStyle/>
+          <a:p>
+            <a:endParaRPr lang="fr-FR"/>
+          </a:p>
+        </p:txBody>
+      </p:sp>
+      <p:sp>
+        <p:nvSpPr>
+          <p:cNvPr id="3" name="Espace réservé du contenu 2">
+            <a:extLst>
+              <a:ext uri="{FF2B5EF4-FFF2-40B4-BE49-F238E27FC236}">
+                <a16:creationId xmlns:a16="http://schemas.microsoft.com/office/drawing/2014/main" id="{F32A5538-1826-9176-0B8D-CEA1D3F76716}"/>
+              </a:ext>
+            </a:extLst>
+          </p:cNvPr>
+          <p:cNvSpPr>
+            <a:spLocks noGrp="1"/>
+          </p:cNvSpPr>
+          <p:nvPr>
+            <p:ph idx="1"/>
+          </p:nvPr>
+        </p:nvSpPr>
+        <p:spPr/>
+        <p:txBody>
+          <a:bodyPr/>
+          <a:lstStyle/>
+          <a:p>
+            <a:endParaRPr lang="fr-FR"/>
+          </a:p>
+        </p:txBody>
+      </p:sp>
+    </p:spTree>
+    <p:extLst>
+      <p:ext uri="{BB962C8B-B14F-4D97-AF65-F5344CB8AC3E}">
+        <p14:creationId xmlns:p14="http://schemas.microsoft.com/office/powerpoint/2010/main" val="3531065004"/>
       </p:ext>
     </p:extLst>
   </p:cSld>

</xml_diff>